<commit_message>
Reveal the job history story line by line on click
The Reading the example slide now shows only the job history and a
The Story button; the story fades in one line per click. Build with
build-deck.js, then add-story-animation.py.

Co-Authored-By: Claude Opus 5.5 <noreply@anthropic.com>
Claude-Session: https://claude.ai/code/session_01FEzv8wwqWDgTsXP8Yz6XYn
</commit_message>
<xml_diff>
--- a/platform-mechanics/platform-operating-mechanics.pptx
+++ b/platform-mechanics/platform-operating-mechanics.pptx
@@ -2550,7 +2550,7 @@
           <a:p>
             <a:r>
               <a:rPr lang="en-US" dirty="0"/>
-              <a:t>Bottom to top: Sep 7, 10:35 AM: the system booked the job for Sep 21 at 10 AM (comment: populate_recurring_contract); status submitted. Sep 14, 2:29 PM: the cleaner claimed it. Sep 21, 9:19 AM: the cleaner rescheduled it from Sep 21, 10 AM to Sep 22, 11 AM. Sep 21, 9:50 AM: the cleaner rescheduled again, from Sep 22, 11 AM to Sep 24, 12:30 PM. Sep 24, 4:09 PM: the cleaner invoiced the job (status before: pending_invoice), and the system logged the invoice snapshot. Article example for reference: On Oct 9 at 7 PM, CS booked a cleaning via CRM for Oct 10 at 11 AM. Around 8:42 PM on the same day, CP Victor claimed the appointment. On Oct 11 at 2:03 PM, the CP invoiced the job, and the system logged it to the snapshot.</a:t>
+              <a:t>TRAINER: let trainees read the job history first (bottom to top). Then click The Story (or press the right arrow) to reveal the story one line at a time, staying on this slide. Story: On Sept 7, 2026, the system booked a cleaning for C Anjuli Kintanar scheduled for Sept 21 10AM CT through the recurring cleaning plan. On Sept 14, CP Truffle Wuffle claimed the job as scheduled. On Sept 21 9:19AM CT, CP Truffle Wuffle rescheduled the appointment from Sept 21, 10AM CT to Sept 22, 11AM. On Sept 21 9:50 AM CT, CP Truffle Wuffle rescheduled the appointment again from Sept 22, 11AM to Sept 24, 12:30 PM CT. On Sept 24, 4:09 PM CT, CP Truffle Wuffle invoiced the appointment and the system logged it in snapshot.</a:t>
             </a:r>
             <a:endParaRPr lang="en-US" dirty="0"/>
           </a:p>
@@ -22974,2442 +22974,230 @@
                 <a:ea typeface="SF Pro Text" pitchFamily="34" charset="-122"/>
                 <a:cs typeface="SF Pro Text" pitchFamily="34" charset="-120"/>
               </a:rPr>
-              <a:t>The same job history, read from the bottom up.</a:t>
+              <a:t>Read the job history from the bottom up. Then click The Story.</a:t>
             </a:r>
             <a:endParaRPr lang="en-US" sz="1200" dirty="0"/>
           </a:p>
         </p:txBody>
       </p:sp>
-      <p:graphicFrame>
-        <p:nvGraphicFramePr>
-          <p:cNvPr id="9" name="Table 0"/>
-          <p:cNvGraphicFramePr>
-            <a:graphicFrameLocks noGrp="1"/>
-          </p:cNvGraphicFramePr>
-          <p:nvPr>
-            <p:extLst>
-              <p:ext uri="{D42A27DB-BD31-4B8C-83A1-F6EECF244321}">
-                <p14:modId xmlns:p14="http://schemas.microsoft.com/office/powerpoint/2010/main" val="1579011935"/>
-              </p:ext>
-            </p:extLst>
-          </p:nvPr>
-        </p:nvGraphicFramePr>
-        <p:xfrm>
-          <a:off x="411480" y="1280160"/>
-          <a:ext cx="8321040" cy="914400"/>
-        </p:xfrm>
-        <a:graphic>
-          <a:graphicData uri="http://schemas.openxmlformats.org/drawingml/2006/table">
-            <a:tbl>
-              <a:tblPr/>
-              <a:tblGrid>
-                <a:gridCol w="365760"/>
-                <a:gridCol w="1554480"/>
-                <a:gridCol w="914400"/>
-                <a:gridCol w="2011680"/>
-                <a:gridCol w="3474720"/>
-              </a:tblGrid>
-              <a:tr h="329184">
-                <a:tc>
-                  <a:txBody>
-                    <a:bodyPr/>
-                    <a:lstStyle/>
-                    <a:p>
-                      <a:pPr indent="0" marL="0">
-                        <a:buNone/>
-                      </a:pPr>
-                      <a:endParaRPr lang="en-US" sz="950" dirty="0">
-                        <a:latin typeface="SF Pro Display" charset="0"/>
-                        <a:ea typeface="SF Pro Display" charset="0"/>
-                        <a:cs typeface="SF Pro Display" charset="0"/>
-                      </a:endParaRPr>
-                    </a:p>
-                  </a:txBody>
-                  <a:tcPr marL="91440" marR="91440" marT="27432" marB="27432" anchor="ctr">
-                    <a:lnL w="9525" cap="flat" cmpd="sng" algn="ctr">
-                      <a:solidFill>
-                        <a:srgbClr val="DCE1E7"/>
-                      </a:solidFill>
-                      <a:prstDash val="solid"/>
-                      <a:round/>
-                      <a:headEnd type="none" w="med" len="med"/>
-                      <a:tailEnd type="none" w="med" len="med"/>
-                    </a:lnL>
-                    <a:lnR w="9525" cap="flat" cmpd="sng" algn="ctr">
-                      <a:solidFill>
-                        <a:srgbClr val="DCE1E7"/>
-                      </a:solidFill>
-                      <a:prstDash val="solid"/>
-                      <a:round/>
-                      <a:headEnd type="none" w="med" len="med"/>
-                      <a:tailEnd type="none" w="med" len="med"/>
-                    </a:lnR>
-                    <a:lnT w="9525" cap="flat" cmpd="sng" algn="ctr">
-                      <a:solidFill>
-                        <a:srgbClr val="DCE1E7"/>
-                      </a:solidFill>
-                      <a:prstDash val="solid"/>
-                      <a:round/>
-                      <a:headEnd type="none" w="med" len="med"/>
-                      <a:tailEnd type="none" w="med" len="med"/>
-                    </a:lnT>
-                    <a:lnB w="9525" cap="flat" cmpd="sng" algn="ctr">
-                      <a:solidFill>
-                        <a:srgbClr val="DCE1E7"/>
-                      </a:solidFill>
-                      <a:prstDash val="solid"/>
-                      <a:round/>
-                      <a:headEnd type="none" w="med" len="med"/>
-                      <a:tailEnd type="none" w="med" len="med"/>
-                    </a:lnB>
-                    <a:solidFill>
-                      <a:srgbClr val="E3F4F1"/>
-                    </a:solidFill>
-                  </a:tcPr>
-                </a:tc>
-                <a:tc>
-                  <a:txBody>
-                    <a:bodyPr/>
-                    <a:lstStyle/>
-                    <a:p>
-                      <a:pPr indent="0" marL="0">
-                        <a:buNone/>
-                      </a:pPr>
-                      <a:r>
-                        <a:rPr lang="en-US" sz="950" b="1" dirty="0">
-                          <a:solidFill>
-                            <a:srgbClr val="0B7A6F"/>
-                          </a:solidFill>
-                          <a:latin typeface="SF Pro Display" pitchFamily="34" charset="0"/>
-                          <a:ea typeface="SF Pro Display" pitchFamily="34" charset="-122"/>
-                          <a:cs typeface="SF Pro Display" pitchFamily="34" charset="-120"/>
-                        </a:rPr>
-                        <a:t>Action on</a:t>
-                      </a:r>
-                      <a:endParaRPr lang="en-US" sz="950" dirty="0">
-                        <a:latin typeface="SF Pro Display" charset="0"/>
-                        <a:ea typeface="SF Pro Display" charset="0"/>
-                        <a:cs typeface="SF Pro Display" charset="0"/>
-                      </a:endParaRPr>
-                    </a:p>
-                  </a:txBody>
-                  <a:tcPr marL="91440" marR="91440" marT="27432" marB="27432" anchor="ctr">
-                    <a:lnL w="9525" cap="flat" cmpd="sng" algn="ctr">
-                      <a:solidFill>
-                        <a:srgbClr val="DCE1E7"/>
-                      </a:solidFill>
-                      <a:prstDash val="solid"/>
-                      <a:round/>
-                      <a:headEnd type="none" w="med" len="med"/>
-                      <a:tailEnd type="none" w="med" len="med"/>
-                    </a:lnL>
-                    <a:lnR w="9525" cap="flat" cmpd="sng" algn="ctr">
-                      <a:solidFill>
-                        <a:srgbClr val="DCE1E7"/>
-                      </a:solidFill>
-                      <a:prstDash val="solid"/>
-                      <a:round/>
-                      <a:headEnd type="none" w="med" len="med"/>
-                      <a:tailEnd type="none" w="med" len="med"/>
-                    </a:lnR>
-                    <a:lnT w="9525" cap="flat" cmpd="sng" algn="ctr">
-                      <a:solidFill>
-                        <a:srgbClr val="DCE1E7"/>
-                      </a:solidFill>
-                      <a:prstDash val="solid"/>
-                      <a:round/>
-                      <a:headEnd type="none" w="med" len="med"/>
-                      <a:tailEnd type="none" w="med" len="med"/>
-                    </a:lnT>
-                    <a:lnB w="9525" cap="flat" cmpd="sng" algn="ctr">
-                      <a:solidFill>
-                        <a:srgbClr val="DCE1E7"/>
-                      </a:solidFill>
-                      <a:prstDash val="solid"/>
-                      <a:round/>
-                      <a:headEnd type="none" w="med" len="med"/>
-                      <a:tailEnd type="none" w="med" len="med"/>
-                    </a:lnB>
-                    <a:solidFill>
-                      <a:srgbClr val="E3F4F1"/>
-                    </a:solidFill>
-                  </a:tcPr>
-                </a:tc>
-                <a:tc>
-                  <a:txBody>
-                    <a:bodyPr/>
-                    <a:lstStyle/>
-                    <a:p>
-                      <a:pPr indent="0" marL="0">
-                        <a:buNone/>
-                      </a:pPr>
-                      <a:r>
-                        <a:rPr lang="en-US" sz="950" b="1" dirty="0">
-                          <a:solidFill>
-                            <a:srgbClr val="0B7A6F"/>
-                          </a:solidFill>
-                          <a:latin typeface="SF Pro Display" pitchFamily="34" charset="0"/>
-                          <a:ea typeface="SF Pro Display" pitchFamily="34" charset="-122"/>
-                          <a:cs typeface="SF Pro Display" pitchFamily="34" charset="-120"/>
-                        </a:rPr>
-                        <a:t>Actor</a:t>
-                      </a:r>
-                      <a:endParaRPr lang="en-US" sz="950" dirty="0">
-                        <a:latin typeface="SF Pro Display" charset="0"/>
-                        <a:ea typeface="SF Pro Display" charset="0"/>
-                        <a:cs typeface="SF Pro Display" charset="0"/>
-                      </a:endParaRPr>
-                    </a:p>
-                  </a:txBody>
-                  <a:tcPr marL="91440" marR="91440" marT="27432" marB="27432" anchor="ctr">
-                    <a:lnL w="9525" cap="flat" cmpd="sng" algn="ctr">
-                      <a:solidFill>
-                        <a:srgbClr val="DCE1E7"/>
-                      </a:solidFill>
-                      <a:prstDash val="solid"/>
-                      <a:round/>
-                      <a:headEnd type="none" w="med" len="med"/>
-                      <a:tailEnd type="none" w="med" len="med"/>
-                    </a:lnL>
-                    <a:lnR w="9525" cap="flat" cmpd="sng" algn="ctr">
-                      <a:solidFill>
-                        <a:srgbClr val="DCE1E7"/>
-                      </a:solidFill>
-                      <a:prstDash val="solid"/>
-                      <a:round/>
-                      <a:headEnd type="none" w="med" len="med"/>
-                      <a:tailEnd type="none" w="med" len="med"/>
-                    </a:lnR>
-                    <a:lnT w="9525" cap="flat" cmpd="sng" algn="ctr">
-                      <a:solidFill>
-                        <a:srgbClr val="DCE1E7"/>
-                      </a:solidFill>
-                      <a:prstDash val="solid"/>
-                      <a:round/>
-                      <a:headEnd type="none" w="med" len="med"/>
-                      <a:tailEnd type="none" w="med" len="med"/>
-                    </a:lnT>
-                    <a:lnB w="9525" cap="flat" cmpd="sng" algn="ctr">
-                      <a:solidFill>
-                        <a:srgbClr val="DCE1E7"/>
-                      </a:solidFill>
-                      <a:prstDash val="solid"/>
-                      <a:round/>
-                      <a:headEnd type="none" w="med" len="med"/>
-                      <a:tailEnd type="none" w="med" len="med"/>
-                    </a:lnB>
-                    <a:solidFill>
-                      <a:srgbClr val="E3F4F1"/>
-                    </a:solidFill>
-                  </a:tcPr>
-                </a:tc>
-                <a:tc>
-                  <a:txBody>
-                    <a:bodyPr/>
-                    <a:lstStyle/>
-                    <a:p>
-                      <a:pPr indent="0" marL="0">
-                        <a:buNone/>
-                      </a:pPr>
-                      <a:r>
-                        <a:rPr lang="en-US" sz="950" b="1" dirty="0">
-                          <a:solidFill>
-                            <a:srgbClr val="0B7A6F"/>
-                          </a:solidFill>
-                          <a:latin typeface="SF Pro Display" pitchFamily="34" charset="0"/>
-                          <a:ea typeface="SF Pro Display" pitchFamily="34" charset="-122"/>
-                          <a:cs typeface="SF Pro Display" pitchFamily="34" charset="-120"/>
-                        </a:rPr>
-                        <a:t>Action</a:t>
-                      </a:r>
-                      <a:endParaRPr lang="en-US" sz="950" dirty="0">
-                        <a:latin typeface="SF Pro Display" charset="0"/>
-                        <a:ea typeface="SF Pro Display" charset="0"/>
-                        <a:cs typeface="SF Pro Display" charset="0"/>
-                      </a:endParaRPr>
-                    </a:p>
-                  </a:txBody>
-                  <a:tcPr marL="91440" marR="91440" marT="27432" marB="27432" anchor="ctr">
-                    <a:lnL w="9525" cap="flat" cmpd="sng" algn="ctr">
-                      <a:solidFill>
-                        <a:srgbClr val="DCE1E7"/>
-                      </a:solidFill>
-                      <a:prstDash val="solid"/>
-                      <a:round/>
-                      <a:headEnd type="none" w="med" len="med"/>
-                      <a:tailEnd type="none" w="med" len="med"/>
-                    </a:lnL>
-                    <a:lnR w="9525" cap="flat" cmpd="sng" algn="ctr">
-                      <a:solidFill>
-                        <a:srgbClr val="DCE1E7"/>
-                      </a:solidFill>
-                      <a:prstDash val="solid"/>
-                      <a:round/>
-                      <a:headEnd type="none" w="med" len="med"/>
-                      <a:tailEnd type="none" w="med" len="med"/>
-                    </a:lnR>
-                    <a:lnT w="9525" cap="flat" cmpd="sng" algn="ctr">
-                      <a:solidFill>
-                        <a:srgbClr val="DCE1E7"/>
-                      </a:solidFill>
-                      <a:prstDash val="solid"/>
-                      <a:round/>
-                      <a:headEnd type="none" w="med" len="med"/>
-                      <a:tailEnd type="none" w="med" len="med"/>
-                    </a:lnT>
-                    <a:lnB w="9525" cap="flat" cmpd="sng" algn="ctr">
-                      <a:solidFill>
-                        <a:srgbClr val="DCE1E7"/>
-                      </a:solidFill>
-                      <a:prstDash val="solid"/>
-                      <a:round/>
-                      <a:headEnd type="none" w="med" len="med"/>
-                      <a:tailEnd type="none" w="med" len="med"/>
-                    </a:lnB>
-                    <a:solidFill>
-                      <a:srgbClr val="E3F4F1"/>
-                    </a:solidFill>
-                  </a:tcPr>
-                </a:tc>
-                <a:tc>
-                  <a:txBody>
-                    <a:bodyPr/>
-                    <a:lstStyle/>
-                    <a:p>
-                      <a:pPr indent="0" marL="0">
-                        <a:buNone/>
-                      </a:pPr>
-                      <a:r>
-                        <a:rPr lang="en-US" sz="950" b="1" dirty="0">
-                          <a:solidFill>
-                            <a:srgbClr val="0B7A6F"/>
-                          </a:solidFill>
-                          <a:latin typeface="SF Pro Display" pitchFamily="34" charset="0"/>
-                          <a:ea typeface="SF Pro Display" pitchFamily="34" charset="-122"/>
-                          <a:cs typeface="SF Pro Display" pitchFamily="34" charset="-120"/>
-                        </a:rPr>
-                        <a:t>What it tells you</a:t>
-                      </a:r>
-                      <a:endParaRPr lang="en-US" sz="950" dirty="0">
-                        <a:latin typeface="SF Pro Display" charset="0"/>
-                        <a:ea typeface="SF Pro Display" charset="0"/>
-                        <a:cs typeface="SF Pro Display" charset="0"/>
-                      </a:endParaRPr>
-                    </a:p>
-                  </a:txBody>
-                  <a:tcPr marL="91440" marR="91440" marT="27432" marB="27432" anchor="ctr">
-                    <a:lnL w="9525" cap="flat" cmpd="sng" algn="ctr">
-                      <a:solidFill>
-                        <a:srgbClr val="DCE1E7"/>
-                      </a:solidFill>
-                      <a:prstDash val="solid"/>
-                      <a:round/>
-                      <a:headEnd type="none" w="med" len="med"/>
-                      <a:tailEnd type="none" w="med" len="med"/>
-                    </a:lnL>
-                    <a:lnR w="9525" cap="flat" cmpd="sng" algn="ctr">
-                      <a:solidFill>
-                        <a:srgbClr val="DCE1E7"/>
-                      </a:solidFill>
-                      <a:prstDash val="solid"/>
-                      <a:round/>
-                      <a:headEnd type="none" w="med" len="med"/>
-                      <a:tailEnd type="none" w="med" len="med"/>
-                    </a:lnR>
-                    <a:lnT w="9525" cap="flat" cmpd="sng" algn="ctr">
-                      <a:solidFill>
-                        <a:srgbClr val="DCE1E7"/>
-                      </a:solidFill>
-                      <a:prstDash val="solid"/>
-                      <a:round/>
-                      <a:headEnd type="none" w="med" len="med"/>
-                      <a:tailEnd type="none" w="med" len="med"/>
-                    </a:lnT>
-                    <a:lnB w="9525" cap="flat" cmpd="sng" algn="ctr">
-                      <a:solidFill>
-                        <a:srgbClr val="DCE1E7"/>
-                      </a:solidFill>
-                      <a:prstDash val="solid"/>
-                      <a:round/>
-                      <a:headEnd type="none" w="med" len="med"/>
-                      <a:tailEnd type="none" w="med" len="med"/>
-                    </a:lnB>
-                    <a:solidFill>
-                      <a:srgbClr val="E3F4F1"/>
-                    </a:solidFill>
-                  </a:tcPr>
-                </a:tc>
-              </a:tr>
-              <a:tr h="329184">
-                <a:tc>
-                  <a:txBody>
-                    <a:bodyPr/>
-                    <a:lstStyle/>
-                    <a:p>
-                      <a:pPr indent="0" marL="0">
-                        <a:buNone/>
-                      </a:pPr>
-                      <a:r>
-                        <a:rPr lang="en-US" sz="950" b="1" dirty="0">
-                          <a:solidFill>
-                            <a:srgbClr val="1D1D1F"/>
-                          </a:solidFill>
-                          <a:latin typeface="SF Pro Text" pitchFamily="34" charset="0"/>
-                          <a:ea typeface="SF Pro Text" pitchFamily="34" charset="-122"/>
-                          <a:cs typeface="SF Pro Text" pitchFamily="34" charset="-120"/>
-                        </a:rPr>
-                        <a:t>1</a:t>
-                      </a:r>
-                      <a:endParaRPr lang="en-US" sz="950" dirty="0">
-                        <a:latin typeface="SF Pro Text" charset="0"/>
-                        <a:ea typeface="SF Pro Text" charset="0"/>
-                        <a:cs typeface="SF Pro Text" charset="0"/>
-                      </a:endParaRPr>
-                    </a:p>
-                  </a:txBody>
-                  <a:tcPr marL="91440" marR="91440" marT="27432" marB="27432" anchor="ctr">
-                    <a:lnL w="9525" cap="flat" cmpd="sng" algn="ctr">
-                      <a:solidFill>
-                        <a:srgbClr val="DCE1E7"/>
-                      </a:solidFill>
-                      <a:prstDash val="solid"/>
-                      <a:round/>
-                      <a:headEnd type="none" w="med" len="med"/>
-                      <a:tailEnd type="none" w="med" len="med"/>
-                    </a:lnL>
-                    <a:lnR w="9525" cap="flat" cmpd="sng" algn="ctr">
-                      <a:solidFill>
-                        <a:srgbClr val="DCE1E7"/>
-                      </a:solidFill>
-                      <a:prstDash val="solid"/>
-                      <a:round/>
-                      <a:headEnd type="none" w="med" len="med"/>
-                      <a:tailEnd type="none" w="med" len="med"/>
-                    </a:lnR>
-                    <a:lnT w="9525" cap="flat" cmpd="sng" algn="ctr">
-                      <a:solidFill>
-                        <a:srgbClr val="DCE1E7"/>
-                      </a:solidFill>
-                      <a:prstDash val="solid"/>
-                      <a:round/>
-                      <a:headEnd type="none" w="med" len="med"/>
-                      <a:tailEnd type="none" w="med" len="med"/>
-                    </a:lnT>
-                    <a:lnB w="9525" cap="flat" cmpd="sng" algn="ctr">
-                      <a:solidFill>
-                        <a:srgbClr val="DCE1E7"/>
-                      </a:solidFill>
-                      <a:prstDash val="solid"/>
-                      <a:round/>
-                      <a:headEnd type="none" w="med" len="med"/>
-                      <a:tailEnd type="none" w="med" len="med"/>
-                    </a:lnB>
-                    <a:solidFill>
-                      <a:srgbClr val="FFFFFF"/>
-                    </a:solidFill>
-                  </a:tcPr>
-                </a:tc>
-                <a:tc>
-                  <a:txBody>
-                    <a:bodyPr/>
-                    <a:lstStyle/>
-                    <a:p>
-                      <a:pPr indent="0" marL="0">
-                        <a:buNone/>
-                      </a:pPr>
-                      <a:r>
-                        <a:rPr lang="en-US" sz="950" dirty="0">
-                          <a:solidFill>
-                            <a:srgbClr val="6E6E73"/>
-                          </a:solidFill>
-                          <a:latin typeface="SF Pro Text" pitchFamily="34" charset="0"/>
-                          <a:ea typeface="SF Pro Text" pitchFamily="34" charset="-122"/>
-                          <a:cs typeface="SF Pro Text" pitchFamily="34" charset="-120"/>
-                        </a:rPr>
-                        <a:t>Sep 7, 10:35 AM</a:t>
-                      </a:r>
-                      <a:endParaRPr lang="en-US" sz="950" dirty="0">
-                        <a:latin typeface="SF Pro Text" charset="0"/>
-                        <a:ea typeface="SF Pro Text" charset="0"/>
-                        <a:cs typeface="SF Pro Text" charset="0"/>
-                      </a:endParaRPr>
-                    </a:p>
-                  </a:txBody>
-                  <a:tcPr marL="91440" marR="91440" marT="27432" marB="27432" anchor="ctr">
-                    <a:lnL w="9525" cap="flat" cmpd="sng" algn="ctr">
-                      <a:solidFill>
-                        <a:srgbClr val="DCE1E7"/>
-                      </a:solidFill>
-                      <a:prstDash val="solid"/>
-                      <a:round/>
-                      <a:headEnd type="none" w="med" len="med"/>
-                      <a:tailEnd type="none" w="med" len="med"/>
-                    </a:lnL>
-                    <a:lnR w="9525" cap="flat" cmpd="sng" algn="ctr">
-                      <a:solidFill>
-                        <a:srgbClr val="DCE1E7"/>
-                      </a:solidFill>
-                      <a:prstDash val="solid"/>
-                      <a:round/>
-                      <a:headEnd type="none" w="med" len="med"/>
-                      <a:tailEnd type="none" w="med" len="med"/>
-                    </a:lnR>
-                    <a:lnT w="9525" cap="flat" cmpd="sng" algn="ctr">
-                      <a:solidFill>
-                        <a:srgbClr val="DCE1E7"/>
-                      </a:solidFill>
-                      <a:prstDash val="solid"/>
-                      <a:round/>
-                      <a:headEnd type="none" w="med" len="med"/>
-                      <a:tailEnd type="none" w="med" len="med"/>
-                    </a:lnT>
-                    <a:lnB w="9525" cap="flat" cmpd="sng" algn="ctr">
-                      <a:solidFill>
-                        <a:srgbClr val="DCE1E7"/>
-                      </a:solidFill>
-                      <a:prstDash val="solid"/>
-                      <a:round/>
-                      <a:headEnd type="none" w="med" len="med"/>
-                      <a:tailEnd type="none" w="med" len="med"/>
-                    </a:lnB>
-                    <a:solidFill>
-                      <a:srgbClr val="FFFFFF"/>
-                    </a:solidFill>
-                  </a:tcPr>
-                </a:tc>
-                <a:tc>
-                  <a:txBody>
-                    <a:bodyPr/>
-                    <a:lstStyle/>
-                    <a:p>
-                      <a:pPr indent="0" marL="0">
-                        <a:buNone/>
-                      </a:pPr>
-                      <a:r>
-                        <a:rPr lang="en-US" sz="950" dirty="0">
-                          <a:solidFill>
-                            <a:srgbClr val="6E6E73"/>
-                          </a:solidFill>
-                          <a:latin typeface="SF Pro Text" pitchFamily="34" charset="0"/>
-                          <a:ea typeface="SF Pro Text" pitchFamily="34" charset="-122"/>
-                          <a:cs typeface="SF Pro Text" pitchFamily="34" charset="-120"/>
-                        </a:rPr>
-                        <a:t>system</a:t>
-                      </a:r>
-                      <a:endParaRPr lang="en-US" sz="950" dirty="0">
-                        <a:latin typeface="SF Pro Text" charset="0"/>
-                        <a:ea typeface="SF Pro Text" charset="0"/>
-                        <a:cs typeface="SF Pro Text" charset="0"/>
-                      </a:endParaRPr>
-                    </a:p>
-                  </a:txBody>
-                  <a:tcPr marL="91440" marR="91440" marT="27432" marB="27432" anchor="ctr">
-                    <a:lnL w="9525" cap="flat" cmpd="sng" algn="ctr">
-                      <a:solidFill>
-                        <a:srgbClr val="DCE1E7"/>
-                      </a:solidFill>
-                      <a:prstDash val="solid"/>
-                      <a:round/>
-                      <a:headEnd type="none" w="med" len="med"/>
-                      <a:tailEnd type="none" w="med" len="med"/>
-                    </a:lnL>
-                    <a:lnR w="9525" cap="flat" cmpd="sng" algn="ctr">
-                      <a:solidFill>
-                        <a:srgbClr val="DCE1E7"/>
-                      </a:solidFill>
-                      <a:prstDash val="solid"/>
-                      <a:round/>
-                      <a:headEnd type="none" w="med" len="med"/>
-                      <a:tailEnd type="none" w="med" len="med"/>
-                    </a:lnR>
-                    <a:lnT w="9525" cap="flat" cmpd="sng" algn="ctr">
-                      <a:solidFill>
-                        <a:srgbClr val="DCE1E7"/>
-                      </a:solidFill>
-                      <a:prstDash val="solid"/>
-                      <a:round/>
-                      <a:headEnd type="none" w="med" len="med"/>
-                      <a:tailEnd type="none" w="med" len="med"/>
-                    </a:lnT>
-                    <a:lnB w="9525" cap="flat" cmpd="sng" algn="ctr">
-                      <a:solidFill>
-                        <a:srgbClr val="DCE1E7"/>
-                      </a:solidFill>
-                      <a:prstDash val="solid"/>
-                      <a:round/>
-                      <a:headEnd type="none" w="med" len="med"/>
-                      <a:tailEnd type="none" w="med" len="med"/>
-                    </a:lnB>
-                    <a:solidFill>
-                      <a:srgbClr val="FFFFFF"/>
-                    </a:solidFill>
-                  </a:tcPr>
-                </a:tc>
-                <a:tc>
-                  <a:txBody>
-                    <a:bodyPr/>
-                    <a:lstStyle/>
-                    <a:p>
-                      <a:pPr indent="0" marL="0">
-                        <a:buNone/>
-                      </a:pPr>
-                      <a:r>
-                        <a:rPr lang="en-US" sz="950" dirty="0">
-                          <a:solidFill>
-                            <a:srgbClr val="6E6E73"/>
-                          </a:solidFill>
-                          <a:latin typeface="SF Pro Text" pitchFamily="34" charset="0"/>
-                          <a:ea typeface="SF Pro Text" pitchFamily="34" charset="-122"/>
-                          <a:cs typeface="SF Pro Text" pitchFamily="34" charset="-120"/>
-                        </a:rPr>
-                        <a:t>book</a:t>
-                      </a:r>
-                      <a:endParaRPr lang="en-US" sz="950" dirty="0">
-                        <a:latin typeface="SF Pro Text" charset="0"/>
-                        <a:ea typeface="SF Pro Text" charset="0"/>
-                        <a:cs typeface="SF Pro Text" charset="0"/>
-                      </a:endParaRPr>
-                    </a:p>
-                  </a:txBody>
-                  <a:tcPr marL="91440" marR="91440" marT="27432" marB="27432" anchor="ctr">
-                    <a:lnL w="9525" cap="flat" cmpd="sng" algn="ctr">
-                      <a:solidFill>
-                        <a:srgbClr val="DCE1E7"/>
-                      </a:solidFill>
-                      <a:prstDash val="solid"/>
-                      <a:round/>
-                      <a:headEnd type="none" w="med" len="med"/>
-                      <a:tailEnd type="none" w="med" len="med"/>
-                    </a:lnL>
-                    <a:lnR w="9525" cap="flat" cmpd="sng" algn="ctr">
-                      <a:solidFill>
-                        <a:srgbClr val="DCE1E7"/>
-                      </a:solidFill>
-                      <a:prstDash val="solid"/>
-                      <a:round/>
-                      <a:headEnd type="none" w="med" len="med"/>
-                      <a:tailEnd type="none" w="med" len="med"/>
-                    </a:lnR>
-                    <a:lnT w="9525" cap="flat" cmpd="sng" algn="ctr">
-                      <a:solidFill>
-                        <a:srgbClr val="DCE1E7"/>
-                      </a:solidFill>
-                      <a:prstDash val="solid"/>
-                      <a:round/>
-                      <a:headEnd type="none" w="med" len="med"/>
-                      <a:tailEnd type="none" w="med" len="med"/>
-                    </a:lnT>
-                    <a:lnB w="9525" cap="flat" cmpd="sng" algn="ctr">
-                      <a:solidFill>
-                        <a:srgbClr val="DCE1E7"/>
-                      </a:solidFill>
-                      <a:prstDash val="solid"/>
-                      <a:round/>
-                      <a:headEnd type="none" w="med" len="med"/>
-                      <a:tailEnd type="none" w="med" len="med"/>
-                    </a:lnB>
-                    <a:solidFill>
-                      <a:srgbClr val="FFFFFF"/>
-                    </a:solidFill>
-                  </a:tcPr>
-                </a:tc>
-                <a:tc>
-                  <a:txBody>
-                    <a:bodyPr/>
-                    <a:lstStyle/>
-                    <a:p>
-                      <a:pPr indent="0" marL="0">
-                        <a:buNone/>
-                      </a:pPr>
-                      <a:r>
-                        <a:rPr lang="en-US" sz="950" dirty="0">
-                          <a:solidFill>
-                            <a:srgbClr val="6E6E73"/>
-                          </a:solidFill>
-                          <a:latin typeface="SF Pro Text" pitchFamily="34" charset="0"/>
-                          <a:ea typeface="SF Pro Text" pitchFamily="34" charset="-122"/>
-                          <a:cs typeface="SF Pro Text" pitchFamily="34" charset="-120"/>
-                        </a:rPr>
-                        <a:t>Job booked for Sep 21, 10 AM</a:t>
-                      </a:r>
-                      <a:endParaRPr lang="en-US" sz="950" dirty="0">
-                        <a:latin typeface="SF Pro Text" charset="0"/>
-                        <a:ea typeface="SF Pro Text" charset="0"/>
-                        <a:cs typeface="SF Pro Text" charset="0"/>
-                      </a:endParaRPr>
-                    </a:p>
-                  </a:txBody>
-                  <a:tcPr marL="91440" marR="91440" marT="27432" marB="27432" anchor="ctr">
-                    <a:lnL w="9525" cap="flat" cmpd="sng" algn="ctr">
-                      <a:solidFill>
-                        <a:srgbClr val="DCE1E7"/>
-                      </a:solidFill>
-                      <a:prstDash val="solid"/>
-                      <a:round/>
-                      <a:headEnd type="none" w="med" len="med"/>
-                      <a:tailEnd type="none" w="med" len="med"/>
-                    </a:lnL>
-                    <a:lnR w="9525" cap="flat" cmpd="sng" algn="ctr">
-                      <a:solidFill>
-                        <a:srgbClr val="DCE1E7"/>
-                      </a:solidFill>
-                      <a:prstDash val="solid"/>
-                      <a:round/>
-                      <a:headEnd type="none" w="med" len="med"/>
-                      <a:tailEnd type="none" w="med" len="med"/>
-                    </a:lnR>
-                    <a:lnT w="9525" cap="flat" cmpd="sng" algn="ctr">
-                      <a:solidFill>
-                        <a:srgbClr val="DCE1E7"/>
-                      </a:solidFill>
-                      <a:prstDash val="solid"/>
-                      <a:round/>
-                      <a:headEnd type="none" w="med" len="med"/>
-                      <a:tailEnd type="none" w="med" len="med"/>
-                    </a:lnT>
-                    <a:lnB w="9525" cap="flat" cmpd="sng" algn="ctr">
-                      <a:solidFill>
-                        <a:srgbClr val="DCE1E7"/>
-                      </a:solidFill>
-                      <a:prstDash val="solid"/>
-                      <a:round/>
-                      <a:headEnd type="none" w="med" len="med"/>
-                      <a:tailEnd type="none" w="med" len="med"/>
-                    </a:lnB>
-                    <a:solidFill>
-                      <a:srgbClr val="FFFFFF"/>
-                    </a:solidFill>
-                  </a:tcPr>
-                </a:tc>
-              </a:tr>
-              <a:tr h="329184">
-                <a:tc>
-                  <a:txBody>
-                    <a:bodyPr/>
-                    <a:lstStyle/>
-                    <a:p>
-                      <a:pPr indent="0" marL="0">
-                        <a:buNone/>
-                      </a:pPr>
-                      <a:r>
-                        <a:rPr lang="en-US" sz="950" b="1" dirty="0">
-                          <a:solidFill>
-                            <a:srgbClr val="1D1D1F"/>
-                          </a:solidFill>
-                          <a:latin typeface="SF Pro Text" pitchFamily="34" charset="0"/>
-                          <a:ea typeface="SF Pro Text" pitchFamily="34" charset="-122"/>
-                          <a:cs typeface="SF Pro Text" pitchFamily="34" charset="-120"/>
-                        </a:rPr>
-                        <a:t>2</a:t>
-                      </a:r>
-                      <a:endParaRPr lang="en-US" sz="950" dirty="0">
-                        <a:latin typeface="SF Pro Text" charset="0"/>
-                        <a:ea typeface="SF Pro Text" charset="0"/>
-                        <a:cs typeface="SF Pro Text" charset="0"/>
-                      </a:endParaRPr>
-                    </a:p>
-                  </a:txBody>
-                  <a:tcPr marL="91440" marR="91440" marT="27432" marB="27432" anchor="ctr">
-                    <a:lnL w="9525" cap="flat" cmpd="sng" algn="ctr">
-                      <a:solidFill>
-                        <a:srgbClr val="DCE1E7"/>
-                      </a:solidFill>
-                      <a:prstDash val="solid"/>
-                      <a:round/>
-                      <a:headEnd type="none" w="med" len="med"/>
-                      <a:tailEnd type="none" w="med" len="med"/>
-                    </a:lnL>
-                    <a:lnR w="9525" cap="flat" cmpd="sng" algn="ctr">
-                      <a:solidFill>
-                        <a:srgbClr val="DCE1E7"/>
-                      </a:solidFill>
-                      <a:prstDash val="solid"/>
-                      <a:round/>
-                      <a:headEnd type="none" w="med" len="med"/>
-                      <a:tailEnd type="none" w="med" len="med"/>
-                    </a:lnR>
-                    <a:lnT w="9525" cap="flat" cmpd="sng" algn="ctr">
-                      <a:solidFill>
-                        <a:srgbClr val="DCE1E7"/>
-                      </a:solidFill>
-                      <a:prstDash val="solid"/>
-                      <a:round/>
-                      <a:headEnd type="none" w="med" len="med"/>
-                      <a:tailEnd type="none" w="med" len="med"/>
-                    </a:lnT>
-                    <a:lnB w="9525" cap="flat" cmpd="sng" algn="ctr">
-                      <a:solidFill>
-                        <a:srgbClr val="DCE1E7"/>
-                      </a:solidFill>
-                      <a:prstDash val="solid"/>
-                      <a:round/>
-                      <a:headEnd type="none" w="med" len="med"/>
-                      <a:tailEnd type="none" w="med" len="med"/>
-                    </a:lnB>
-                    <a:solidFill>
-                      <a:srgbClr val="FFFFFF"/>
-                    </a:solidFill>
-                  </a:tcPr>
-                </a:tc>
-                <a:tc>
-                  <a:txBody>
-                    <a:bodyPr/>
-                    <a:lstStyle/>
-                    <a:p>
-                      <a:pPr indent="0" marL="0">
-                        <a:buNone/>
-                      </a:pPr>
-                      <a:r>
-                        <a:rPr lang="en-US" sz="950" dirty="0">
-                          <a:solidFill>
-                            <a:srgbClr val="6E6E73"/>
-                          </a:solidFill>
-                          <a:latin typeface="SF Pro Text" pitchFamily="34" charset="0"/>
-                          <a:ea typeface="SF Pro Text" pitchFamily="34" charset="-122"/>
-                          <a:cs typeface="SF Pro Text" pitchFamily="34" charset="-120"/>
-                        </a:rPr>
-                        <a:t>Sep 14, 2:29 PM</a:t>
-                      </a:r>
-                      <a:endParaRPr lang="en-US" sz="950" dirty="0">
-                        <a:latin typeface="SF Pro Text" charset="0"/>
-                        <a:ea typeface="SF Pro Text" charset="0"/>
-                        <a:cs typeface="SF Pro Text" charset="0"/>
-                      </a:endParaRPr>
-                    </a:p>
-                  </a:txBody>
-                  <a:tcPr marL="91440" marR="91440" marT="27432" marB="27432" anchor="ctr">
-                    <a:lnL w="9525" cap="flat" cmpd="sng" algn="ctr">
-                      <a:solidFill>
-                        <a:srgbClr val="DCE1E7"/>
-                      </a:solidFill>
-                      <a:prstDash val="solid"/>
-                      <a:round/>
-                      <a:headEnd type="none" w="med" len="med"/>
-                      <a:tailEnd type="none" w="med" len="med"/>
-                    </a:lnL>
-                    <a:lnR w="9525" cap="flat" cmpd="sng" algn="ctr">
-                      <a:solidFill>
-                        <a:srgbClr val="DCE1E7"/>
-                      </a:solidFill>
-                      <a:prstDash val="solid"/>
-                      <a:round/>
-                      <a:headEnd type="none" w="med" len="med"/>
-                      <a:tailEnd type="none" w="med" len="med"/>
-                    </a:lnR>
-                    <a:lnT w="9525" cap="flat" cmpd="sng" algn="ctr">
-                      <a:solidFill>
-                        <a:srgbClr val="DCE1E7"/>
-                      </a:solidFill>
-                      <a:prstDash val="solid"/>
-                      <a:round/>
-                      <a:headEnd type="none" w="med" len="med"/>
-                      <a:tailEnd type="none" w="med" len="med"/>
-                    </a:lnT>
-                    <a:lnB w="9525" cap="flat" cmpd="sng" algn="ctr">
-                      <a:solidFill>
-                        <a:srgbClr val="DCE1E7"/>
-                      </a:solidFill>
-                      <a:prstDash val="solid"/>
-                      <a:round/>
-                      <a:headEnd type="none" w="med" len="med"/>
-                      <a:tailEnd type="none" w="med" len="med"/>
-                    </a:lnB>
-                    <a:solidFill>
-                      <a:srgbClr val="FFFFFF"/>
-                    </a:solidFill>
-                  </a:tcPr>
-                </a:tc>
-                <a:tc>
-                  <a:txBody>
-                    <a:bodyPr/>
-                    <a:lstStyle/>
-                    <a:p>
-                      <a:pPr indent="0" marL="0">
-                        <a:buNone/>
-                      </a:pPr>
-                      <a:r>
-                        <a:rPr lang="en-US" sz="950" dirty="0">
-                          <a:solidFill>
-                            <a:srgbClr val="6E6E73"/>
-                          </a:solidFill>
-                          <a:latin typeface="SF Pro Text" pitchFamily="34" charset="0"/>
-                          <a:ea typeface="SF Pro Text" pitchFamily="34" charset="-122"/>
-                          <a:cs typeface="SF Pro Text" pitchFamily="34" charset="-120"/>
-                        </a:rPr>
-                        <a:t>cleaner</a:t>
-                      </a:r>
-                      <a:endParaRPr lang="en-US" sz="950" dirty="0">
-                        <a:latin typeface="SF Pro Text" charset="0"/>
-                        <a:ea typeface="SF Pro Text" charset="0"/>
-                        <a:cs typeface="SF Pro Text" charset="0"/>
-                      </a:endParaRPr>
-                    </a:p>
-                  </a:txBody>
-                  <a:tcPr marL="91440" marR="91440" marT="27432" marB="27432" anchor="ctr">
-                    <a:lnL w="9525" cap="flat" cmpd="sng" algn="ctr">
-                      <a:solidFill>
-                        <a:srgbClr val="DCE1E7"/>
-                      </a:solidFill>
-                      <a:prstDash val="solid"/>
-                      <a:round/>
-                      <a:headEnd type="none" w="med" len="med"/>
-                      <a:tailEnd type="none" w="med" len="med"/>
-                    </a:lnL>
-                    <a:lnR w="9525" cap="flat" cmpd="sng" algn="ctr">
-                      <a:solidFill>
-                        <a:srgbClr val="DCE1E7"/>
-                      </a:solidFill>
-                      <a:prstDash val="solid"/>
-                      <a:round/>
-                      <a:headEnd type="none" w="med" len="med"/>
-                      <a:tailEnd type="none" w="med" len="med"/>
-                    </a:lnR>
-                    <a:lnT w="9525" cap="flat" cmpd="sng" algn="ctr">
-                      <a:solidFill>
-                        <a:srgbClr val="DCE1E7"/>
-                      </a:solidFill>
-                      <a:prstDash val="solid"/>
-                      <a:round/>
-                      <a:headEnd type="none" w="med" len="med"/>
-                      <a:tailEnd type="none" w="med" len="med"/>
-                    </a:lnT>
-                    <a:lnB w="9525" cap="flat" cmpd="sng" algn="ctr">
-                      <a:solidFill>
-                        <a:srgbClr val="DCE1E7"/>
-                      </a:solidFill>
-                      <a:prstDash val="solid"/>
-                      <a:round/>
-                      <a:headEnd type="none" w="med" len="med"/>
-                      <a:tailEnd type="none" w="med" len="med"/>
-                    </a:lnB>
-                    <a:solidFill>
-                      <a:srgbClr val="FFFFFF"/>
-                    </a:solidFill>
-                  </a:tcPr>
-                </a:tc>
-                <a:tc>
-                  <a:txBody>
-                    <a:bodyPr/>
-                    <a:lstStyle/>
-                    <a:p>
-                      <a:pPr indent="0" marL="0">
-                        <a:buNone/>
-                      </a:pPr>
-                      <a:r>
-                        <a:rPr lang="en-US" sz="950" dirty="0">
-                          <a:solidFill>
-                            <a:srgbClr val="6E6E73"/>
-                          </a:solidFill>
-                          <a:latin typeface="SF Pro Text" pitchFamily="34" charset="0"/>
-                          <a:ea typeface="SF Pro Text" pitchFamily="34" charset="-122"/>
-                          <a:cs typeface="SF Pro Text" pitchFamily="34" charset="-120"/>
-                        </a:rPr>
-                        <a:t>claim</a:t>
-                      </a:r>
-                      <a:endParaRPr lang="en-US" sz="950" dirty="0">
-                        <a:latin typeface="SF Pro Text" charset="0"/>
-                        <a:ea typeface="SF Pro Text" charset="0"/>
-                        <a:cs typeface="SF Pro Text" charset="0"/>
-                      </a:endParaRPr>
-                    </a:p>
-                  </a:txBody>
-                  <a:tcPr marL="91440" marR="91440" marT="27432" marB="27432" anchor="ctr">
-                    <a:lnL w="9525" cap="flat" cmpd="sng" algn="ctr">
-                      <a:solidFill>
-                        <a:srgbClr val="DCE1E7"/>
-                      </a:solidFill>
-                      <a:prstDash val="solid"/>
-                      <a:round/>
-                      <a:headEnd type="none" w="med" len="med"/>
-                      <a:tailEnd type="none" w="med" len="med"/>
-                    </a:lnL>
-                    <a:lnR w="9525" cap="flat" cmpd="sng" algn="ctr">
-                      <a:solidFill>
-                        <a:srgbClr val="DCE1E7"/>
-                      </a:solidFill>
-                      <a:prstDash val="solid"/>
-                      <a:round/>
-                      <a:headEnd type="none" w="med" len="med"/>
-                      <a:tailEnd type="none" w="med" len="med"/>
-                    </a:lnR>
-                    <a:lnT w="9525" cap="flat" cmpd="sng" algn="ctr">
-                      <a:solidFill>
-                        <a:srgbClr val="DCE1E7"/>
-                      </a:solidFill>
-                      <a:prstDash val="solid"/>
-                      <a:round/>
-                      <a:headEnd type="none" w="med" len="med"/>
-                      <a:tailEnd type="none" w="med" len="med"/>
-                    </a:lnT>
-                    <a:lnB w="9525" cap="flat" cmpd="sng" algn="ctr">
-                      <a:solidFill>
-                        <a:srgbClr val="DCE1E7"/>
-                      </a:solidFill>
-                      <a:prstDash val="solid"/>
-                      <a:round/>
-                      <a:headEnd type="none" w="med" len="med"/>
-                      <a:tailEnd type="none" w="med" len="med"/>
-                    </a:lnB>
-                    <a:solidFill>
-                      <a:srgbClr val="FFFFFF"/>
-                    </a:solidFill>
-                  </a:tcPr>
-                </a:tc>
-                <a:tc>
-                  <a:txBody>
-                    <a:bodyPr/>
-                    <a:lstStyle/>
-                    <a:p>
-                      <a:pPr indent="0" marL="0">
-                        <a:buNone/>
-                      </a:pPr>
-                      <a:r>
-                        <a:rPr lang="en-US" sz="950" dirty="0">
-                          <a:solidFill>
-                            <a:srgbClr val="6E6E73"/>
-                          </a:solidFill>
-                          <a:latin typeface="SF Pro Text" pitchFamily="34" charset="0"/>
-                          <a:ea typeface="SF Pro Text" pitchFamily="34" charset="-122"/>
-                          <a:cs typeface="SF Pro Text" pitchFamily="34" charset="-120"/>
-                        </a:rPr>
-                        <a:t>The cleaner claimed it</a:t>
-                      </a:r>
-                      <a:endParaRPr lang="en-US" sz="950" dirty="0">
-                        <a:latin typeface="SF Pro Text" charset="0"/>
-                        <a:ea typeface="SF Pro Text" charset="0"/>
-                        <a:cs typeface="SF Pro Text" charset="0"/>
-                      </a:endParaRPr>
-                    </a:p>
-                  </a:txBody>
-                  <a:tcPr marL="91440" marR="91440" marT="27432" marB="27432" anchor="ctr">
-                    <a:lnL w="9525" cap="flat" cmpd="sng" algn="ctr">
-                      <a:solidFill>
-                        <a:srgbClr val="DCE1E7"/>
-                      </a:solidFill>
-                      <a:prstDash val="solid"/>
-                      <a:round/>
-                      <a:headEnd type="none" w="med" len="med"/>
-                      <a:tailEnd type="none" w="med" len="med"/>
-                    </a:lnL>
-                    <a:lnR w="9525" cap="flat" cmpd="sng" algn="ctr">
-                      <a:solidFill>
-                        <a:srgbClr val="DCE1E7"/>
-                      </a:solidFill>
-                      <a:prstDash val="solid"/>
-                      <a:round/>
-                      <a:headEnd type="none" w="med" len="med"/>
-                      <a:tailEnd type="none" w="med" len="med"/>
-                    </a:lnR>
-                    <a:lnT w="9525" cap="flat" cmpd="sng" algn="ctr">
-                      <a:solidFill>
-                        <a:srgbClr val="DCE1E7"/>
-                      </a:solidFill>
-                      <a:prstDash val="solid"/>
-                      <a:round/>
-                      <a:headEnd type="none" w="med" len="med"/>
-                      <a:tailEnd type="none" w="med" len="med"/>
-                    </a:lnT>
-                    <a:lnB w="9525" cap="flat" cmpd="sng" algn="ctr">
-                      <a:solidFill>
-                        <a:srgbClr val="DCE1E7"/>
-                      </a:solidFill>
-                      <a:prstDash val="solid"/>
-                      <a:round/>
-                      <a:headEnd type="none" w="med" len="med"/>
-                      <a:tailEnd type="none" w="med" len="med"/>
-                    </a:lnB>
-                    <a:solidFill>
-                      <a:srgbClr val="FFFFFF"/>
-                    </a:solidFill>
-                  </a:tcPr>
-                </a:tc>
-              </a:tr>
-              <a:tr h="329184">
-                <a:tc>
-                  <a:txBody>
-                    <a:bodyPr/>
-                    <a:lstStyle/>
-                    <a:p>
-                      <a:pPr indent="0" marL="0">
-                        <a:buNone/>
-                      </a:pPr>
-                      <a:r>
-                        <a:rPr lang="en-US" sz="950" b="1" dirty="0">
-                          <a:solidFill>
-                            <a:srgbClr val="1D1D1F"/>
-                          </a:solidFill>
-                          <a:latin typeface="SF Pro Text" pitchFamily="34" charset="0"/>
-                          <a:ea typeface="SF Pro Text" pitchFamily="34" charset="-122"/>
-                          <a:cs typeface="SF Pro Text" pitchFamily="34" charset="-120"/>
-                        </a:rPr>
-                        <a:t>3</a:t>
-                      </a:r>
-                      <a:endParaRPr lang="en-US" sz="950" dirty="0">
-                        <a:latin typeface="SF Pro Text" charset="0"/>
-                        <a:ea typeface="SF Pro Text" charset="0"/>
-                        <a:cs typeface="SF Pro Text" charset="0"/>
-                      </a:endParaRPr>
-                    </a:p>
-                  </a:txBody>
-                  <a:tcPr marL="91440" marR="91440" marT="27432" marB="27432" anchor="ctr">
-                    <a:lnL w="9525" cap="flat" cmpd="sng" algn="ctr">
-                      <a:solidFill>
-                        <a:srgbClr val="DCE1E7"/>
-                      </a:solidFill>
-                      <a:prstDash val="solid"/>
-                      <a:round/>
-                      <a:headEnd type="none" w="med" len="med"/>
-                      <a:tailEnd type="none" w="med" len="med"/>
-                    </a:lnL>
-                    <a:lnR w="9525" cap="flat" cmpd="sng" algn="ctr">
-                      <a:solidFill>
-                        <a:srgbClr val="DCE1E7"/>
-                      </a:solidFill>
-                      <a:prstDash val="solid"/>
-                      <a:round/>
-                      <a:headEnd type="none" w="med" len="med"/>
-                      <a:tailEnd type="none" w="med" len="med"/>
-                    </a:lnR>
-                    <a:lnT w="9525" cap="flat" cmpd="sng" algn="ctr">
-                      <a:solidFill>
-                        <a:srgbClr val="DCE1E7"/>
-                      </a:solidFill>
-                      <a:prstDash val="solid"/>
-                      <a:round/>
-                      <a:headEnd type="none" w="med" len="med"/>
-                      <a:tailEnd type="none" w="med" len="med"/>
-                    </a:lnT>
-                    <a:lnB w="9525" cap="flat" cmpd="sng" algn="ctr">
-                      <a:solidFill>
-                        <a:srgbClr val="DCE1E7"/>
-                      </a:solidFill>
-                      <a:prstDash val="solid"/>
-                      <a:round/>
-                      <a:headEnd type="none" w="med" len="med"/>
-                      <a:tailEnd type="none" w="med" len="med"/>
-                    </a:lnB>
-                    <a:solidFill>
-                      <a:srgbClr val="FFFFFF"/>
-                    </a:solidFill>
-                  </a:tcPr>
-                </a:tc>
-                <a:tc>
-                  <a:txBody>
-                    <a:bodyPr/>
-                    <a:lstStyle/>
-                    <a:p>
-                      <a:pPr indent="0" marL="0">
-                        <a:buNone/>
-                      </a:pPr>
-                      <a:r>
-                        <a:rPr lang="en-US" sz="950" dirty="0">
-                          <a:solidFill>
-                            <a:srgbClr val="6E6E73"/>
-                          </a:solidFill>
-                          <a:latin typeface="SF Pro Text" pitchFamily="34" charset="0"/>
-                          <a:ea typeface="SF Pro Text" pitchFamily="34" charset="-122"/>
-                          <a:cs typeface="SF Pro Text" pitchFamily="34" charset="-120"/>
-                        </a:rPr>
-                        <a:t>Sep 21, 9:19 AM</a:t>
-                      </a:r>
-                      <a:endParaRPr lang="en-US" sz="950" dirty="0">
-                        <a:latin typeface="SF Pro Text" charset="0"/>
-                        <a:ea typeface="SF Pro Text" charset="0"/>
-                        <a:cs typeface="SF Pro Text" charset="0"/>
-                      </a:endParaRPr>
-                    </a:p>
-                  </a:txBody>
-                  <a:tcPr marL="91440" marR="91440" marT="27432" marB="27432" anchor="ctr">
-                    <a:lnL w="9525" cap="flat" cmpd="sng" algn="ctr">
-                      <a:solidFill>
-                        <a:srgbClr val="DCE1E7"/>
-                      </a:solidFill>
-                      <a:prstDash val="solid"/>
-                      <a:round/>
-                      <a:headEnd type="none" w="med" len="med"/>
-                      <a:tailEnd type="none" w="med" len="med"/>
-                    </a:lnL>
-                    <a:lnR w="9525" cap="flat" cmpd="sng" algn="ctr">
-                      <a:solidFill>
-                        <a:srgbClr val="DCE1E7"/>
-                      </a:solidFill>
-                      <a:prstDash val="solid"/>
-                      <a:round/>
-                      <a:headEnd type="none" w="med" len="med"/>
-                      <a:tailEnd type="none" w="med" len="med"/>
-                    </a:lnR>
-                    <a:lnT w="9525" cap="flat" cmpd="sng" algn="ctr">
-                      <a:solidFill>
-                        <a:srgbClr val="DCE1E7"/>
-                      </a:solidFill>
-                      <a:prstDash val="solid"/>
-                      <a:round/>
-                      <a:headEnd type="none" w="med" len="med"/>
-                      <a:tailEnd type="none" w="med" len="med"/>
-                    </a:lnT>
-                    <a:lnB w="9525" cap="flat" cmpd="sng" algn="ctr">
-                      <a:solidFill>
-                        <a:srgbClr val="DCE1E7"/>
-                      </a:solidFill>
-                      <a:prstDash val="solid"/>
-                      <a:round/>
-                      <a:headEnd type="none" w="med" len="med"/>
-                      <a:tailEnd type="none" w="med" len="med"/>
-                    </a:lnB>
-                    <a:solidFill>
-                      <a:srgbClr val="FFFFFF"/>
-                    </a:solidFill>
-                  </a:tcPr>
-                </a:tc>
-                <a:tc>
-                  <a:txBody>
-                    <a:bodyPr/>
-                    <a:lstStyle/>
-                    <a:p>
-                      <a:pPr indent="0" marL="0">
-                        <a:buNone/>
-                      </a:pPr>
-                      <a:r>
-                        <a:rPr lang="en-US" sz="950" dirty="0">
-                          <a:solidFill>
-                            <a:srgbClr val="6E6E73"/>
-                          </a:solidFill>
-                          <a:latin typeface="SF Pro Text" pitchFamily="34" charset="0"/>
-                          <a:ea typeface="SF Pro Text" pitchFamily="34" charset="-122"/>
-                          <a:cs typeface="SF Pro Text" pitchFamily="34" charset="-120"/>
-                        </a:rPr>
-                        <a:t>cleaner</a:t>
-                      </a:r>
-                      <a:endParaRPr lang="en-US" sz="950" dirty="0">
-                        <a:latin typeface="SF Pro Text" charset="0"/>
-                        <a:ea typeface="SF Pro Text" charset="0"/>
-                        <a:cs typeface="SF Pro Text" charset="0"/>
-                      </a:endParaRPr>
-                    </a:p>
-                  </a:txBody>
-                  <a:tcPr marL="91440" marR="91440" marT="27432" marB="27432" anchor="ctr">
-                    <a:lnL w="9525" cap="flat" cmpd="sng" algn="ctr">
-                      <a:solidFill>
-                        <a:srgbClr val="DCE1E7"/>
-                      </a:solidFill>
-                      <a:prstDash val="solid"/>
-                      <a:round/>
-                      <a:headEnd type="none" w="med" len="med"/>
-                      <a:tailEnd type="none" w="med" len="med"/>
-                    </a:lnL>
-                    <a:lnR w="9525" cap="flat" cmpd="sng" algn="ctr">
-                      <a:solidFill>
-                        <a:srgbClr val="DCE1E7"/>
-                      </a:solidFill>
-                      <a:prstDash val="solid"/>
-                      <a:round/>
-                      <a:headEnd type="none" w="med" len="med"/>
-                      <a:tailEnd type="none" w="med" len="med"/>
-                    </a:lnR>
-                    <a:lnT w="9525" cap="flat" cmpd="sng" algn="ctr">
-                      <a:solidFill>
-                        <a:srgbClr val="DCE1E7"/>
-                      </a:solidFill>
-                      <a:prstDash val="solid"/>
-                      <a:round/>
-                      <a:headEnd type="none" w="med" len="med"/>
-                      <a:tailEnd type="none" w="med" len="med"/>
-                    </a:lnT>
-                    <a:lnB w="9525" cap="flat" cmpd="sng" algn="ctr">
-                      <a:solidFill>
-                        <a:srgbClr val="DCE1E7"/>
-                      </a:solidFill>
-                      <a:prstDash val="solid"/>
-                      <a:round/>
-                      <a:headEnd type="none" w="med" len="med"/>
-                      <a:tailEnd type="none" w="med" len="med"/>
-                    </a:lnB>
-                    <a:solidFill>
-                      <a:srgbClr val="FFFFFF"/>
-                    </a:solidFill>
-                  </a:tcPr>
-                </a:tc>
-                <a:tc>
-                  <a:txBody>
-                    <a:bodyPr/>
-                    <a:lstStyle/>
-                    <a:p>
-                      <a:pPr indent="0" marL="0">
-                        <a:buNone/>
-                      </a:pPr>
-                      <a:r>
-                        <a:rPr lang="en-US" sz="950" dirty="0">
-                          <a:solidFill>
-                            <a:srgbClr val="6E6E73"/>
-                          </a:solidFill>
-                          <a:latin typeface="SF Pro Text" pitchFamily="34" charset="0"/>
-                          <a:ea typeface="SF Pro Text" pitchFamily="34" charset="-122"/>
-                          <a:cs typeface="SF Pro Text" pitchFamily="34" charset="-120"/>
-                        </a:rPr>
-                        <a:t>reschedule</a:t>
-                      </a:r>
-                      <a:endParaRPr lang="en-US" sz="950" dirty="0">
-                        <a:latin typeface="SF Pro Text" charset="0"/>
-                        <a:ea typeface="SF Pro Text" charset="0"/>
-                        <a:cs typeface="SF Pro Text" charset="0"/>
-                      </a:endParaRPr>
-                    </a:p>
-                  </a:txBody>
-                  <a:tcPr marL="91440" marR="91440" marT="27432" marB="27432" anchor="ctr">
-                    <a:lnL w="9525" cap="flat" cmpd="sng" algn="ctr">
-                      <a:solidFill>
-                        <a:srgbClr val="DCE1E7"/>
-                      </a:solidFill>
-                      <a:prstDash val="solid"/>
-                      <a:round/>
-                      <a:headEnd type="none" w="med" len="med"/>
-                      <a:tailEnd type="none" w="med" len="med"/>
-                    </a:lnL>
-                    <a:lnR w="9525" cap="flat" cmpd="sng" algn="ctr">
-                      <a:solidFill>
-                        <a:srgbClr val="DCE1E7"/>
-                      </a:solidFill>
-                      <a:prstDash val="solid"/>
-                      <a:round/>
-                      <a:headEnd type="none" w="med" len="med"/>
-                      <a:tailEnd type="none" w="med" len="med"/>
-                    </a:lnR>
-                    <a:lnT w="9525" cap="flat" cmpd="sng" algn="ctr">
-                      <a:solidFill>
-                        <a:srgbClr val="DCE1E7"/>
-                      </a:solidFill>
-                      <a:prstDash val="solid"/>
-                      <a:round/>
-                      <a:headEnd type="none" w="med" len="med"/>
-                      <a:tailEnd type="none" w="med" len="med"/>
-                    </a:lnT>
-                    <a:lnB w="9525" cap="flat" cmpd="sng" algn="ctr">
-                      <a:solidFill>
-                        <a:srgbClr val="DCE1E7"/>
-                      </a:solidFill>
-                      <a:prstDash val="solid"/>
-                      <a:round/>
-                      <a:headEnd type="none" w="med" len="med"/>
-                      <a:tailEnd type="none" w="med" len="med"/>
-                    </a:lnB>
-                    <a:solidFill>
-                      <a:srgbClr val="FFFFFF"/>
-                    </a:solidFill>
-                  </a:tcPr>
-                </a:tc>
-                <a:tc>
-                  <a:txBody>
-                    <a:bodyPr/>
-                    <a:lstStyle/>
-                    <a:p>
-                      <a:pPr indent="0" marL="0">
-                        <a:buNone/>
-                      </a:pPr>
-                      <a:r>
-                        <a:rPr lang="en-US" sz="950" dirty="0">
-                          <a:solidFill>
-                            <a:srgbClr val="6E6E73"/>
-                          </a:solidFill>
-                          <a:latin typeface="SF Pro Text" pitchFamily="34" charset="0"/>
-                          <a:ea typeface="SF Pro Text" pitchFamily="34" charset="-122"/>
-                          <a:cs typeface="SF Pro Text" pitchFamily="34" charset="-120"/>
-                        </a:rPr>
-                        <a:t>Moved from Sep 21, 10 AM to Sep 22, 11 AM</a:t>
-                      </a:r>
-                      <a:endParaRPr lang="en-US" sz="950" dirty="0">
-                        <a:latin typeface="SF Pro Text" charset="0"/>
-                        <a:ea typeface="SF Pro Text" charset="0"/>
-                        <a:cs typeface="SF Pro Text" charset="0"/>
-                      </a:endParaRPr>
-                    </a:p>
-                  </a:txBody>
-                  <a:tcPr marL="91440" marR="91440" marT="27432" marB="27432" anchor="ctr">
-                    <a:lnL w="9525" cap="flat" cmpd="sng" algn="ctr">
-                      <a:solidFill>
-                        <a:srgbClr val="DCE1E7"/>
-                      </a:solidFill>
-                      <a:prstDash val="solid"/>
-                      <a:round/>
-                      <a:headEnd type="none" w="med" len="med"/>
-                      <a:tailEnd type="none" w="med" len="med"/>
-                    </a:lnL>
-                    <a:lnR w="9525" cap="flat" cmpd="sng" algn="ctr">
-                      <a:solidFill>
-                        <a:srgbClr val="DCE1E7"/>
-                      </a:solidFill>
-                      <a:prstDash val="solid"/>
-                      <a:round/>
-                      <a:headEnd type="none" w="med" len="med"/>
-                      <a:tailEnd type="none" w="med" len="med"/>
-                    </a:lnR>
-                    <a:lnT w="9525" cap="flat" cmpd="sng" algn="ctr">
-                      <a:solidFill>
-                        <a:srgbClr val="DCE1E7"/>
-                      </a:solidFill>
-                      <a:prstDash val="solid"/>
-                      <a:round/>
-                      <a:headEnd type="none" w="med" len="med"/>
-                      <a:tailEnd type="none" w="med" len="med"/>
-                    </a:lnT>
-                    <a:lnB w="9525" cap="flat" cmpd="sng" algn="ctr">
-                      <a:solidFill>
-                        <a:srgbClr val="DCE1E7"/>
-                      </a:solidFill>
-                      <a:prstDash val="solid"/>
-                      <a:round/>
-                      <a:headEnd type="none" w="med" len="med"/>
-                      <a:tailEnd type="none" w="med" len="med"/>
-                    </a:lnB>
-                    <a:solidFill>
-                      <a:srgbClr val="FFFFFF"/>
-                    </a:solidFill>
-                  </a:tcPr>
-                </a:tc>
-              </a:tr>
-              <a:tr h="329184">
-                <a:tc>
-                  <a:txBody>
-                    <a:bodyPr/>
-                    <a:lstStyle/>
-                    <a:p>
-                      <a:pPr indent="0" marL="0">
-                        <a:buNone/>
-                      </a:pPr>
-                      <a:r>
-                        <a:rPr lang="en-US" sz="950" b="1" dirty="0">
-                          <a:solidFill>
-                            <a:srgbClr val="1D1D1F"/>
-                          </a:solidFill>
-                          <a:latin typeface="SF Pro Text" pitchFamily="34" charset="0"/>
-                          <a:ea typeface="SF Pro Text" pitchFamily="34" charset="-122"/>
-                          <a:cs typeface="SF Pro Text" pitchFamily="34" charset="-120"/>
-                        </a:rPr>
-                        <a:t>4</a:t>
-                      </a:r>
-                      <a:endParaRPr lang="en-US" sz="950" dirty="0">
-                        <a:latin typeface="SF Pro Text" charset="0"/>
-                        <a:ea typeface="SF Pro Text" charset="0"/>
-                        <a:cs typeface="SF Pro Text" charset="0"/>
-                      </a:endParaRPr>
-                    </a:p>
-                  </a:txBody>
-                  <a:tcPr marL="91440" marR="91440" marT="27432" marB="27432" anchor="ctr">
-                    <a:lnL w="9525" cap="flat" cmpd="sng" algn="ctr">
-                      <a:solidFill>
-                        <a:srgbClr val="DCE1E7"/>
-                      </a:solidFill>
-                      <a:prstDash val="solid"/>
-                      <a:round/>
-                      <a:headEnd type="none" w="med" len="med"/>
-                      <a:tailEnd type="none" w="med" len="med"/>
-                    </a:lnL>
-                    <a:lnR w="9525" cap="flat" cmpd="sng" algn="ctr">
-                      <a:solidFill>
-                        <a:srgbClr val="DCE1E7"/>
-                      </a:solidFill>
-                      <a:prstDash val="solid"/>
-                      <a:round/>
-                      <a:headEnd type="none" w="med" len="med"/>
-                      <a:tailEnd type="none" w="med" len="med"/>
-                    </a:lnR>
-                    <a:lnT w="9525" cap="flat" cmpd="sng" algn="ctr">
-                      <a:solidFill>
-                        <a:srgbClr val="DCE1E7"/>
-                      </a:solidFill>
-                      <a:prstDash val="solid"/>
-                      <a:round/>
-                      <a:headEnd type="none" w="med" len="med"/>
-                      <a:tailEnd type="none" w="med" len="med"/>
-                    </a:lnT>
-                    <a:lnB w="9525" cap="flat" cmpd="sng" algn="ctr">
-                      <a:solidFill>
-                        <a:srgbClr val="DCE1E7"/>
-                      </a:solidFill>
-                      <a:prstDash val="solid"/>
-                      <a:round/>
-                      <a:headEnd type="none" w="med" len="med"/>
-                      <a:tailEnd type="none" w="med" len="med"/>
-                    </a:lnB>
-                    <a:solidFill>
-                      <a:srgbClr val="FFFFFF"/>
-                    </a:solidFill>
-                  </a:tcPr>
-                </a:tc>
-                <a:tc>
-                  <a:txBody>
-                    <a:bodyPr/>
-                    <a:lstStyle/>
-                    <a:p>
-                      <a:pPr indent="0" marL="0">
-                        <a:buNone/>
-                      </a:pPr>
-                      <a:r>
-                        <a:rPr lang="en-US" sz="950" dirty="0">
-                          <a:solidFill>
-                            <a:srgbClr val="6E6E73"/>
-                          </a:solidFill>
-                          <a:latin typeface="SF Pro Text" pitchFamily="34" charset="0"/>
-                          <a:ea typeface="SF Pro Text" pitchFamily="34" charset="-122"/>
-                          <a:cs typeface="SF Pro Text" pitchFamily="34" charset="-120"/>
-                        </a:rPr>
-                        <a:t>Sep 21, 9:50 AM</a:t>
-                      </a:r>
-                      <a:endParaRPr lang="en-US" sz="950" dirty="0">
-                        <a:latin typeface="SF Pro Text" charset="0"/>
-                        <a:ea typeface="SF Pro Text" charset="0"/>
-                        <a:cs typeface="SF Pro Text" charset="0"/>
-                      </a:endParaRPr>
-                    </a:p>
-                  </a:txBody>
-                  <a:tcPr marL="91440" marR="91440" marT="27432" marB="27432" anchor="ctr">
-                    <a:lnL w="9525" cap="flat" cmpd="sng" algn="ctr">
-                      <a:solidFill>
-                        <a:srgbClr val="DCE1E7"/>
-                      </a:solidFill>
-                      <a:prstDash val="solid"/>
-                      <a:round/>
-                      <a:headEnd type="none" w="med" len="med"/>
-                      <a:tailEnd type="none" w="med" len="med"/>
-                    </a:lnL>
-                    <a:lnR w="9525" cap="flat" cmpd="sng" algn="ctr">
-                      <a:solidFill>
-                        <a:srgbClr val="DCE1E7"/>
-                      </a:solidFill>
-                      <a:prstDash val="solid"/>
-                      <a:round/>
-                      <a:headEnd type="none" w="med" len="med"/>
-                      <a:tailEnd type="none" w="med" len="med"/>
-                    </a:lnR>
-                    <a:lnT w="9525" cap="flat" cmpd="sng" algn="ctr">
-                      <a:solidFill>
-                        <a:srgbClr val="DCE1E7"/>
-                      </a:solidFill>
-                      <a:prstDash val="solid"/>
-                      <a:round/>
-                      <a:headEnd type="none" w="med" len="med"/>
-                      <a:tailEnd type="none" w="med" len="med"/>
-                    </a:lnT>
-                    <a:lnB w="9525" cap="flat" cmpd="sng" algn="ctr">
-                      <a:solidFill>
-                        <a:srgbClr val="DCE1E7"/>
-                      </a:solidFill>
-                      <a:prstDash val="solid"/>
-                      <a:round/>
-                      <a:headEnd type="none" w="med" len="med"/>
-                      <a:tailEnd type="none" w="med" len="med"/>
-                    </a:lnB>
-                    <a:solidFill>
-                      <a:srgbClr val="FFFFFF"/>
-                    </a:solidFill>
-                  </a:tcPr>
-                </a:tc>
-                <a:tc>
-                  <a:txBody>
-                    <a:bodyPr/>
-                    <a:lstStyle/>
-                    <a:p>
-                      <a:pPr indent="0" marL="0">
-                        <a:buNone/>
-                      </a:pPr>
-                      <a:r>
-                        <a:rPr lang="en-US" sz="950" dirty="0">
-                          <a:solidFill>
-                            <a:srgbClr val="6E6E73"/>
-                          </a:solidFill>
-                          <a:latin typeface="SF Pro Text" pitchFamily="34" charset="0"/>
-                          <a:ea typeface="SF Pro Text" pitchFamily="34" charset="-122"/>
-                          <a:cs typeface="SF Pro Text" pitchFamily="34" charset="-120"/>
-                        </a:rPr>
-                        <a:t>cleaner</a:t>
-                      </a:r>
-                      <a:endParaRPr lang="en-US" sz="950" dirty="0">
-                        <a:latin typeface="SF Pro Text" charset="0"/>
-                        <a:ea typeface="SF Pro Text" charset="0"/>
-                        <a:cs typeface="SF Pro Text" charset="0"/>
-                      </a:endParaRPr>
-                    </a:p>
-                  </a:txBody>
-                  <a:tcPr marL="91440" marR="91440" marT="27432" marB="27432" anchor="ctr">
-                    <a:lnL w="9525" cap="flat" cmpd="sng" algn="ctr">
-                      <a:solidFill>
-                        <a:srgbClr val="DCE1E7"/>
-                      </a:solidFill>
-                      <a:prstDash val="solid"/>
-                      <a:round/>
-                      <a:headEnd type="none" w="med" len="med"/>
-                      <a:tailEnd type="none" w="med" len="med"/>
-                    </a:lnL>
-                    <a:lnR w="9525" cap="flat" cmpd="sng" algn="ctr">
-                      <a:solidFill>
-                        <a:srgbClr val="DCE1E7"/>
-                      </a:solidFill>
-                      <a:prstDash val="solid"/>
-                      <a:round/>
-                      <a:headEnd type="none" w="med" len="med"/>
-                      <a:tailEnd type="none" w="med" len="med"/>
-                    </a:lnR>
-                    <a:lnT w="9525" cap="flat" cmpd="sng" algn="ctr">
-                      <a:solidFill>
-                        <a:srgbClr val="DCE1E7"/>
-                      </a:solidFill>
-                      <a:prstDash val="solid"/>
-                      <a:round/>
-                      <a:headEnd type="none" w="med" len="med"/>
-                      <a:tailEnd type="none" w="med" len="med"/>
-                    </a:lnT>
-                    <a:lnB w="9525" cap="flat" cmpd="sng" algn="ctr">
-                      <a:solidFill>
-                        <a:srgbClr val="DCE1E7"/>
-                      </a:solidFill>
-                      <a:prstDash val="solid"/>
-                      <a:round/>
-                      <a:headEnd type="none" w="med" len="med"/>
-                      <a:tailEnd type="none" w="med" len="med"/>
-                    </a:lnB>
-                    <a:solidFill>
-                      <a:srgbClr val="FFFFFF"/>
-                    </a:solidFill>
-                  </a:tcPr>
-                </a:tc>
-                <a:tc>
-                  <a:txBody>
-                    <a:bodyPr/>
-                    <a:lstStyle/>
-                    <a:p>
-                      <a:pPr indent="0" marL="0">
-                        <a:buNone/>
-                      </a:pPr>
-                      <a:r>
-                        <a:rPr lang="en-US" sz="950" dirty="0">
-                          <a:solidFill>
-                            <a:srgbClr val="6E6E73"/>
-                          </a:solidFill>
-                          <a:latin typeface="SF Pro Text" pitchFamily="34" charset="0"/>
-                          <a:ea typeface="SF Pro Text" pitchFamily="34" charset="-122"/>
-                          <a:cs typeface="SF Pro Text" pitchFamily="34" charset="-120"/>
-                        </a:rPr>
-                        <a:t>reschedule</a:t>
-                      </a:r>
-                      <a:endParaRPr lang="en-US" sz="950" dirty="0">
-                        <a:latin typeface="SF Pro Text" charset="0"/>
-                        <a:ea typeface="SF Pro Text" charset="0"/>
-                        <a:cs typeface="SF Pro Text" charset="0"/>
-                      </a:endParaRPr>
-                    </a:p>
-                  </a:txBody>
-                  <a:tcPr marL="91440" marR="91440" marT="27432" marB="27432" anchor="ctr">
-                    <a:lnL w="9525" cap="flat" cmpd="sng" algn="ctr">
-                      <a:solidFill>
-                        <a:srgbClr val="DCE1E7"/>
-                      </a:solidFill>
-                      <a:prstDash val="solid"/>
-                      <a:round/>
-                      <a:headEnd type="none" w="med" len="med"/>
-                      <a:tailEnd type="none" w="med" len="med"/>
-                    </a:lnL>
-                    <a:lnR w="9525" cap="flat" cmpd="sng" algn="ctr">
-                      <a:solidFill>
-                        <a:srgbClr val="DCE1E7"/>
-                      </a:solidFill>
-                      <a:prstDash val="solid"/>
-                      <a:round/>
-                      <a:headEnd type="none" w="med" len="med"/>
-                      <a:tailEnd type="none" w="med" len="med"/>
-                    </a:lnR>
-                    <a:lnT w="9525" cap="flat" cmpd="sng" algn="ctr">
-                      <a:solidFill>
-                        <a:srgbClr val="DCE1E7"/>
-                      </a:solidFill>
-                      <a:prstDash val="solid"/>
-                      <a:round/>
-                      <a:headEnd type="none" w="med" len="med"/>
-                      <a:tailEnd type="none" w="med" len="med"/>
-                    </a:lnT>
-                    <a:lnB w="9525" cap="flat" cmpd="sng" algn="ctr">
-                      <a:solidFill>
-                        <a:srgbClr val="DCE1E7"/>
-                      </a:solidFill>
-                      <a:prstDash val="solid"/>
-                      <a:round/>
-                      <a:headEnd type="none" w="med" len="med"/>
-                      <a:tailEnd type="none" w="med" len="med"/>
-                    </a:lnB>
-                    <a:solidFill>
-                      <a:srgbClr val="FFFFFF"/>
-                    </a:solidFill>
-                  </a:tcPr>
-                </a:tc>
-                <a:tc>
-                  <a:txBody>
-                    <a:bodyPr/>
-                    <a:lstStyle/>
-                    <a:p>
-                      <a:pPr indent="0" marL="0">
-                        <a:buNone/>
-                      </a:pPr>
-                      <a:r>
-                        <a:rPr lang="en-US" sz="950" dirty="0">
-                          <a:solidFill>
-                            <a:srgbClr val="6E6E73"/>
-                          </a:solidFill>
-                          <a:latin typeface="SF Pro Text" pitchFamily="34" charset="0"/>
-                          <a:ea typeface="SF Pro Text" pitchFamily="34" charset="-122"/>
-                          <a:cs typeface="SF Pro Text" pitchFamily="34" charset="-120"/>
-                        </a:rPr>
-                        <a:t>Moved again, to Sep 24, 12:30 PM</a:t>
-                      </a:r>
-                      <a:endParaRPr lang="en-US" sz="950" dirty="0">
-                        <a:latin typeface="SF Pro Text" charset="0"/>
-                        <a:ea typeface="SF Pro Text" charset="0"/>
-                        <a:cs typeface="SF Pro Text" charset="0"/>
-                      </a:endParaRPr>
-                    </a:p>
-                  </a:txBody>
-                  <a:tcPr marL="91440" marR="91440" marT="27432" marB="27432" anchor="ctr">
-                    <a:lnL w="9525" cap="flat" cmpd="sng" algn="ctr">
-                      <a:solidFill>
-                        <a:srgbClr val="DCE1E7"/>
-                      </a:solidFill>
-                      <a:prstDash val="solid"/>
-                      <a:round/>
-                      <a:headEnd type="none" w="med" len="med"/>
-                      <a:tailEnd type="none" w="med" len="med"/>
-                    </a:lnL>
-                    <a:lnR w="9525" cap="flat" cmpd="sng" algn="ctr">
-                      <a:solidFill>
-                        <a:srgbClr val="DCE1E7"/>
-                      </a:solidFill>
-                      <a:prstDash val="solid"/>
-                      <a:round/>
-                      <a:headEnd type="none" w="med" len="med"/>
-                      <a:tailEnd type="none" w="med" len="med"/>
-                    </a:lnR>
-                    <a:lnT w="9525" cap="flat" cmpd="sng" algn="ctr">
-                      <a:solidFill>
-                        <a:srgbClr val="DCE1E7"/>
-                      </a:solidFill>
-                      <a:prstDash val="solid"/>
-                      <a:round/>
-                      <a:headEnd type="none" w="med" len="med"/>
-                      <a:tailEnd type="none" w="med" len="med"/>
-                    </a:lnT>
-                    <a:lnB w="9525" cap="flat" cmpd="sng" algn="ctr">
-                      <a:solidFill>
-                        <a:srgbClr val="DCE1E7"/>
-                      </a:solidFill>
-                      <a:prstDash val="solid"/>
-                      <a:round/>
-                      <a:headEnd type="none" w="med" len="med"/>
-                      <a:tailEnd type="none" w="med" len="med"/>
-                    </a:lnB>
-                    <a:solidFill>
-                      <a:srgbClr val="FFFFFF"/>
-                    </a:solidFill>
-                  </a:tcPr>
-                </a:tc>
-              </a:tr>
-              <a:tr h="329184">
-                <a:tc>
-                  <a:txBody>
-                    <a:bodyPr/>
-                    <a:lstStyle/>
-                    <a:p>
-                      <a:pPr indent="0" marL="0">
-                        <a:buNone/>
-                      </a:pPr>
-                      <a:r>
-                        <a:rPr lang="en-US" sz="950" b="1" dirty="0">
-                          <a:solidFill>
-                            <a:srgbClr val="1D1D1F"/>
-                          </a:solidFill>
-                          <a:latin typeface="SF Pro Text" pitchFamily="34" charset="0"/>
-                          <a:ea typeface="SF Pro Text" pitchFamily="34" charset="-122"/>
-                          <a:cs typeface="SF Pro Text" pitchFamily="34" charset="-120"/>
-                        </a:rPr>
-                        <a:t>5</a:t>
-                      </a:r>
-                      <a:endParaRPr lang="en-US" sz="950" dirty="0">
-                        <a:latin typeface="SF Pro Text" charset="0"/>
-                        <a:ea typeface="SF Pro Text" charset="0"/>
-                        <a:cs typeface="SF Pro Text" charset="0"/>
-                      </a:endParaRPr>
-                    </a:p>
-                  </a:txBody>
-                  <a:tcPr marL="91440" marR="91440" marT="27432" marB="27432" anchor="ctr">
-                    <a:lnL w="9525" cap="flat" cmpd="sng" algn="ctr">
-                      <a:solidFill>
-                        <a:srgbClr val="DCE1E7"/>
-                      </a:solidFill>
-                      <a:prstDash val="solid"/>
-                      <a:round/>
-                      <a:headEnd type="none" w="med" len="med"/>
-                      <a:tailEnd type="none" w="med" len="med"/>
-                    </a:lnL>
-                    <a:lnR w="9525" cap="flat" cmpd="sng" algn="ctr">
-                      <a:solidFill>
-                        <a:srgbClr val="DCE1E7"/>
-                      </a:solidFill>
-                      <a:prstDash val="solid"/>
-                      <a:round/>
-                      <a:headEnd type="none" w="med" len="med"/>
-                      <a:tailEnd type="none" w="med" len="med"/>
-                    </a:lnR>
-                    <a:lnT w="9525" cap="flat" cmpd="sng" algn="ctr">
-                      <a:solidFill>
-                        <a:srgbClr val="DCE1E7"/>
-                      </a:solidFill>
-                      <a:prstDash val="solid"/>
-                      <a:round/>
-                      <a:headEnd type="none" w="med" len="med"/>
-                      <a:tailEnd type="none" w="med" len="med"/>
-                    </a:lnT>
-                    <a:lnB w="9525" cap="flat" cmpd="sng" algn="ctr">
-                      <a:solidFill>
-                        <a:srgbClr val="DCE1E7"/>
-                      </a:solidFill>
-                      <a:prstDash val="solid"/>
-                      <a:round/>
-                      <a:headEnd type="none" w="med" len="med"/>
-                      <a:tailEnd type="none" w="med" len="med"/>
-                    </a:lnB>
-                    <a:solidFill>
-                      <a:srgbClr val="FFFFFF"/>
-                    </a:solidFill>
-                  </a:tcPr>
-                </a:tc>
-                <a:tc>
-                  <a:txBody>
-                    <a:bodyPr/>
-                    <a:lstStyle/>
-                    <a:p>
-                      <a:pPr indent="0" marL="0">
-                        <a:buNone/>
-                      </a:pPr>
-                      <a:r>
-                        <a:rPr lang="en-US" sz="950" dirty="0">
-                          <a:solidFill>
-                            <a:srgbClr val="6E6E73"/>
-                          </a:solidFill>
-                          <a:latin typeface="SF Pro Text" pitchFamily="34" charset="0"/>
-                          <a:ea typeface="SF Pro Text" pitchFamily="34" charset="-122"/>
-                          <a:cs typeface="SF Pro Text" pitchFamily="34" charset="-120"/>
-                        </a:rPr>
-                        <a:t>Sep 24, 4:09 PM</a:t>
-                      </a:r>
-                      <a:endParaRPr lang="en-US" sz="950" dirty="0">
-                        <a:latin typeface="SF Pro Text" charset="0"/>
-                        <a:ea typeface="SF Pro Text" charset="0"/>
-                        <a:cs typeface="SF Pro Text" charset="0"/>
-                      </a:endParaRPr>
-                    </a:p>
-                  </a:txBody>
-                  <a:tcPr marL="91440" marR="91440" marT="27432" marB="27432" anchor="ctr">
-                    <a:lnL w="9525" cap="flat" cmpd="sng" algn="ctr">
-                      <a:solidFill>
-                        <a:srgbClr val="DCE1E7"/>
-                      </a:solidFill>
-                      <a:prstDash val="solid"/>
-                      <a:round/>
-                      <a:headEnd type="none" w="med" len="med"/>
-                      <a:tailEnd type="none" w="med" len="med"/>
-                    </a:lnL>
-                    <a:lnR w="9525" cap="flat" cmpd="sng" algn="ctr">
-                      <a:solidFill>
-                        <a:srgbClr val="DCE1E7"/>
-                      </a:solidFill>
-                      <a:prstDash val="solid"/>
-                      <a:round/>
-                      <a:headEnd type="none" w="med" len="med"/>
-                      <a:tailEnd type="none" w="med" len="med"/>
-                    </a:lnR>
-                    <a:lnT w="9525" cap="flat" cmpd="sng" algn="ctr">
-                      <a:solidFill>
-                        <a:srgbClr val="DCE1E7"/>
-                      </a:solidFill>
-                      <a:prstDash val="solid"/>
-                      <a:round/>
-                      <a:headEnd type="none" w="med" len="med"/>
-                      <a:tailEnd type="none" w="med" len="med"/>
-                    </a:lnT>
-                    <a:lnB w="9525" cap="flat" cmpd="sng" algn="ctr">
-                      <a:solidFill>
-                        <a:srgbClr val="DCE1E7"/>
-                      </a:solidFill>
-                      <a:prstDash val="solid"/>
-                      <a:round/>
-                      <a:headEnd type="none" w="med" len="med"/>
-                      <a:tailEnd type="none" w="med" len="med"/>
-                    </a:lnB>
-                    <a:solidFill>
-                      <a:srgbClr val="FFFFFF"/>
-                    </a:solidFill>
-                  </a:tcPr>
-                </a:tc>
-                <a:tc>
-                  <a:txBody>
-                    <a:bodyPr/>
-                    <a:lstStyle/>
-                    <a:p>
-                      <a:pPr indent="0" marL="0">
-                        <a:buNone/>
-                      </a:pPr>
-                      <a:r>
-                        <a:rPr lang="en-US" sz="950" dirty="0">
-                          <a:solidFill>
-                            <a:srgbClr val="6E6E73"/>
-                          </a:solidFill>
-                          <a:latin typeface="SF Pro Text" pitchFamily="34" charset="0"/>
-                          <a:ea typeface="SF Pro Text" pitchFamily="34" charset="-122"/>
-                          <a:cs typeface="SF Pro Text" pitchFamily="34" charset="-120"/>
-                        </a:rPr>
-                        <a:t>cleaner</a:t>
-                      </a:r>
-                      <a:endParaRPr lang="en-US" sz="950" dirty="0">
-                        <a:latin typeface="SF Pro Text" charset="0"/>
-                        <a:ea typeface="SF Pro Text" charset="0"/>
-                        <a:cs typeface="SF Pro Text" charset="0"/>
-                      </a:endParaRPr>
-                    </a:p>
-                  </a:txBody>
-                  <a:tcPr marL="91440" marR="91440" marT="27432" marB="27432" anchor="ctr">
-                    <a:lnL w="9525" cap="flat" cmpd="sng" algn="ctr">
-                      <a:solidFill>
-                        <a:srgbClr val="DCE1E7"/>
-                      </a:solidFill>
-                      <a:prstDash val="solid"/>
-                      <a:round/>
-                      <a:headEnd type="none" w="med" len="med"/>
-                      <a:tailEnd type="none" w="med" len="med"/>
-                    </a:lnL>
-                    <a:lnR w="9525" cap="flat" cmpd="sng" algn="ctr">
-                      <a:solidFill>
-                        <a:srgbClr val="DCE1E7"/>
-                      </a:solidFill>
-                      <a:prstDash val="solid"/>
-                      <a:round/>
-                      <a:headEnd type="none" w="med" len="med"/>
-                      <a:tailEnd type="none" w="med" len="med"/>
-                    </a:lnR>
-                    <a:lnT w="9525" cap="flat" cmpd="sng" algn="ctr">
-                      <a:solidFill>
-                        <a:srgbClr val="DCE1E7"/>
-                      </a:solidFill>
-                      <a:prstDash val="solid"/>
-                      <a:round/>
-                      <a:headEnd type="none" w="med" len="med"/>
-                      <a:tailEnd type="none" w="med" len="med"/>
-                    </a:lnT>
-                    <a:lnB w="9525" cap="flat" cmpd="sng" algn="ctr">
-                      <a:solidFill>
-                        <a:srgbClr val="DCE1E7"/>
-                      </a:solidFill>
-                      <a:prstDash val="solid"/>
-                      <a:round/>
-                      <a:headEnd type="none" w="med" len="med"/>
-                      <a:tailEnd type="none" w="med" len="med"/>
-                    </a:lnB>
-                    <a:solidFill>
-                      <a:srgbClr val="FFFFFF"/>
-                    </a:solidFill>
-                  </a:tcPr>
-                </a:tc>
-                <a:tc>
-                  <a:txBody>
-                    <a:bodyPr/>
-                    <a:lstStyle/>
-                    <a:p>
-                      <a:pPr indent="0" marL="0">
-                        <a:buNone/>
-                      </a:pPr>
-                      <a:r>
-                        <a:rPr lang="en-US" sz="950" dirty="0">
-                          <a:solidFill>
-                            <a:srgbClr val="6E6E73"/>
-                          </a:solidFill>
-                          <a:latin typeface="SF Pro Text" pitchFamily="34" charset="0"/>
-                          <a:ea typeface="SF Pro Text" pitchFamily="34" charset="-122"/>
-                          <a:cs typeface="SF Pro Text" pitchFamily="34" charset="-120"/>
-                        </a:rPr>
-                        <a:t>invoice</a:t>
-                      </a:r>
-                      <a:endParaRPr lang="en-US" sz="950" dirty="0">
-                        <a:latin typeface="SF Pro Text" charset="0"/>
-                        <a:ea typeface="SF Pro Text" charset="0"/>
-                        <a:cs typeface="SF Pro Text" charset="0"/>
-                      </a:endParaRPr>
-                    </a:p>
-                  </a:txBody>
-                  <a:tcPr marL="91440" marR="91440" marT="27432" marB="27432" anchor="ctr">
-                    <a:lnL w="9525" cap="flat" cmpd="sng" algn="ctr">
-                      <a:solidFill>
-                        <a:srgbClr val="DCE1E7"/>
-                      </a:solidFill>
-                      <a:prstDash val="solid"/>
-                      <a:round/>
-                      <a:headEnd type="none" w="med" len="med"/>
-                      <a:tailEnd type="none" w="med" len="med"/>
-                    </a:lnL>
-                    <a:lnR w="9525" cap="flat" cmpd="sng" algn="ctr">
-                      <a:solidFill>
-                        <a:srgbClr val="DCE1E7"/>
-                      </a:solidFill>
-                      <a:prstDash val="solid"/>
-                      <a:round/>
-                      <a:headEnd type="none" w="med" len="med"/>
-                      <a:tailEnd type="none" w="med" len="med"/>
-                    </a:lnR>
-                    <a:lnT w="9525" cap="flat" cmpd="sng" algn="ctr">
-                      <a:solidFill>
-                        <a:srgbClr val="DCE1E7"/>
-                      </a:solidFill>
-                      <a:prstDash val="solid"/>
-                      <a:round/>
-                      <a:headEnd type="none" w="med" len="med"/>
-                      <a:tailEnd type="none" w="med" len="med"/>
-                    </a:lnT>
-                    <a:lnB w="9525" cap="flat" cmpd="sng" algn="ctr">
-                      <a:solidFill>
-                        <a:srgbClr val="DCE1E7"/>
-                      </a:solidFill>
-                      <a:prstDash val="solid"/>
-                      <a:round/>
-                      <a:headEnd type="none" w="med" len="med"/>
-                      <a:tailEnd type="none" w="med" len="med"/>
-                    </a:lnB>
-                    <a:solidFill>
-                      <a:srgbClr val="FFFFFF"/>
-                    </a:solidFill>
-                  </a:tcPr>
-                </a:tc>
-                <a:tc>
-                  <a:txBody>
-                    <a:bodyPr/>
-                    <a:lstStyle/>
-                    <a:p>
-                      <a:pPr indent="0" marL="0">
-                        <a:buNone/>
-                      </a:pPr>
-                      <a:r>
-                        <a:rPr lang="en-US" sz="950" dirty="0">
-                          <a:solidFill>
-                            <a:srgbClr val="6E6E73"/>
-                          </a:solidFill>
-                          <a:latin typeface="SF Pro Text" pitchFamily="34" charset="0"/>
-                          <a:ea typeface="SF Pro Text" pitchFamily="34" charset="-122"/>
-                          <a:cs typeface="SF Pro Text" pitchFamily="34" charset="-120"/>
-                        </a:rPr>
-                        <a:t>Invoiced, from Pending Invoice</a:t>
-                      </a:r>
-                      <a:endParaRPr lang="en-US" sz="950" dirty="0">
-                        <a:latin typeface="SF Pro Text" charset="0"/>
-                        <a:ea typeface="SF Pro Text" charset="0"/>
-                        <a:cs typeface="SF Pro Text" charset="0"/>
-                      </a:endParaRPr>
-                    </a:p>
-                  </a:txBody>
-                  <a:tcPr marL="91440" marR="91440" marT="27432" marB="27432" anchor="ctr">
-                    <a:lnL w="9525" cap="flat" cmpd="sng" algn="ctr">
-                      <a:solidFill>
-                        <a:srgbClr val="DCE1E7"/>
-                      </a:solidFill>
-                      <a:prstDash val="solid"/>
-                      <a:round/>
-                      <a:headEnd type="none" w="med" len="med"/>
-                      <a:tailEnd type="none" w="med" len="med"/>
-                    </a:lnL>
-                    <a:lnR w="9525" cap="flat" cmpd="sng" algn="ctr">
-                      <a:solidFill>
-                        <a:srgbClr val="DCE1E7"/>
-                      </a:solidFill>
-                      <a:prstDash val="solid"/>
-                      <a:round/>
-                      <a:headEnd type="none" w="med" len="med"/>
-                      <a:tailEnd type="none" w="med" len="med"/>
-                    </a:lnR>
-                    <a:lnT w="9525" cap="flat" cmpd="sng" algn="ctr">
-                      <a:solidFill>
-                        <a:srgbClr val="DCE1E7"/>
-                      </a:solidFill>
-                      <a:prstDash val="solid"/>
-                      <a:round/>
-                      <a:headEnd type="none" w="med" len="med"/>
-                      <a:tailEnd type="none" w="med" len="med"/>
-                    </a:lnT>
-                    <a:lnB w="9525" cap="flat" cmpd="sng" algn="ctr">
-                      <a:solidFill>
-                        <a:srgbClr val="DCE1E7"/>
-                      </a:solidFill>
-                      <a:prstDash val="solid"/>
-                      <a:round/>
-                      <a:headEnd type="none" w="med" len="med"/>
-                      <a:tailEnd type="none" w="med" len="med"/>
-                    </a:lnB>
-                    <a:solidFill>
-                      <a:srgbClr val="FFFFFF"/>
-                    </a:solidFill>
-                  </a:tcPr>
-                </a:tc>
-              </a:tr>
-              <a:tr h="329184">
-                <a:tc>
-                  <a:txBody>
-                    <a:bodyPr/>
-                    <a:lstStyle/>
-                    <a:p>
-                      <a:pPr indent="0" marL="0">
-                        <a:buNone/>
-                      </a:pPr>
-                      <a:r>
-                        <a:rPr lang="en-US" sz="950" b="1" dirty="0">
-                          <a:solidFill>
-                            <a:srgbClr val="1D1D1F"/>
-                          </a:solidFill>
-                          <a:latin typeface="SF Pro Text" pitchFamily="34" charset="0"/>
-                          <a:ea typeface="SF Pro Text" pitchFamily="34" charset="-122"/>
-                          <a:cs typeface="SF Pro Text" pitchFamily="34" charset="-120"/>
-                        </a:rPr>
-                        <a:t>6</a:t>
-                      </a:r>
-                      <a:endParaRPr lang="en-US" sz="950" dirty="0">
-                        <a:latin typeface="SF Pro Text" charset="0"/>
-                        <a:ea typeface="SF Pro Text" charset="0"/>
-                        <a:cs typeface="SF Pro Text" charset="0"/>
-                      </a:endParaRPr>
-                    </a:p>
-                  </a:txBody>
-                  <a:tcPr marL="91440" marR="91440" marT="27432" marB="27432" anchor="ctr">
-                    <a:lnL w="9525" cap="flat" cmpd="sng" algn="ctr">
-                      <a:solidFill>
-                        <a:srgbClr val="DCE1E7"/>
-                      </a:solidFill>
-                      <a:prstDash val="solid"/>
-                      <a:round/>
-                      <a:headEnd type="none" w="med" len="med"/>
-                      <a:tailEnd type="none" w="med" len="med"/>
-                    </a:lnL>
-                    <a:lnR w="9525" cap="flat" cmpd="sng" algn="ctr">
-                      <a:solidFill>
-                        <a:srgbClr val="DCE1E7"/>
-                      </a:solidFill>
-                      <a:prstDash val="solid"/>
-                      <a:round/>
-                      <a:headEnd type="none" w="med" len="med"/>
-                      <a:tailEnd type="none" w="med" len="med"/>
-                    </a:lnR>
-                    <a:lnT w="9525" cap="flat" cmpd="sng" algn="ctr">
-                      <a:solidFill>
-                        <a:srgbClr val="DCE1E7"/>
-                      </a:solidFill>
-                      <a:prstDash val="solid"/>
-                      <a:round/>
-                      <a:headEnd type="none" w="med" len="med"/>
-                      <a:tailEnd type="none" w="med" len="med"/>
-                    </a:lnT>
-                    <a:lnB w="9525" cap="flat" cmpd="sng" algn="ctr">
-                      <a:solidFill>
-                        <a:srgbClr val="DCE1E7"/>
-                      </a:solidFill>
-                      <a:prstDash val="solid"/>
-                      <a:round/>
-                      <a:headEnd type="none" w="med" len="med"/>
-                      <a:tailEnd type="none" w="med" len="med"/>
-                    </a:lnB>
-                    <a:solidFill>
-                      <a:srgbClr val="FFFFFF"/>
-                    </a:solidFill>
-                  </a:tcPr>
-                </a:tc>
-                <a:tc>
-                  <a:txBody>
-                    <a:bodyPr/>
-                    <a:lstStyle/>
-                    <a:p>
-                      <a:pPr indent="0" marL="0">
-                        <a:buNone/>
-                      </a:pPr>
-                      <a:r>
-                        <a:rPr lang="en-US" sz="950" dirty="0">
-                          <a:solidFill>
-                            <a:srgbClr val="6E6E73"/>
-                          </a:solidFill>
-                          <a:latin typeface="SF Pro Text" pitchFamily="34" charset="0"/>
-                          <a:ea typeface="SF Pro Text" pitchFamily="34" charset="-122"/>
-                          <a:cs typeface="SF Pro Text" pitchFamily="34" charset="-120"/>
-                        </a:rPr>
-                        <a:t>Sep 24, 4:09 PM</a:t>
-                      </a:r>
-                      <a:endParaRPr lang="en-US" sz="950" dirty="0">
-                        <a:latin typeface="SF Pro Text" charset="0"/>
-                        <a:ea typeface="SF Pro Text" charset="0"/>
-                        <a:cs typeface="SF Pro Text" charset="0"/>
-                      </a:endParaRPr>
-                    </a:p>
-                  </a:txBody>
-                  <a:tcPr marL="91440" marR="91440" marT="27432" marB="27432" anchor="ctr">
-                    <a:lnL w="9525" cap="flat" cmpd="sng" algn="ctr">
-                      <a:solidFill>
-                        <a:srgbClr val="DCE1E7"/>
-                      </a:solidFill>
-                      <a:prstDash val="solid"/>
-                      <a:round/>
-                      <a:headEnd type="none" w="med" len="med"/>
-                      <a:tailEnd type="none" w="med" len="med"/>
-                    </a:lnL>
-                    <a:lnR w="9525" cap="flat" cmpd="sng" algn="ctr">
-                      <a:solidFill>
-                        <a:srgbClr val="DCE1E7"/>
-                      </a:solidFill>
-                      <a:prstDash val="solid"/>
-                      <a:round/>
-                      <a:headEnd type="none" w="med" len="med"/>
-                      <a:tailEnd type="none" w="med" len="med"/>
-                    </a:lnR>
-                    <a:lnT w="9525" cap="flat" cmpd="sng" algn="ctr">
-                      <a:solidFill>
-                        <a:srgbClr val="DCE1E7"/>
-                      </a:solidFill>
-                      <a:prstDash val="solid"/>
-                      <a:round/>
-                      <a:headEnd type="none" w="med" len="med"/>
-                      <a:tailEnd type="none" w="med" len="med"/>
-                    </a:lnT>
-                    <a:lnB w="9525" cap="flat" cmpd="sng" algn="ctr">
-                      <a:solidFill>
-                        <a:srgbClr val="DCE1E7"/>
-                      </a:solidFill>
-                      <a:prstDash val="solid"/>
-                      <a:round/>
-                      <a:headEnd type="none" w="med" len="med"/>
-                      <a:tailEnd type="none" w="med" len="med"/>
-                    </a:lnB>
-                    <a:solidFill>
-                      <a:srgbClr val="FFFFFF"/>
-                    </a:solidFill>
-                  </a:tcPr>
-                </a:tc>
-                <a:tc>
-                  <a:txBody>
-                    <a:bodyPr/>
-                    <a:lstStyle/>
-                    <a:p>
-                      <a:pPr indent="0" marL="0">
-                        <a:buNone/>
-                      </a:pPr>
-                      <a:r>
-                        <a:rPr lang="en-US" sz="950" dirty="0">
-                          <a:solidFill>
-                            <a:srgbClr val="6E6E73"/>
-                          </a:solidFill>
-                          <a:latin typeface="SF Pro Text" pitchFamily="34" charset="0"/>
-                          <a:ea typeface="SF Pro Text" pitchFamily="34" charset="-122"/>
-                          <a:cs typeface="SF Pro Text" pitchFamily="34" charset="-120"/>
-                        </a:rPr>
-                        <a:t>system</a:t>
-                      </a:r>
-                      <a:endParaRPr lang="en-US" sz="950" dirty="0">
-                        <a:latin typeface="SF Pro Text" charset="0"/>
-                        <a:ea typeface="SF Pro Text" charset="0"/>
-                        <a:cs typeface="SF Pro Text" charset="0"/>
-                      </a:endParaRPr>
-                    </a:p>
-                  </a:txBody>
-                  <a:tcPr marL="91440" marR="91440" marT="27432" marB="27432" anchor="ctr">
-                    <a:lnL w="9525" cap="flat" cmpd="sng" algn="ctr">
-                      <a:solidFill>
-                        <a:srgbClr val="DCE1E7"/>
-                      </a:solidFill>
-                      <a:prstDash val="solid"/>
-                      <a:round/>
-                      <a:headEnd type="none" w="med" len="med"/>
-                      <a:tailEnd type="none" w="med" len="med"/>
-                    </a:lnL>
-                    <a:lnR w="9525" cap="flat" cmpd="sng" algn="ctr">
-                      <a:solidFill>
-                        <a:srgbClr val="DCE1E7"/>
-                      </a:solidFill>
-                      <a:prstDash val="solid"/>
-                      <a:round/>
-                      <a:headEnd type="none" w="med" len="med"/>
-                      <a:tailEnd type="none" w="med" len="med"/>
-                    </a:lnR>
-                    <a:lnT w="9525" cap="flat" cmpd="sng" algn="ctr">
-                      <a:solidFill>
-                        <a:srgbClr val="DCE1E7"/>
-                      </a:solidFill>
-                      <a:prstDash val="solid"/>
-                      <a:round/>
-                      <a:headEnd type="none" w="med" len="med"/>
-                      <a:tailEnd type="none" w="med" len="med"/>
-                    </a:lnT>
-                    <a:lnB w="9525" cap="flat" cmpd="sng" algn="ctr">
-                      <a:solidFill>
-                        <a:srgbClr val="DCE1E7"/>
-                      </a:solidFill>
-                      <a:prstDash val="solid"/>
-                      <a:round/>
-                      <a:headEnd type="none" w="med" len="med"/>
-                      <a:tailEnd type="none" w="med" len="med"/>
-                    </a:lnB>
-                    <a:solidFill>
-                      <a:srgbClr val="FFFFFF"/>
-                    </a:solidFill>
-                  </a:tcPr>
-                </a:tc>
-                <a:tc>
-                  <a:txBody>
-                    <a:bodyPr/>
-                    <a:lstStyle/>
-                    <a:p>
-                      <a:pPr indent="0" marL="0">
-                        <a:buNone/>
-                      </a:pPr>
-                      <a:r>
-                        <a:rPr lang="en-US" sz="950" dirty="0">
-                          <a:solidFill>
-                            <a:srgbClr val="6E6E73"/>
-                          </a:solidFill>
-                          <a:latin typeface="SF Pro Text" pitchFamily="34" charset="0"/>
-                          <a:ea typeface="SF Pro Text" pitchFamily="34" charset="-122"/>
-                          <a:cs typeface="SF Pro Text" pitchFamily="34" charset="-120"/>
-                        </a:rPr>
-                        <a:t>log_snapshot_on_invoice</a:t>
-                      </a:r>
-                      <a:endParaRPr lang="en-US" sz="950" dirty="0">
-                        <a:latin typeface="SF Pro Text" charset="0"/>
-                        <a:ea typeface="SF Pro Text" charset="0"/>
-                        <a:cs typeface="SF Pro Text" charset="0"/>
-                      </a:endParaRPr>
-                    </a:p>
-                  </a:txBody>
-                  <a:tcPr marL="91440" marR="91440" marT="27432" marB="27432" anchor="ctr">
-                    <a:lnL w="9525" cap="flat" cmpd="sng" algn="ctr">
-                      <a:solidFill>
-                        <a:srgbClr val="DCE1E7"/>
-                      </a:solidFill>
-                      <a:prstDash val="solid"/>
-                      <a:round/>
-                      <a:headEnd type="none" w="med" len="med"/>
-                      <a:tailEnd type="none" w="med" len="med"/>
-                    </a:lnL>
-                    <a:lnR w="9525" cap="flat" cmpd="sng" algn="ctr">
-                      <a:solidFill>
-                        <a:srgbClr val="DCE1E7"/>
-                      </a:solidFill>
-                      <a:prstDash val="solid"/>
-                      <a:round/>
-                      <a:headEnd type="none" w="med" len="med"/>
-                      <a:tailEnd type="none" w="med" len="med"/>
-                    </a:lnR>
-                    <a:lnT w="9525" cap="flat" cmpd="sng" algn="ctr">
-                      <a:solidFill>
-                        <a:srgbClr val="DCE1E7"/>
-                      </a:solidFill>
-                      <a:prstDash val="solid"/>
-                      <a:round/>
-                      <a:headEnd type="none" w="med" len="med"/>
-                      <a:tailEnd type="none" w="med" len="med"/>
-                    </a:lnT>
-                    <a:lnB w="9525" cap="flat" cmpd="sng" algn="ctr">
-                      <a:solidFill>
-                        <a:srgbClr val="DCE1E7"/>
-                      </a:solidFill>
-                      <a:prstDash val="solid"/>
-                      <a:round/>
-                      <a:headEnd type="none" w="med" len="med"/>
-                      <a:tailEnd type="none" w="med" len="med"/>
-                    </a:lnB>
-                    <a:solidFill>
-                      <a:srgbClr val="FFFFFF"/>
-                    </a:solidFill>
-                  </a:tcPr>
-                </a:tc>
-                <a:tc>
-                  <a:txBody>
-                    <a:bodyPr/>
-                    <a:lstStyle/>
-                    <a:p>
-                      <a:pPr indent="0" marL="0">
-                        <a:buNone/>
-                      </a:pPr>
-                      <a:r>
-                        <a:rPr lang="en-US" sz="950" dirty="0">
-                          <a:solidFill>
-                            <a:srgbClr val="6E6E73"/>
-                          </a:solidFill>
-                          <a:latin typeface="SF Pro Text" pitchFamily="34" charset="0"/>
-                          <a:ea typeface="SF Pro Text" pitchFamily="34" charset="-122"/>
-                          <a:cs typeface="SF Pro Text" pitchFamily="34" charset="-120"/>
-                        </a:rPr>
-                        <a:t>The system logged the invoice</a:t>
-                      </a:r>
-                      <a:endParaRPr lang="en-US" sz="950" dirty="0">
-                        <a:latin typeface="SF Pro Text" charset="0"/>
-                        <a:ea typeface="SF Pro Text" charset="0"/>
-                        <a:cs typeface="SF Pro Text" charset="0"/>
-                      </a:endParaRPr>
-                    </a:p>
-                  </a:txBody>
-                  <a:tcPr marL="91440" marR="91440" marT="27432" marB="27432" anchor="ctr">
-                    <a:lnL w="9525" cap="flat" cmpd="sng" algn="ctr">
-                      <a:solidFill>
-                        <a:srgbClr val="DCE1E7"/>
-                      </a:solidFill>
-                      <a:prstDash val="solid"/>
-                      <a:round/>
-                      <a:headEnd type="none" w="med" len="med"/>
-                      <a:tailEnd type="none" w="med" len="med"/>
-                    </a:lnL>
-                    <a:lnR w="9525" cap="flat" cmpd="sng" algn="ctr">
-                      <a:solidFill>
-                        <a:srgbClr val="DCE1E7"/>
-                      </a:solidFill>
-                      <a:prstDash val="solid"/>
-                      <a:round/>
-                      <a:headEnd type="none" w="med" len="med"/>
-                      <a:tailEnd type="none" w="med" len="med"/>
-                    </a:lnR>
-                    <a:lnT w="9525" cap="flat" cmpd="sng" algn="ctr">
-                      <a:solidFill>
-                        <a:srgbClr val="DCE1E7"/>
-                      </a:solidFill>
-                      <a:prstDash val="solid"/>
-                      <a:round/>
-                      <a:headEnd type="none" w="med" len="med"/>
-                      <a:tailEnd type="none" w="med" len="med"/>
-                    </a:lnT>
-                    <a:lnB w="9525" cap="flat" cmpd="sng" algn="ctr">
-                      <a:solidFill>
-                        <a:srgbClr val="DCE1E7"/>
-                      </a:solidFill>
-                      <a:prstDash val="solid"/>
-                      <a:round/>
-                      <a:headEnd type="none" w="med" len="med"/>
-                      <a:tailEnd type="none" w="med" len="med"/>
-                    </a:lnB>
-                    <a:solidFill>
-                      <a:srgbClr val="FFFFFF"/>
-                    </a:solidFill>
-                  </a:tcPr>
-                </a:tc>
-              </a:tr>
-            </a:tbl>
-          </a:graphicData>
-        </a:graphic>
-      </p:graphicFrame>
-      <p:sp>
-        <p:nvSpPr>
-          <p:cNvPr id="7" name="Shape 3"/>
+      <p:sp>
+        <p:nvSpPr>
+          <p:cNvPr id="6" name="Shape 3"/>
           <p:cNvSpPr/>
           <p:nvPr/>
         </p:nvSpPr>
         <p:spPr>
           <a:xfrm>
-            <a:off x="411480" y="3703320"/>
-            <a:ext cx="8321040" cy="594360"/>
+            <a:off x="411480" y="1188720"/>
+            <a:ext cx="5257800" cy="2651760"/>
           </a:xfrm>
           <a:prstGeom prst="roundRect">
             <a:avLst>
-              <a:gd name="adj" fmla="val 12308"/>
+              <a:gd name="adj" fmla="val 2759"/>
+            </a:avLst>
+          </a:prstGeom>
+          <a:solidFill>
+            <a:srgbClr val="FFFFFF"/>
+          </a:solidFill>
+          <a:ln w="9525">
+            <a:solidFill>
+              <a:srgbClr val="DCE1E7"/>
+            </a:solidFill>
+            <a:prstDash val="solid"/>
+          </a:ln>
+        </p:spPr>
+      </p:sp>
+      <p:pic>
+        <p:nvPicPr>
+          <p:cNvPr id="7" name="Image 0" descr="/tmp/claude-0/-workspace-training/3ce5cff6-cccf-5f33-b0ee-0b147a55120e/scratchpad/img3/jh_table.png">    </p:cNvPr>
+          <p:cNvPicPr>
+            <a:picLocks noChangeAspect="1"/>
+          </p:cNvPicPr>
+          <p:nvPr/>
+        </p:nvPicPr>
+        <p:blipFill>
+          <a:blip r:embed="rId1"/>
+          <a:stretch>
+            <a:fillRect/>
+          </a:stretch>
+        </p:blipFill>
+        <p:spPr>
+          <a:xfrm>
+            <a:off x="484632" y="1298989"/>
+            <a:ext cx="5111496" cy="2431222"/>
+          </a:xfrm>
+          <a:prstGeom prst="rect">
+            <a:avLst/>
+          </a:prstGeom>
+        </p:spPr>
+      </p:pic>
+      <p:pic>
+        <p:nvPicPr>
+          <p:cNvPr id="8" name="Image 1" descr="preencoded.png">    </p:cNvPr>
+          <p:cNvPicPr>
+            <a:picLocks noChangeAspect="1"/>
+          </p:cNvPicPr>
+          <p:nvPr/>
+        </p:nvPicPr>
+        <p:blipFill>
+          <a:blip r:embed="rId2"/>
+          <a:stretch>
+            <a:fillRect/>
+          </a:stretch>
+        </p:blipFill>
+        <p:spPr>
+          <a:xfrm>
+            <a:off x="502920" y="3931920"/>
+            <a:ext cx="182880" cy="182880"/>
+          </a:xfrm>
+          <a:prstGeom prst="rect">
+            <a:avLst/>
+          </a:prstGeom>
+        </p:spPr>
+      </p:pic>
+      <p:sp>
+        <p:nvSpPr>
+          <p:cNvPr id="9" name="Text 4"/>
+          <p:cNvSpPr txBox="1"/>
+          <p:nvPr/>
+        </p:nvSpPr>
+        <p:spPr>
+          <a:xfrm>
+            <a:off x="731520" y="3904488"/>
+            <a:ext cx="2743200" cy="237744"/>
+          </a:xfrm>
+          <a:prstGeom prst="rect">
+            <a:avLst/>
+          </a:prstGeom>
+          <a:noFill/>
+          <a:ln/>
+        </p:spPr>
+        <p:txBody>
+          <a:bodyPr wrap="square" lIns="0" tIns="0" rIns="0" bIns="0" rtlCol="0" anchor="ctr"/>
+          <a:lstStyle/>
+          <a:p>
+            <a:pPr indent="0" marL="0">
+              <a:buNone/>
+            </a:pPr>
+            <a:r>
+              <a:rPr lang="en-US" sz="950" b="1" dirty="0">
+                <a:solidFill>
+                  <a:srgbClr val="0B7A6F"/>
+                </a:solidFill>
+                <a:latin typeface="SF Pro Text" pitchFamily="34" charset="0"/>
+                <a:ea typeface="SF Pro Text" pitchFamily="34" charset="-122"/>
+                <a:cs typeface="SF Pro Text" pitchFamily="34" charset="-120"/>
+              </a:rPr>
+              <a:t>Read bottom to top</a:t>
+            </a:r>
+            <a:endParaRPr lang="en-US" sz="950" dirty="0"/>
+          </a:p>
+        </p:txBody>
+      </p:sp>
+      <p:sp>
+        <p:nvSpPr>
+          <p:cNvPr id="10" name="Shape 5"/>
+          <p:cNvSpPr/>
+          <p:nvPr/>
+        </p:nvSpPr>
+        <p:spPr>
+          <a:xfrm>
+            <a:off x="5806440" y="1188720"/>
+            <a:ext cx="2926080" cy="457200"/>
+          </a:xfrm>
+          <a:prstGeom prst="roundRect">
+            <a:avLst>
+              <a:gd name="adj" fmla="val 20000"/>
+            </a:avLst>
+          </a:prstGeom>
+          <a:solidFill>
+            <a:srgbClr val="0B7A6F"/>
+          </a:solidFill>
+          <a:ln w="12700">
+            <a:solidFill>
+              <a:srgbClr val="0B7A6F"/>
+            </a:solidFill>
+            <a:prstDash val="solid"/>
+          </a:ln>
+        </p:spPr>
+      </p:sp>
+      <p:pic>
+        <p:nvPicPr>
+          <p:cNvPr id="11" name="Image 2" descr="preencoded.png">    </p:cNvPr>
+          <p:cNvPicPr>
+            <a:picLocks noChangeAspect="1"/>
+          </p:cNvPicPr>
+          <p:nvPr/>
+        </p:nvPicPr>
+        <p:blipFill>
+          <a:blip r:embed="rId3"/>
+          <a:stretch>
+            <a:fillRect/>
+          </a:stretch>
+        </p:blipFill>
+        <p:spPr>
+          <a:xfrm>
+            <a:off x="5989320" y="1307592"/>
+            <a:ext cx="219456" cy="219456"/>
+          </a:xfrm>
+          <a:prstGeom prst="rect">
+            <a:avLst/>
+          </a:prstGeom>
+        </p:spPr>
+      </p:pic>
+      <p:sp>
+        <p:nvSpPr>
+          <p:cNvPr id="12" name="Text 6"/>
+          <p:cNvSpPr txBox="1"/>
+          <p:nvPr/>
+        </p:nvSpPr>
+        <p:spPr>
+          <a:xfrm>
+            <a:off x="6309360" y="1188720"/>
+            <a:ext cx="2286000" cy="457200"/>
+          </a:xfrm>
+          <a:prstGeom prst="rect">
+            <a:avLst/>
+          </a:prstGeom>
+          <a:noFill/>
+          <a:ln/>
+        </p:spPr>
+        <p:txBody>
+          <a:bodyPr wrap="square" lIns="0" tIns="0" rIns="0" bIns="0" rtlCol="0" anchor="ctr"/>
+          <a:lstStyle/>
+          <a:p>
+            <a:pPr indent="0" marL="0">
+              <a:buNone/>
+            </a:pPr>
+            <a:r>
+              <a:rPr lang="en-US" sz="1300" b="1" dirty="0">
+                <a:solidFill>
+                  <a:srgbClr val="FFFFFF"/>
+                </a:solidFill>
+                <a:latin typeface="SF Pro Display" pitchFamily="34" charset="0"/>
+                <a:ea typeface="SF Pro Display" pitchFamily="34" charset="-122"/>
+                <a:cs typeface="SF Pro Display" pitchFamily="34" charset="-120"/>
+              </a:rPr>
+              <a:t>The Story</a:t>
+            </a:r>
+            <a:endParaRPr lang="en-US" sz="1300" dirty="0"/>
+          </a:p>
+        </p:txBody>
+      </p:sp>
+      <p:sp>
+        <p:nvSpPr>
+          <p:cNvPr id="13" name="Shape 7"/>
+          <p:cNvSpPr/>
+          <p:nvPr/>
+        </p:nvSpPr>
+        <p:spPr>
+          <a:xfrm>
+            <a:off x="5806440" y="1737360"/>
+            <a:ext cx="2926080" cy="2971800"/>
+          </a:xfrm>
+          <a:prstGeom prst="roundRect">
+            <a:avLst>
+              <a:gd name="adj" fmla="val 2500"/>
             </a:avLst>
           </a:prstGeom>
           <a:solidFill>
@@ -25425,14 +23213,14 @@
       </p:sp>
       <p:sp>
         <p:nvSpPr>
-          <p:cNvPr id="8" name="Text 4"/>
+          <p:cNvPr id="14" name="storyText"/>
           <p:cNvSpPr txBox="1"/>
           <p:nvPr/>
         </p:nvSpPr>
         <p:spPr>
           <a:xfrm>
-            <a:off x="640080" y="3703320"/>
-            <a:ext cx="7955280" cy="594360"/>
+            <a:off x="5943600" y="1847088"/>
+            <a:ext cx="2651760" cy="2788920"/>
           </a:xfrm>
           <a:prstGeom prst="rect">
             <a:avLst/>
@@ -25441,14 +23229,17 @@
           <a:ln/>
         </p:spPr>
         <p:txBody>
-          <a:bodyPr wrap="square" lIns="0" tIns="0" rIns="0" bIns="0" rtlCol="0" anchor="ctr"/>
+          <a:bodyPr wrap="square" lIns="0" tIns="0" rIns="0" bIns="0" rtlCol="0" anchor="t"/>
           <a:lstStyle/>
           <a:p>
             <a:pPr indent="0" marL="0">
+              <a:spcAft>
+                <a:spcPts val="500"/>
+              </a:spcAft>
               <a:buNone/>
             </a:pPr>
             <a:r>
-              <a:rPr lang="en-US" sz="1050" b="1" dirty="0">
+              <a:rPr lang="en-US" sz="900" b="1" dirty="0">
                 <a:solidFill>
                   <a:srgbClr val="0B7A6F"/>
                 </a:solidFill>
@@ -25456,13 +23247,16 @@
                 <a:ea typeface="SF Pro Text" pitchFamily="34" charset="-122"/>
                 <a:cs typeface="SF Pro Text" pitchFamily="34" charset="-120"/>
               </a:rPr>
-              <a:t>The story:  </a:t>
+              <a:t>Sept 7, 2026: </a:t>
             </a:r>
             <a:pPr indent="0" marL="0">
+              <a:spcAft>
+                <a:spcPts val="500"/>
+              </a:spcAft>
               <a:buNone/>
             </a:pPr>
             <a:r>
-              <a:rPr lang="en-US" sz="1050" dirty="0">
+              <a:rPr lang="en-US" sz="900" dirty="0">
                 <a:solidFill>
                   <a:srgbClr val="1D1D1F"/>
                 </a:solidFill>
@@ -25470,9 +23264,157 @@
                 <a:ea typeface="SF Pro Text" pitchFamily="34" charset="-122"/>
                 <a:cs typeface="SF Pro Text" pitchFamily="34" charset="-120"/>
               </a:rPr>
-              <a:t>booked for Sep 21, claimed Sep 14, rescheduled twice by the cleaner, then invoiced on Sep 24.</a:t>
-            </a:r>
-            <a:endParaRPr lang="en-US" sz="1050" dirty="0"/>
+              <a:t>the system booked a cleaning for C Anjuli Kintanar for Sept 21, 10 AM CT, through the recurring cleaning plan.</a:t>
+            </a:r>
+            <a:endParaRPr lang="en-US" sz="900" dirty="0"/>
+          </a:p>
+          <a:p>
+            <a:pPr indent="0" marL="0">
+              <a:spcAft>
+                <a:spcPts val="500"/>
+              </a:spcAft>
+              <a:buNone/>
+            </a:pPr>
+            <a:r>
+              <a:rPr lang="en-US" sz="900" b="1" dirty="0">
+                <a:solidFill>
+                  <a:srgbClr val="0B7A6F"/>
+                </a:solidFill>
+                <a:latin typeface="SF Pro Text" pitchFamily="34" charset="0"/>
+                <a:ea typeface="SF Pro Text" pitchFamily="34" charset="-122"/>
+                <a:cs typeface="SF Pro Text" pitchFamily="34" charset="-120"/>
+              </a:rPr>
+              <a:t>Sept 14: </a:t>
+            </a:r>
+            <a:pPr indent="0" marL="0">
+              <a:spcAft>
+                <a:spcPts val="500"/>
+              </a:spcAft>
+              <a:buNone/>
+            </a:pPr>
+            <a:r>
+              <a:rPr lang="en-US" sz="900" dirty="0">
+                <a:solidFill>
+                  <a:srgbClr val="1D1D1F"/>
+                </a:solidFill>
+                <a:latin typeface="SF Pro Text" pitchFamily="34" charset="0"/>
+                <a:ea typeface="SF Pro Text" pitchFamily="34" charset="-122"/>
+                <a:cs typeface="SF Pro Text" pitchFamily="34" charset="-120"/>
+              </a:rPr>
+              <a:t>CP Truffle Wuffle claimed the job as scheduled.</a:t>
+            </a:r>
+            <a:endParaRPr lang="en-US" sz="900" dirty="0"/>
+          </a:p>
+          <a:p>
+            <a:pPr indent="0" marL="0">
+              <a:spcAft>
+                <a:spcPts val="500"/>
+              </a:spcAft>
+              <a:buNone/>
+            </a:pPr>
+            <a:r>
+              <a:rPr lang="en-US" sz="900" b="1" dirty="0">
+                <a:solidFill>
+                  <a:srgbClr val="0B7A6F"/>
+                </a:solidFill>
+                <a:latin typeface="SF Pro Text" pitchFamily="34" charset="0"/>
+                <a:ea typeface="SF Pro Text" pitchFamily="34" charset="-122"/>
+                <a:cs typeface="SF Pro Text" pitchFamily="34" charset="-120"/>
+              </a:rPr>
+              <a:t>Sept 21, 9:19 AM CT: </a:t>
+            </a:r>
+            <a:pPr indent="0" marL="0">
+              <a:spcAft>
+                <a:spcPts val="500"/>
+              </a:spcAft>
+              <a:buNone/>
+            </a:pPr>
+            <a:r>
+              <a:rPr lang="en-US" sz="900" dirty="0">
+                <a:solidFill>
+                  <a:srgbClr val="1D1D1F"/>
+                </a:solidFill>
+                <a:latin typeface="SF Pro Text" pitchFamily="34" charset="0"/>
+                <a:ea typeface="SF Pro Text" pitchFamily="34" charset="-122"/>
+                <a:cs typeface="SF Pro Text" pitchFamily="34" charset="-120"/>
+              </a:rPr>
+              <a:t>CP Truffle Wuffle rescheduled from Sept 21, 10 AM CT to Sept 22, 11 AM.</a:t>
+            </a:r>
+            <a:endParaRPr lang="en-US" sz="900" dirty="0"/>
+          </a:p>
+          <a:p>
+            <a:pPr indent="0" marL="0">
+              <a:spcAft>
+                <a:spcPts val="500"/>
+              </a:spcAft>
+              <a:buNone/>
+            </a:pPr>
+            <a:r>
+              <a:rPr lang="en-US" sz="900" b="1" dirty="0">
+                <a:solidFill>
+                  <a:srgbClr val="0B7A6F"/>
+                </a:solidFill>
+                <a:latin typeface="SF Pro Text" pitchFamily="34" charset="0"/>
+                <a:ea typeface="SF Pro Text" pitchFamily="34" charset="-122"/>
+                <a:cs typeface="SF Pro Text" pitchFamily="34" charset="-120"/>
+              </a:rPr>
+              <a:t>Sept 21, 9:50 AM CT: </a:t>
+            </a:r>
+            <a:pPr indent="0" marL="0">
+              <a:spcAft>
+                <a:spcPts val="500"/>
+              </a:spcAft>
+              <a:buNone/>
+            </a:pPr>
+            <a:r>
+              <a:rPr lang="en-US" sz="900" dirty="0">
+                <a:solidFill>
+                  <a:srgbClr val="1D1D1F"/>
+                </a:solidFill>
+                <a:latin typeface="SF Pro Text" pitchFamily="34" charset="0"/>
+                <a:ea typeface="SF Pro Text" pitchFamily="34" charset="-122"/>
+                <a:cs typeface="SF Pro Text" pitchFamily="34" charset="-120"/>
+              </a:rPr>
+              <a:t>CP Truffle Wuffle rescheduled again, from Sept 22, 11 AM to Sept 24, 12:30 PM CT.</a:t>
+            </a:r>
+            <a:endParaRPr lang="en-US" sz="900" dirty="0"/>
+          </a:p>
+          <a:p>
+            <a:pPr indent="0" marL="0">
+              <a:spcAft>
+                <a:spcPts val="500"/>
+              </a:spcAft>
+              <a:buNone/>
+            </a:pPr>
+            <a:r>
+              <a:rPr lang="en-US" sz="900" b="1" dirty="0">
+                <a:solidFill>
+                  <a:srgbClr val="0B7A6F"/>
+                </a:solidFill>
+                <a:latin typeface="SF Pro Text" pitchFamily="34" charset="0"/>
+                <a:ea typeface="SF Pro Text" pitchFamily="34" charset="-122"/>
+                <a:cs typeface="SF Pro Text" pitchFamily="34" charset="-120"/>
+              </a:rPr>
+              <a:t>Sept 24, 4:09 PM CT: </a:t>
+            </a:r>
+            <a:pPr indent="0" marL="0">
+              <a:spcAft>
+                <a:spcPts val="500"/>
+              </a:spcAft>
+              <a:buNone/>
+            </a:pPr>
+            <a:r>
+              <a:rPr lang="en-US" sz="900" dirty="0">
+                <a:solidFill>
+                  <a:srgbClr val="1D1D1F"/>
+                </a:solidFill>
+                <a:latin typeface="SF Pro Text" pitchFamily="34" charset="0"/>
+                <a:ea typeface="SF Pro Text" pitchFamily="34" charset="-122"/>
+                <a:cs typeface="SF Pro Text" pitchFamily="34" charset="-120"/>
+              </a:rPr>
+              <a:t>CP Truffle Wuffle invoiced the appointment and the system logged it in snapshot.</a:t>
+            </a:r>
+            <a:endParaRPr lang="en-US" sz="900" dirty="0"/>
           </a:p>
         </p:txBody>
       </p:sp>
@@ -25529,6 +23471,344 @@
   <p:clrMapOvr>
     <a:masterClrMapping/>
   </p:clrMapOvr>
+  <p:timing>
+    <p:tnLst>
+      <p:par>
+        <p:cTn id="1" dur="indefinite" restart="never" nodeType="tmRoot">
+          <p:childTnLst>
+            <p:seq concurrent="1" nextAc="seek">
+              <p:cTn id="2" dur="indefinite" nodeType="mainSeq">
+                <p:childTnLst>
+                  <p:par>
+                    <p:cTn id="3" fill="hold">
+                      <p:stCondLst>
+                        <p:cond delay="indefinite"/>
+                      </p:stCondLst>
+                      <p:childTnLst>
+                        <p:par>
+                          <p:cTn id="4" fill="hold">
+                            <p:stCondLst>
+                              <p:cond delay="0"/>
+                            </p:stCondLst>
+                            <p:childTnLst>
+                              <p:par>
+                                <p:cTn id="5" presetID="10" presetClass="entr" presetSubtype="0" fill="hold" grpId="0" nodeType="clickEffect">
+                                  <p:stCondLst>
+                                    <p:cond delay="0"/>
+                                  </p:stCondLst>
+                                  <p:childTnLst>
+                                    <p:set>
+                                      <p:cBhvr>
+                                        <p:cTn id="6" dur="1" fill="hold">
+                                          <p:stCondLst>
+                                            <p:cond delay="0"/>
+                                          </p:stCondLst>
+                                        </p:cTn>
+                                        <p:tgtEl>
+                                          <p:spTgt spid="14">
+                                            <p:txEl>
+                                              <p:pRg st="0" end="0"/>
+                                            </p:txEl>
+                                          </p:spTgt>
+                                        </p:tgtEl>
+                                        <p:attrNameLst>
+                                          <p:attrName>style.visibility</p:attrName>
+                                        </p:attrNameLst>
+                                      </p:cBhvr>
+                                      <p:to>
+                                        <p:strVal val="visible"/>
+                                      </p:to>
+                                    </p:set>
+                                    <p:animEffect transition="in" filter="fade">
+                                      <p:cBhvr>
+                                        <p:cTn id="7" dur="600"/>
+                                        <p:tgtEl>
+                                          <p:spTgt spid="14">
+                                            <p:txEl>
+                                              <p:pRg st="0" end="0"/>
+                                            </p:txEl>
+                                          </p:spTgt>
+                                        </p:tgtEl>
+                                      </p:cBhvr>
+                                    </p:animEffect>
+                                  </p:childTnLst>
+                                </p:cTn>
+                              </p:par>
+                            </p:childTnLst>
+                          </p:cTn>
+                        </p:par>
+                      </p:childTnLst>
+                    </p:cTn>
+                  </p:par>
+                  <p:par>
+                    <p:cTn id="8" fill="hold">
+                      <p:stCondLst>
+                        <p:cond delay="indefinite"/>
+                      </p:stCondLst>
+                      <p:childTnLst>
+                        <p:par>
+                          <p:cTn id="9" fill="hold">
+                            <p:stCondLst>
+                              <p:cond delay="0"/>
+                            </p:stCondLst>
+                            <p:childTnLst>
+                              <p:par>
+                                <p:cTn id="10" presetID="10" presetClass="entr" presetSubtype="0" fill="hold" grpId="0" nodeType="clickEffect">
+                                  <p:stCondLst>
+                                    <p:cond delay="0"/>
+                                  </p:stCondLst>
+                                  <p:childTnLst>
+                                    <p:set>
+                                      <p:cBhvr>
+                                        <p:cTn id="11" dur="1" fill="hold">
+                                          <p:stCondLst>
+                                            <p:cond delay="0"/>
+                                          </p:stCondLst>
+                                        </p:cTn>
+                                        <p:tgtEl>
+                                          <p:spTgt spid="14">
+                                            <p:txEl>
+                                              <p:pRg st="1" end="1"/>
+                                            </p:txEl>
+                                          </p:spTgt>
+                                        </p:tgtEl>
+                                        <p:attrNameLst>
+                                          <p:attrName>style.visibility</p:attrName>
+                                        </p:attrNameLst>
+                                      </p:cBhvr>
+                                      <p:to>
+                                        <p:strVal val="visible"/>
+                                      </p:to>
+                                    </p:set>
+                                    <p:animEffect transition="in" filter="fade">
+                                      <p:cBhvr>
+                                        <p:cTn id="12" dur="600"/>
+                                        <p:tgtEl>
+                                          <p:spTgt spid="14">
+                                            <p:txEl>
+                                              <p:pRg st="1" end="1"/>
+                                            </p:txEl>
+                                          </p:spTgt>
+                                        </p:tgtEl>
+                                      </p:cBhvr>
+                                    </p:animEffect>
+                                  </p:childTnLst>
+                                </p:cTn>
+                              </p:par>
+                            </p:childTnLst>
+                          </p:cTn>
+                        </p:par>
+                      </p:childTnLst>
+                    </p:cTn>
+                  </p:par>
+                  <p:par>
+                    <p:cTn id="13" fill="hold">
+                      <p:stCondLst>
+                        <p:cond delay="indefinite"/>
+                      </p:stCondLst>
+                      <p:childTnLst>
+                        <p:par>
+                          <p:cTn id="14" fill="hold">
+                            <p:stCondLst>
+                              <p:cond delay="0"/>
+                            </p:stCondLst>
+                            <p:childTnLst>
+                              <p:par>
+                                <p:cTn id="15" presetID="10" presetClass="entr" presetSubtype="0" fill="hold" grpId="0" nodeType="clickEffect">
+                                  <p:stCondLst>
+                                    <p:cond delay="0"/>
+                                  </p:stCondLst>
+                                  <p:childTnLst>
+                                    <p:set>
+                                      <p:cBhvr>
+                                        <p:cTn id="16" dur="1" fill="hold">
+                                          <p:stCondLst>
+                                            <p:cond delay="0"/>
+                                          </p:stCondLst>
+                                        </p:cTn>
+                                        <p:tgtEl>
+                                          <p:spTgt spid="14">
+                                            <p:txEl>
+                                              <p:pRg st="2" end="2"/>
+                                            </p:txEl>
+                                          </p:spTgt>
+                                        </p:tgtEl>
+                                        <p:attrNameLst>
+                                          <p:attrName>style.visibility</p:attrName>
+                                        </p:attrNameLst>
+                                      </p:cBhvr>
+                                      <p:to>
+                                        <p:strVal val="visible"/>
+                                      </p:to>
+                                    </p:set>
+                                    <p:animEffect transition="in" filter="fade">
+                                      <p:cBhvr>
+                                        <p:cTn id="17" dur="600"/>
+                                        <p:tgtEl>
+                                          <p:spTgt spid="14">
+                                            <p:txEl>
+                                              <p:pRg st="2" end="2"/>
+                                            </p:txEl>
+                                          </p:spTgt>
+                                        </p:tgtEl>
+                                      </p:cBhvr>
+                                    </p:animEffect>
+                                  </p:childTnLst>
+                                </p:cTn>
+                              </p:par>
+                            </p:childTnLst>
+                          </p:cTn>
+                        </p:par>
+                      </p:childTnLst>
+                    </p:cTn>
+                  </p:par>
+                  <p:par>
+                    <p:cTn id="18" fill="hold">
+                      <p:stCondLst>
+                        <p:cond delay="indefinite"/>
+                      </p:stCondLst>
+                      <p:childTnLst>
+                        <p:par>
+                          <p:cTn id="19" fill="hold">
+                            <p:stCondLst>
+                              <p:cond delay="0"/>
+                            </p:stCondLst>
+                            <p:childTnLst>
+                              <p:par>
+                                <p:cTn id="20" presetID="10" presetClass="entr" presetSubtype="0" fill="hold" grpId="0" nodeType="clickEffect">
+                                  <p:stCondLst>
+                                    <p:cond delay="0"/>
+                                  </p:stCondLst>
+                                  <p:childTnLst>
+                                    <p:set>
+                                      <p:cBhvr>
+                                        <p:cTn id="21" dur="1" fill="hold">
+                                          <p:stCondLst>
+                                            <p:cond delay="0"/>
+                                          </p:stCondLst>
+                                        </p:cTn>
+                                        <p:tgtEl>
+                                          <p:spTgt spid="14">
+                                            <p:txEl>
+                                              <p:pRg st="3" end="3"/>
+                                            </p:txEl>
+                                          </p:spTgt>
+                                        </p:tgtEl>
+                                        <p:attrNameLst>
+                                          <p:attrName>style.visibility</p:attrName>
+                                        </p:attrNameLst>
+                                      </p:cBhvr>
+                                      <p:to>
+                                        <p:strVal val="visible"/>
+                                      </p:to>
+                                    </p:set>
+                                    <p:animEffect transition="in" filter="fade">
+                                      <p:cBhvr>
+                                        <p:cTn id="22" dur="600"/>
+                                        <p:tgtEl>
+                                          <p:spTgt spid="14">
+                                            <p:txEl>
+                                              <p:pRg st="3" end="3"/>
+                                            </p:txEl>
+                                          </p:spTgt>
+                                        </p:tgtEl>
+                                      </p:cBhvr>
+                                    </p:animEffect>
+                                  </p:childTnLst>
+                                </p:cTn>
+                              </p:par>
+                            </p:childTnLst>
+                          </p:cTn>
+                        </p:par>
+                      </p:childTnLst>
+                    </p:cTn>
+                  </p:par>
+                  <p:par>
+                    <p:cTn id="23" fill="hold">
+                      <p:stCondLst>
+                        <p:cond delay="indefinite"/>
+                      </p:stCondLst>
+                      <p:childTnLst>
+                        <p:par>
+                          <p:cTn id="24" fill="hold">
+                            <p:stCondLst>
+                              <p:cond delay="0"/>
+                            </p:stCondLst>
+                            <p:childTnLst>
+                              <p:par>
+                                <p:cTn id="25" presetID="10" presetClass="entr" presetSubtype="0" fill="hold" grpId="0" nodeType="clickEffect">
+                                  <p:stCondLst>
+                                    <p:cond delay="0"/>
+                                  </p:stCondLst>
+                                  <p:childTnLst>
+                                    <p:set>
+                                      <p:cBhvr>
+                                        <p:cTn id="26" dur="1" fill="hold">
+                                          <p:stCondLst>
+                                            <p:cond delay="0"/>
+                                          </p:stCondLst>
+                                        </p:cTn>
+                                        <p:tgtEl>
+                                          <p:spTgt spid="14">
+                                            <p:txEl>
+                                              <p:pRg st="4" end="4"/>
+                                            </p:txEl>
+                                          </p:spTgt>
+                                        </p:tgtEl>
+                                        <p:attrNameLst>
+                                          <p:attrName>style.visibility</p:attrName>
+                                        </p:attrNameLst>
+                                      </p:cBhvr>
+                                      <p:to>
+                                        <p:strVal val="visible"/>
+                                      </p:to>
+                                    </p:set>
+                                    <p:animEffect transition="in" filter="fade">
+                                      <p:cBhvr>
+                                        <p:cTn id="27" dur="600"/>
+                                        <p:tgtEl>
+                                          <p:spTgt spid="14">
+                                            <p:txEl>
+                                              <p:pRg st="4" end="4"/>
+                                            </p:txEl>
+                                          </p:spTgt>
+                                        </p:tgtEl>
+                                      </p:cBhvr>
+                                    </p:animEffect>
+                                  </p:childTnLst>
+                                </p:cTn>
+                              </p:par>
+                            </p:childTnLst>
+                          </p:cTn>
+                        </p:par>
+                      </p:childTnLst>
+                    </p:cTn>
+                  </p:par>
+                </p:childTnLst>
+              </p:cTn>
+              <p:prevCondLst>
+                <p:cond evt="onPrev" delay="0">
+                  <p:tgtEl>
+                    <p:sldTgt/>
+                  </p:tgtEl>
+                </p:cond>
+              </p:prevCondLst>
+              <p:nextCondLst>
+                <p:cond evt="onNext" delay="0">
+                  <p:tgtEl>
+                    <p:sldTgt/>
+                  </p:tgtEl>
+                </p:cond>
+              </p:nextCondLst>
+            </p:seq>
+          </p:childTnLst>
+        </p:cTn>
+      </p:par>
+    </p:tnLst>
+    <p:bldLst>
+      <p:bldP spid="14" grpId="0" build="p"/>
+    </p:bldLst>
+  </p:timing>
 </p:sld>
 </file>
 

</xml_diff>

<commit_message>
Use legacy CRM voucher screenshots on the voucher status slide
Co-Authored-By: Claude Opus 5.5 <noreply@anthropic.com>
Claude-Session: https://claude.ai/code/session_01FEzv8wwqWDgTsXP8Yz6XYn
</commit_message>
<xml_diff>
--- a/platform-mechanics/platform-operating-mechanics.pptx
+++ b/platform-mechanics/platform-operating-mechanics.pptx
@@ -2658,7 +2658,7 @@
           <a:p>
             <a:r>
               <a:rPr lang="en-US" dirty="0"/>
-              <a:t>Unused (issued or redeemed): assigned to the account and will apply to the next invoiced job, shown in an orange box with duration, type, price and the 16-letter code. Applied (used): a green box with a check mark, the job ID and the appointment date and time. Grayed out: canceled/invalidated (removed through a refund, dispute or admin invalidation), converted (turned into credits equal to the purchase price), or expired. The reason usually appears beside the code. Refunded: refunded to the customer's card on file.</a:t>
+              <a:t>Unused (issued or redeemed): assigned to the account and will apply to the next invoiced job, shown in an orange box with duration, type, price and the 16-letter code. Applied (used): a green box with a check mark, the job ID and the appointment date and time. Grayed out: canceled/invalidated (removed through a refund, dispute or admin invalidation), converted (turned into credits equal to the purchase price), or expired. The reason usually appears beside the code. Refunded: refunded to the customer's card on file. Examples on the slide: an unused 3hr DHJ ($19.00) sitting below the card on file; a 3hr DHJ applied to Job 12242911 on 10/31/25 (green tag); a 2hr DHJ ($9.00) grayed out with the reason admin_refund on 5/1/26.</a:t>
             </a:r>
             <a:endParaRPr lang="en-US" dirty="0"/>
           </a:p>
@@ -28502,11 +28502,11 @@
         <p:spPr>
           <a:xfrm>
             <a:off x="411480" y="1325880"/>
-            <a:ext cx="2682240" cy="1691640"/>
+            <a:ext cx="2606040" cy="841248"/>
           </a:xfrm>
           <a:prstGeom prst="roundRect">
             <a:avLst>
-              <a:gd name="adj" fmla="val 4324"/>
+              <a:gd name="adj" fmla="val 8696"/>
             </a:avLst>
           </a:prstGeom>
           <a:solidFill>
@@ -28528,8 +28528,8 @@
         </p:nvSpPr>
         <p:spPr>
           <a:xfrm>
-            <a:off x="576072" y="1490472"/>
-            <a:ext cx="329184" cy="329184"/>
+            <a:off x="548640" y="1554480"/>
+            <a:ext cx="384048" cy="384048"/>
           </a:xfrm>
           <a:prstGeom prst="ellipse">
             <a:avLst/>
@@ -28561,8 +28561,8 @@
         </p:blipFill>
         <p:spPr>
           <a:xfrm>
-            <a:off x="655076" y="1569476"/>
-            <a:ext cx="171176" cy="171176"/>
+            <a:off x="640812" y="1646652"/>
+            <a:ext cx="199705" cy="199705"/>
           </a:xfrm>
           <a:prstGeom prst="rect">
             <a:avLst/>
@@ -28577,8 +28577,8 @@
         </p:nvSpPr>
         <p:spPr>
           <a:xfrm>
-            <a:off x="576072" y="1929384"/>
-            <a:ext cx="2353056" cy="274320"/>
+            <a:off x="1024128" y="1380744"/>
+            <a:ext cx="1920240" cy="731520"/>
           </a:xfrm>
           <a:prstGeom prst="rect">
             <a:avLst/>
@@ -28587,7 +28587,7 @@
           <a:ln/>
         </p:spPr>
         <p:txBody>
-          <a:bodyPr wrap="square" lIns="0" tIns="0" rIns="0" bIns="0" rtlCol="0" anchor="t"/>
+          <a:bodyPr wrap="square" lIns="0" tIns="0" rIns="0" bIns="0" rtlCol="0" anchor="ctr"/>
           <a:lstStyle/>
           <a:p>
             <a:pPr indent="0" marL="0">
@@ -28606,34 +28606,12 @@
             </a:r>
             <a:endParaRPr lang="en-US" sz="1200" dirty="0"/>
           </a:p>
-        </p:txBody>
-      </p:sp>
-      <p:sp>
-        <p:nvSpPr>
-          <p:cNvPr id="10" name="Text 6"/>
-          <p:cNvSpPr txBox="1"/>
-          <p:nvPr/>
-        </p:nvSpPr>
-        <p:spPr>
-          <a:xfrm>
-            <a:off x="576072" y="2221992"/>
-            <a:ext cx="2353056" cy="704088"/>
-          </a:xfrm>
-          <a:prstGeom prst="rect">
-            <a:avLst/>
-          </a:prstGeom>
-          <a:noFill/>
-          <a:ln/>
-        </p:spPr>
-        <p:txBody>
-          <a:bodyPr wrap="square" lIns="0" tIns="0" rIns="0" bIns="0" rtlCol="0" anchor="t"/>
-          <a:lstStyle/>
           <a:p>
             <a:pPr indent="0" marL="0">
               <a:buNone/>
             </a:pPr>
             <a:r>
-              <a:rPr lang="en-US" sz="950" dirty="0">
+              <a:rPr lang="en-US" sz="900" dirty="0">
                 <a:solidFill>
                   <a:srgbClr val="6E6E73"/>
                 </a:solidFill>
@@ -28641,26 +28619,26 @@
                 <a:ea typeface="SF Pro Text" pitchFamily="34" charset="-122"/>
                 <a:cs typeface="SF Pro Text" pitchFamily="34" charset="-120"/>
               </a:rPr>
-              <a:t>Orange box. Applies to the next invoiced job.</a:t>
-            </a:r>
-            <a:endParaRPr lang="en-US" sz="950" dirty="0"/>
-          </a:p>
-        </p:txBody>
-      </p:sp>
-      <p:sp>
-        <p:nvSpPr>
-          <p:cNvPr id="11" name="Shape 7"/>
+              <a:t>Orange tag. Applies to the next invoiced job.</a:t>
+            </a:r>
+            <a:endParaRPr lang="en-US" sz="1200" dirty="0"/>
+          </a:p>
+        </p:txBody>
+      </p:sp>
+      <p:sp>
+        <p:nvSpPr>
+          <p:cNvPr id="10" name="Shape 6"/>
           <p:cNvSpPr/>
           <p:nvPr/>
         </p:nvSpPr>
         <p:spPr>
           <a:xfrm>
-            <a:off x="3230880" y="1325880"/>
-            <a:ext cx="2682240" cy="1691640"/>
+            <a:off x="3127248" y="1325880"/>
+            <a:ext cx="5605272" cy="841248"/>
           </a:xfrm>
           <a:prstGeom prst="roundRect">
             <a:avLst>
-              <a:gd name="adj" fmla="val 4324"/>
+              <a:gd name="adj" fmla="val 8696"/>
             </a:avLst>
           </a:prstGeom>
           <a:solidFill>
@@ -28674,16 +28652,67 @@
           </a:ln>
         </p:spPr>
       </p:sp>
-      <p:sp>
-        <p:nvSpPr>
-          <p:cNvPr id="12" name="Shape 8"/>
+      <p:pic>
+        <p:nvPicPr>
+          <p:cNvPr id="11" name="Image 1" descr="/tmp/claude-0/-workspace-training/3ce5cff6-cccf-5f33-b0ee-0b147a55120e/scratchpad/img3/v_unused.png">    </p:cNvPr>
+          <p:cNvPicPr>
+            <a:picLocks noChangeAspect="1"/>
+          </p:cNvPicPr>
+          <p:nvPr/>
+        </p:nvPicPr>
+        <p:blipFill>
+          <a:blip r:embed="rId2"/>
+          <a:stretch>
+            <a:fillRect/>
+          </a:stretch>
+        </p:blipFill>
+        <p:spPr>
+          <a:xfrm>
+            <a:off x="3236976" y="1399032"/>
+            <a:ext cx="3722234" cy="694944"/>
+          </a:xfrm>
+          <a:prstGeom prst="rect">
+            <a:avLst/>
+          </a:prstGeom>
+        </p:spPr>
+      </p:pic>
+      <p:sp>
+        <p:nvSpPr>
+          <p:cNvPr id="12" name="Shape 7"/>
           <p:cNvSpPr/>
           <p:nvPr/>
         </p:nvSpPr>
         <p:spPr>
           <a:xfrm>
-            <a:off x="3395472" y="1490472"/>
-            <a:ext cx="329184" cy="329184"/>
+            <a:off x="411480" y="2258568"/>
+            <a:ext cx="2606040" cy="841248"/>
+          </a:xfrm>
+          <a:prstGeom prst="roundRect">
+            <a:avLst>
+              <a:gd name="adj" fmla="val 8696"/>
+            </a:avLst>
+          </a:prstGeom>
+          <a:solidFill>
+            <a:srgbClr val="FFFFFF"/>
+          </a:solidFill>
+          <a:ln w="9525">
+            <a:solidFill>
+              <a:srgbClr val="DCE1E7"/>
+            </a:solidFill>
+            <a:prstDash val="solid"/>
+          </a:ln>
+        </p:spPr>
+      </p:sp>
+      <p:sp>
+        <p:nvSpPr>
+          <p:cNvPr id="13" name="Shape 8"/>
+          <p:cNvSpPr/>
+          <p:nvPr/>
+        </p:nvSpPr>
+        <p:spPr>
+          <a:xfrm>
+            <a:off x="548640" y="2487168"/>
+            <a:ext cx="384048" cy="384048"/>
           </a:xfrm>
           <a:prstGeom prst="ellipse">
             <a:avLst/>
@@ -28701,22 +28730,22 @@
       </p:sp>
       <p:pic>
         <p:nvPicPr>
-          <p:cNvPr id="13" name="Image 1" descr="preencoded.png">    </p:cNvPr>
+          <p:cNvPr id="14" name="Image 2" descr="preencoded.png">    </p:cNvPr>
           <p:cNvPicPr>
             <a:picLocks noChangeAspect="1"/>
           </p:cNvPicPr>
           <p:nvPr/>
         </p:nvPicPr>
         <p:blipFill>
-          <a:blip r:embed="rId2"/>
+          <a:blip r:embed="rId3"/>
           <a:stretch>
             <a:fillRect/>
           </a:stretch>
         </p:blipFill>
         <p:spPr>
           <a:xfrm>
-            <a:off x="3474476" y="1569476"/>
-            <a:ext cx="171176" cy="171176"/>
+            <a:off x="640812" y="2579340"/>
+            <a:ext cx="199705" cy="199705"/>
           </a:xfrm>
           <a:prstGeom prst="rect">
             <a:avLst/>
@@ -28725,14 +28754,14 @@
       </p:pic>
       <p:sp>
         <p:nvSpPr>
-          <p:cNvPr id="14" name="Text 9"/>
+          <p:cNvPr id="15" name="Text 9"/>
           <p:cNvSpPr txBox="1"/>
           <p:nvPr/>
         </p:nvSpPr>
         <p:spPr>
           <a:xfrm>
-            <a:off x="3395472" y="1929384"/>
-            <a:ext cx="2353056" cy="274320"/>
+            <a:off x="1024128" y="2313432"/>
+            <a:ext cx="1920240" cy="731520"/>
           </a:xfrm>
           <a:prstGeom prst="rect">
             <a:avLst/>
@@ -28741,7 +28770,7 @@
           <a:ln/>
         </p:spPr>
         <p:txBody>
-          <a:bodyPr wrap="square" lIns="0" tIns="0" rIns="0" bIns="0" rtlCol="0" anchor="t"/>
+          <a:bodyPr wrap="square" lIns="0" tIns="0" rIns="0" bIns="0" rtlCol="0" anchor="ctr"/>
           <a:lstStyle/>
           <a:p>
             <a:pPr indent="0" marL="0">
@@ -28760,34 +28789,12 @@
             </a:r>
             <a:endParaRPr lang="en-US" sz="1200" dirty="0"/>
           </a:p>
-        </p:txBody>
-      </p:sp>
-      <p:sp>
-        <p:nvSpPr>
-          <p:cNvPr id="15" name="Text 10"/>
-          <p:cNvSpPr txBox="1"/>
-          <p:nvPr/>
-        </p:nvSpPr>
-        <p:spPr>
-          <a:xfrm>
-            <a:off x="3395472" y="2221992"/>
-            <a:ext cx="2353056" cy="704088"/>
-          </a:xfrm>
-          <a:prstGeom prst="rect">
-            <a:avLst/>
-          </a:prstGeom>
-          <a:noFill/>
-          <a:ln/>
-        </p:spPr>
-        <p:txBody>
-          <a:bodyPr wrap="square" lIns="0" tIns="0" rIns="0" bIns="0" rtlCol="0" anchor="t"/>
-          <a:lstStyle/>
           <a:p>
             <a:pPr indent="0" marL="0">
               <a:buNone/>
             </a:pPr>
             <a:r>
-              <a:rPr lang="en-US" sz="950" dirty="0">
+              <a:rPr lang="en-US" sz="900" dirty="0">
                 <a:solidFill>
                   <a:srgbClr val="6E6E73"/>
                 </a:solidFill>
@@ -28795,26 +28802,26 @@
                 <a:ea typeface="SF Pro Text" pitchFamily="34" charset="-122"/>
                 <a:cs typeface="SF Pro Text" pitchFamily="34" charset="-120"/>
               </a:rPr>
-              <a:t>Green box with a check mark, job ID and date.</a:t>
-            </a:r>
-            <a:endParaRPr lang="en-US" sz="950" dirty="0"/>
-          </a:p>
-        </p:txBody>
-      </p:sp>
-      <p:sp>
-        <p:nvSpPr>
-          <p:cNvPr id="16" name="Shape 11"/>
+              <a:t>Green tag with a check mark, job ID and date.</a:t>
+            </a:r>
+            <a:endParaRPr lang="en-US" sz="1200" dirty="0"/>
+          </a:p>
+        </p:txBody>
+      </p:sp>
+      <p:sp>
+        <p:nvSpPr>
+          <p:cNvPr id="16" name="Shape 10"/>
           <p:cNvSpPr/>
           <p:nvPr/>
         </p:nvSpPr>
         <p:spPr>
           <a:xfrm>
-            <a:off x="6050280" y="1325880"/>
-            <a:ext cx="2682240" cy="1691640"/>
+            <a:off x="3127248" y="2258568"/>
+            <a:ext cx="5605272" cy="841248"/>
           </a:xfrm>
           <a:prstGeom prst="roundRect">
             <a:avLst>
-              <a:gd name="adj" fmla="val 4324"/>
+              <a:gd name="adj" fmla="val 8696"/>
             </a:avLst>
           </a:prstGeom>
           <a:solidFill>
@@ -28828,16 +28835,67 @@
           </a:ln>
         </p:spPr>
       </p:sp>
-      <p:sp>
-        <p:nvSpPr>
-          <p:cNvPr id="17" name="Shape 12"/>
+      <p:pic>
+        <p:nvPicPr>
+          <p:cNvPr id="17" name="Image 3" descr="/tmp/claude-0/-workspace-training/3ce5cff6-cccf-5f33-b0ee-0b147a55120e/scratchpad/img3/v_applied.png">    </p:cNvPr>
+          <p:cNvPicPr>
+            <a:picLocks noChangeAspect="1"/>
+          </p:cNvPicPr>
+          <p:nvPr/>
+        </p:nvPicPr>
+        <p:blipFill>
+          <a:blip r:embed="rId4"/>
+          <a:stretch>
+            <a:fillRect/>
+          </a:stretch>
+        </p:blipFill>
+        <p:spPr>
+          <a:xfrm>
+            <a:off x="3236976" y="2372079"/>
+            <a:ext cx="5394960" cy="614227"/>
+          </a:xfrm>
+          <a:prstGeom prst="rect">
+            <a:avLst/>
+          </a:prstGeom>
+        </p:spPr>
+      </p:pic>
+      <p:sp>
+        <p:nvSpPr>
+          <p:cNvPr id="18" name="Shape 11"/>
           <p:cNvSpPr/>
           <p:nvPr/>
         </p:nvSpPr>
         <p:spPr>
           <a:xfrm>
-            <a:off x="6214872" y="1490472"/>
-            <a:ext cx="329184" cy="329184"/>
+            <a:off x="411480" y="3191256"/>
+            <a:ext cx="2606040" cy="841248"/>
+          </a:xfrm>
+          <a:prstGeom prst="roundRect">
+            <a:avLst>
+              <a:gd name="adj" fmla="val 8696"/>
+            </a:avLst>
+          </a:prstGeom>
+          <a:solidFill>
+            <a:srgbClr val="FFFFFF"/>
+          </a:solidFill>
+          <a:ln w="9525">
+            <a:solidFill>
+              <a:srgbClr val="DCE1E7"/>
+            </a:solidFill>
+            <a:prstDash val="solid"/>
+          </a:ln>
+        </p:spPr>
+      </p:sp>
+      <p:sp>
+        <p:nvSpPr>
+          <p:cNvPr id="19" name="Shape 12"/>
+          <p:cNvSpPr/>
+          <p:nvPr/>
+        </p:nvSpPr>
+        <p:spPr>
+          <a:xfrm>
+            <a:off x="548640" y="3419856"/>
+            <a:ext cx="384048" cy="384048"/>
           </a:xfrm>
           <a:prstGeom prst="ellipse">
             <a:avLst/>
@@ -28855,22 +28913,22 @@
       </p:sp>
       <p:pic>
         <p:nvPicPr>
-          <p:cNvPr id="18" name="Image 2" descr="preencoded.png">    </p:cNvPr>
+          <p:cNvPr id="20" name="Image 4" descr="preencoded.png">    </p:cNvPr>
           <p:cNvPicPr>
             <a:picLocks noChangeAspect="1"/>
           </p:cNvPicPr>
           <p:nvPr/>
         </p:nvPicPr>
         <p:blipFill>
-          <a:blip r:embed="rId3"/>
+          <a:blip r:embed="rId5"/>
           <a:stretch>
             <a:fillRect/>
           </a:stretch>
         </p:blipFill>
         <p:spPr>
           <a:xfrm>
-            <a:off x="6293876" y="1569476"/>
-            <a:ext cx="171176" cy="171176"/>
+            <a:off x="640812" y="3512028"/>
+            <a:ext cx="199705" cy="199705"/>
           </a:xfrm>
           <a:prstGeom prst="rect">
             <a:avLst/>
@@ -28879,14 +28937,14 @@
       </p:pic>
       <p:sp>
         <p:nvSpPr>
-          <p:cNvPr id="19" name="Text 13"/>
+          <p:cNvPr id="21" name="Text 13"/>
           <p:cNvSpPr txBox="1"/>
           <p:nvPr/>
         </p:nvSpPr>
         <p:spPr>
           <a:xfrm>
-            <a:off x="6214872" y="1929384"/>
-            <a:ext cx="2353056" cy="274320"/>
+            <a:off x="1024128" y="3246120"/>
+            <a:ext cx="1920240" cy="731520"/>
           </a:xfrm>
           <a:prstGeom prst="rect">
             <a:avLst/>
@@ -28895,7 +28953,7 @@
           <a:ln/>
         </p:spPr>
         <p:txBody>
-          <a:bodyPr wrap="square" lIns="0" tIns="0" rIns="0" bIns="0" rtlCol="0" anchor="t"/>
+          <a:bodyPr wrap="square" lIns="0" tIns="0" rIns="0" bIns="0" rtlCol="0" anchor="ctr"/>
           <a:lstStyle/>
           <a:p>
             <a:pPr indent="0" marL="0">
@@ -28914,34 +28972,12 @@
             </a:r>
             <a:endParaRPr lang="en-US" sz="1200" dirty="0"/>
           </a:p>
-        </p:txBody>
-      </p:sp>
-      <p:sp>
-        <p:nvSpPr>
-          <p:cNvPr id="20" name="Text 14"/>
-          <p:cNvSpPr txBox="1"/>
-          <p:nvPr/>
-        </p:nvSpPr>
-        <p:spPr>
-          <a:xfrm>
-            <a:off x="6214872" y="2221992"/>
-            <a:ext cx="2353056" cy="704088"/>
-          </a:xfrm>
-          <a:prstGeom prst="rect">
-            <a:avLst/>
-          </a:prstGeom>
-          <a:noFill/>
-          <a:ln/>
-        </p:spPr>
-        <p:txBody>
-          <a:bodyPr wrap="square" lIns="0" tIns="0" rIns="0" bIns="0" rtlCol="0" anchor="t"/>
-          <a:lstStyle/>
           <a:p>
             <a:pPr indent="0" marL="0">
               <a:buNone/>
             </a:pPr>
             <a:r>
-              <a:rPr lang="en-US" sz="950" dirty="0">
+              <a:rPr lang="en-US" sz="900" dirty="0">
                 <a:solidFill>
                   <a:srgbClr val="6E6E73"/>
                 </a:solidFill>
@@ -28949,21 +28985,72 @@
                 <a:ea typeface="SF Pro Text" pitchFamily="34" charset="-122"/>
                 <a:cs typeface="SF Pro Text" pitchFamily="34" charset="-120"/>
               </a:rPr>
-              <a:t>Canceled, invalidated, converted or expired. Reason shown by the code.</a:t>
-            </a:r>
-            <a:endParaRPr lang="en-US" sz="950" dirty="0"/>
-          </a:p>
-        </p:txBody>
-      </p:sp>
-      <p:sp>
-        <p:nvSpPr>
-          <p:cNvPr id="21" name="Shape 15"/>
+              <a:t>Canceled, invalidated, converted or expired. Reason next to the code.</a:t>
+            </a:r>
+            <a:endParaRPr lang="en-US" sz="1200" dirty="0"/>
+          </a:p>
+        </p:txBody>
+      </p:sp>
+      <p:sp>
+        <p:nvSpPr>
+          <p:cNvPr id="22" name="Shape 14"/>
           <p:cNvSpPr/>
           <p:nvPr/>
         </p:nvSpPr>
         <p:spPr>
           <a:xfrm>
-            <a:off x="411480" y="3200400"/>
+            <a:off x="3127248" y="3191256"/>
+            <a:ext cx="5605272" cy="841248"/>
+          </a:xfrm>
+          <a:prstGeom prst="roundRect">
+            <a:avLst>
+              <a:gd name="adj" fmla="val 8696"/>
+            </a:avLst>
+          </a:prstGeom>
+          <a:solidFill>
+            <a:srgbClr val="FFFFFF"/>
+          </a:solidFill>
+          <a:ln w="9525">
+            <a:solidFill>
+              <a:srgbClr val="DCE1E7"/>
+            </a:solidFill>
+            <a:prstDash val="solid"/>
+          </a:ln>
+        </p:spPr>
+      </p:sp>
+      <p:pic>
+        <p:nvPicPr>
+          <p:cNvPr id="23" name="Image 5" descr="/tmp/claude-0/-workspace-training/3ce5cff6-cccf-5f33-b0ee-0b147a55120e/scratchpad/img3/v_grayed.png">    </p:cNvPr>
+          <p:cNvPicPr>
+            <a:picLocks noChangeAspect="1"/>
+          </p:cNvPicPr>
+          <p:nvPr/>
+        </p:nvPicPr>
+        <p:blipFill>
+          <a:blip r:embed="rId6"/>
+          <a:stretch>
+            <a:fillRect/>
+          </a:stretch>
+        </p:blipFill>
+        <p:spPr>
+          <a:xfrm>
+            <a:off x="3236976" y="3264408"/>
+            <a:ext cx="4552387" cy="694944"/>
+          </a:xfrm>
+          <a:prstGeom prst="rect">
+            <a:avLst/>
+          </a:prstGeom>
+        </p:spPr>
+      </p:pic>
+      <p:sp>
+        <p:nvSpPr>
+          <p:cNvPr id="24" name="Shape 15"/>
+          <p:cNvSpPr/>
+          <p:nvPr/>
+        </p:nvSpPr>
+        <p:spPr>
+          <a:xfrm>
+            <a:off x="411480" y="4206240"/>
             <a:ext cx="8321040" cy="384048"/>
           </a:xfrm>
           <a:prstGeom prst="roundRect">
@@ -28984,21 +29071,21 @@
       </p:sp>
       <p:pic>
         <p:nvPicPr>
-          <p:cNvPr id="22" name="Image 3" descr="preencoded.png">    </p:cNvPr>
+          <p:cNvPr id="25" name="Image 6" descr="preencoded.png">    </p:cNvPr>
           <p:cNvPicPr>
             <a:picLocks noChangeAspect="1"/>
           </p:cNvPicPr>
           <p:nvPr/>
         </p:nvPicPr>
         <p:blipFill>
-          <a:blip r:embed="rId4"/>
+          <a:blip r:embed="rId7"/>
           <a:stretch>
             <a:fillRect/>
           </a:stretch>
         </p:blipFill>
         <p:spPr>
           <a:xfrm>
-            <a:off x="566928" y="3310128"/>
+            <a:off x="566928" y="4315968"/>
             <a:ext cx="164592" cy="164592"/>
           </a:xfrm>
           <a:prstGeom prst="rect">
@@ -29008,13 +29095,13 @@
       </p:pic>
       <p:sp>
         <p:nvSpPr>
-          <p:cNvPr id="23" name="Text 16"/>
+          <p:cNvPr id="26" name="Text 16"/>
           <p:cNvSpPr txBox="1"/>
           <p:nvPr/>
         </p:nvSpPr>
         <p:spPr>
           <a:xfrm>
-            <a:off x="822960" y="3300984"/>
+            <a:off x="822960" y="4306824"/>
             <a:ext cx="7772400" cy="201168"/>
           </a:xfrm>
           <a:prstGeom prst="rect">

</xml_diff>

<commit_message>
Show the Update Max Rate steps on the max CP rate slide
Co-Authored-By: Claude Opus 5.5 <noreply@anthropic.com>
Claude-Session: https://claude.ai/code/session_01FEzv8wwqWDgTsXP8Yz6XYn
</commit_message>
<xml_diff>
--- a/platform-mechanics/platform-operating-mechanics.pptx
+++ b/platform-mechanics/platform-operating-mechanics.pptx
@@ -3626,7 +3626,7 @@
           <a:p>
             <a:r>
               <a:rPr lang="en-US" dirty="0"/>
-              <a:t>An agent can set a maximum hourly rate on a customer's behalf via the Update Max Rate action in the legacy CRM (C CRM &gt; Do). It caps what CPs can claim the customer's jobs at, going forward; CPs above that rate simply can't claim. Trade-off: a lower cap protects the customer's wallet, but shrinks the pool of CPs who can claim, possibly including their current CP if that CP's rate is above the new cap. Setting it without understanding how it interacts with booked jobs, rescheduling and admin-locked jobs is how a well-intentioned cap turns into an unclaimed-job ticket a week later.</a:t>
+              <a:t>An agent can set a maximum hourly rate on a customer's behalf via the Update Max Rate action in the legacy CRM (C CRM &gt; Do). It caps what CPs can claim the customer's jobs at, going forward; CPs above that rate simply can't claim. Steps on the slide: 1) open the customer's legacy C CRM and click Do (next to View); 2) in the Do menu, find the Max Rate row, which shows the current cap, and click Update Max Rate; 3) enter the maximum hourly rate and click Update Max Rate (the form notes it caps current and future jobs). Trade-off: a lower cap protects the customer's wallet, but shrinks the pool of CPs who can claim, possibly including their current CP if that CP's rate is above the new cap. Setting it without understanding how it interacts with booked jobs, rescheduling and admin-locked jobs is how a well-intentioned cap turns into an unclaimed-job ticket a week later.</a:t>
             </a:r>
             <a:endParaRPr lang="en-US" dirty="0"/>
           </a:p>
@@ -41523,12 +41523,115 @@
         </p:nvSpPr>
         <p:spPr>
           <a:xfrm>
-            <a:off x="411480" y="1371600"/>
-            <a:ext cx="4091940" cy="2011680"/>
+            <a:off x="411480" y="1344168"/>
+            <a:ext cx="274320" cy="274320"/>
+          </a:xfrm>
+          <a:prstGeom prst="ellipse">
+            <a:avLst/>
+          </a:prstGeom>
+          <a:solidFill>
+            <a:srgbClr val="E3F4F1"/>
+          </a:solidFill>
+          <a:ln w="12700">
+            <a:solidFill>
+              <a:srgbClr val="E3F4F1"/>
+            </a:solidFill>
+            <a:prstDash val="solid"/>
+          </a:ln>
+        </p:spPr>
+      </p:sp>
+      <p:sp>
+        <p:nvSpPr>
+          <p:cNvPr id="7" name="Text 4"/>
+          <p:cNvSpPr txBox="1"/>
+          <p:nvPr/>
+        </p:nvSpPr>
+        <p:spPr>
+          <a:xfrm>
+            <a:off x="411480" y="1344168"/>
+            <a:ext cx="274320" cy="274320"/>
+          </a:xfrm>
+          <a:prstGeom prst="rect">
+            <a:avLst/>
+          </a:prstGeom>
+          <a:noFill/>
+          <a:ln/>
+        </p:spPr>
+        <p:txBody>
+          <a:bodyPr wrap="square" lIns="0" tIns="0" rIns="0" bIns="0" rtlCol="0" anchor="ctr"/>
+          <a:lstStyle/>
+          <a:p>
+            <a:pPr algn="ctr" indent="0" marL="0">
+              <a:buNone/>
+            </a:pPr>
+            <a:r>
+              <a:rPr lang="en-US" sz="900" b="1" dirty="0">
+                <a:solidFill>
+                  <a:srgbClr val="0B7A6F"/>
+                </a:solidFill>
+                <a:latin typeface="SF Pro Display" pitchFamily="34" charset="0"/>
+                <a:ea typeface="SF Pro Display" pitchFamily="34" charset="-122"/>
+                <a:cs typeface="SF Pro Display" pitchFamily="34" charset="-120"/>
+              </a:rPr>
+              <a:t>1</a:t>
+            </a:r>
+            <a:endParaRPr lang="en-US" sz="900" dirty="0"/>
+          </a:p>
+        </p:txBody>
+      </p:sp>
+      <p:sp>
+        <p:nvSpPr>
+          <p:cNvPr id="8" name="Text 5"/>
+          <p:cNvSpPr txBox="1"/>
+          <p:nvPr/>
+        </p:nvSpPr>
+        <p:spPr>
+          <a:xfrm>
+            <a:off x="822960" y="1280160"/>
+            <a:ext cx="2270760" cy="457200"/>
+          </a:xfrm>
+          <a:prstGeom prst="rect">
+            <a:avLst/>
+          </a:prstGeom>
+          <a:noFill/>
+          <a:ln/>
+        </p:spPr>
+        <p:txBody>
+          <a:bodyPr wrap="square" lIns="0" tIns="0" rIns="0" bIns="0" rtlCol="0" anchor="ctr"/>
+          <a:lstStyle/>
+          <a:p>
+            <a:pPr indent="0" marL="0">
+              <a:buNone/>
+            </a:pPr>
+            <a:r>
+              <a:rPr lang="en-US" sz="1050" b="1" dirty="0">
+                <a:solidFill>
+                  <a:srgbClr val="1D1D1F"/>
+                </a:solidFill>
+                <a:latin typeface="SF Pro Display" pitchFamily="34" charset="0"/>
+                <a:ea typeface="SF Pro Display" pitchFamily="34" charset="-122"/>
+                <a:cs typeface="SF Pro Display" pitchFamily="34" charset="-120"/>
+              </a:rPr>
+              <a:t>Open the customer's legacy C CRM and click Do</a:t>
+            </a:r>
+            <a:endParaRPr lang="en-US" sz="1050" dirty="0"/>
+          </a:p>
+        </p:txBody>
+      </p:sp>
+      <p:sp>
+        <p:nvSpPr>
+          <p:cNvPr id="9" name="Shape 6"/>
+          <p:cNvSpPr/>
+          <p:nvPr/>
+        </p:nvSpPr>
+        <p:spPr>
+          <a:xfrm>
+            <a:off x="411480" y="1810512"/>
+            <a:ext cx="2682240" cy="1600200"/>
           </a:xfrm>
           <a:prstGeom prst="roundRect">
             <a:avLst>
-              <a:gd name="adj" fmla="val 3636"/>
+              <a:gd name="adj" fmla="val 4571"/>
             </a:avLst>
           </a:prstGeom>
           <a:solidFill>
@@ -41542,16 +41645,128 @@
           </a:ln>
         </p:spPr>
       </p:sp>
-      <p:sp>
-        <p:nvSpPr>
-          <p:cNvPr id="7" name="Shape 4"/>
+      <p:pic>
+        <p:nvPicPr>
+          <p:cNvPr id="10" name="Image 0" descr="/tmp/claude-0/-workspace-training/3ce5cff6-cccf-5f33-b0ee-0b147a55120e/scratchpad/img3/maxrate_do_btn.png">    </p:cNvPr>
+          <p:cNvPicPr>
+            <a:picLocks noChangeAspect="1"/>
+          </p:cNvPicPr>
+          <p:nvPr/>
+        </p:nvPicPr>
+        <p:blipFill>
+          <a:blip r:embed="rId1"/>
+          <a:stretch>
+            <a:fillRect/>
+          </a:stretch>
+        </p:blipFill>
+        <p:spPr>
+          <a:xfrm>
+            <a:off x="484632" y="2140756"/>
+            <a:ext cx="2535936" cy="939712"/>
+          </a:xfrm>
+          <a:prstGeom prst="rect">
+            <a:avLst/>
+          </a:prstGeom>
+        </p:spPr>
+      </p:pic>
+      <p:sp>
+        <p:nvSpPr>
+          <p:cNvPr id="11" name="Shape 7"/>
           <p:cNvSpPr/>
           <p:nvPr/>
         </p:nvSpPr>
         <p:spPr>
           <a:xfrm>
-            <a:off x="594360" y="1554480"/>
-            <a:ext cx="384048" cy="384048"/>
+            <a:off x="1771909" y="2269484"/>
+            <a:ext cx="476293" cy="411929"/>
+          </a:xfrm>
+          <a:prstGeom prst="roundRect">
+            <a:avLst>
+              <a:gd name="adj" fmla="val 6659"/>
+            </a:avLst>
+          </a:prstGeom>
+          <a:ln w="25400">
+            <a:solidFill>
+              <a:srgbClr val="0B7A6F"/>
+            </a:solidFill>
+            <a:prstDash val="solid"/>
+          </a:ln>
+        </p:spPr>
+      </p:sp>
+      <p:sp>
+        <p:nvSpPr>
+          <p:cNvPr id="12" name="Shape 8"/>
+          <p:cNvSpPr/>
+          <p:nvPr/>
+        </p:nvSpPr>
+        <p:spPr>
+          <a:xfrm>
+            <a:off x="1671325" y="2168900"/>
+            <a:ext cx="201168" cy="201168"/>
+          </a:xfrm>
+          <a:prstGeom prst="ellipse">
+            <a:avLst/>
+          </a:prstGeom>
+          <a:solidFill>
+            <a:srgbClr val="0B7A6F"/>
+          </a:solidFill>
+          <a:ln w="12700">
+            <a:solidFill>
+              <a:srgbClr val="FFFFFF"/>
+            </a:solidFill>
+            <a:prstDash val="solid"/>
+          </a:ln>
+        </p:spPr>
+      </p:sp>
+      <p:sp>
+        <p:nvSpPr>
+          <p:cNvPr id="13" name="Text 9"/>
+          <p:cNvSpPr txBox="1"/>
+          <p:nvPr/>
+        </p:nvSpPr>
+        <p:spPr>
+          <a:xfrm>
+            <a:off x="1671325" y="2168900"/>
+            <a:ext cx="201168" cy="201168"/>
+          </a:xfrm>
+          <a:prstGeom prst="rect">
+            <a:avLst/>
+          </a:prstGeom>
+          <a:noFill/>
+          <a:ln/>
+        </p:spPr>
+        <p:txBody>
+          <a:bodyPr wrap="square" lIns="0" tIns="0" rIns="0" bIns="0" rtlCol="0" anchor="ctr"/>
+          <a:lstStyle/>
+          <a:p>
+            <a:pPr algn="ctr" indent="0" marL="0">
+              <a:buNone/>
+            </a:pPr>
+            <a:r>
+              <a:rPr lang="en-US" sz="800" b="1" dirty="0">
+                <a:solidFill>
+                  <a:srgbClr val="FFFFFF"/>
+                </a:solidFill>
+                <a:latin typeface="SF Pro Display" pitchFamily="34" charset="0"/>
+                <a:ea typeface="SF Pro Display" pitchFamily="34" charset="-122"/>
+                <a:cs typeface="SF Pro Display" pitchFamily="34" charset="-120"/>
+              </a:rPr>
+              <a:t>1</a:t>
+            </a:r>
+            <a:endParaRPr lang="en-US" sz="800" dirty="0"/>
+          </a:p>
+        </p:txBody>
+      </p:sp>
+      <p:sp>
+        <p:nvSpPr>
+          <p:cNvPr id="14" name="Shape 10"/>
+          <p:cNvSpPr/>
+          <p:nvPr/>
+        </p:nvSpPr>
+        <p:spPr>
+          <a:xfrm>
+            <a:off x="3230880" y="1344168"/>
+            <a:ext cx="274320" cy="274320"/>
           </a:xfrm>
           <a:prstGeom prst="ellipse">
             <a:avLst/>
@@ -41567,40 +41782,16 @@
           </a:ln>
         </p:spPr>
       </p:sp>
-      <p:pic>
-        <p:nvPicPr>
-          <p:cNvPr id="8" name="Image 0" descr="preencoded.png">    </p:cNvPr>
-          <p:cNvPicPr>
-            <a:picLocks noChangeAspect="1"/>
-          </p:cNvPicPr>
-          <p:nvPr/>
-        </p:nvPicPr>
-        <p:blipFill>
-          <a:blip r:embed="rId1"/>
-          <a:stretch>
-            <a:fillRect/>
-          </a:stretch>
-        </p:blipFill>
-        <p:spPr>
-          <a:xfrm>
-            <a:off x="686532" y="1646652"/>
-            <a:ext cx="199705" cy="199705"/>
-          </a:xfrm>
-          <a:prstGeom prst="rect">
-            <a:avLst/>
-          </a:prstGeom>
-        </p:spPr>
-      </p:pic>
-      <p:sp>
-        <p:nvSpPr>
-          <p:cNvPr id="9" name="Text 5"/>
+      <p:sp>
+        <p:nvSpPr>
+          <p:cNvPr id="15" name="Text 11"/>
           <p:cNvSpPr txBox="1"/>
           <p:nvPr/>
         </p:nvSpPr>
         <p:spPr>
           <a:xfrm>
-            <a:off x="1097280" y="1554480"/>
-            <a:ext cx="3223260" cy="384048"/>
+            <a:off x="3230880" y="1344168"/>
+            <a:ext cx="274320" cy="274320"/>
           </a:xfrm>
           <a:prstGeom prst="rect">
             <a:avLst/>
@@ -41612,34 +41803,34 @@
           <a:bodyPr wrap="square" lIns="0" tIns="0" rIns="0" bIns="0" rtlCol="0" anchor="ctr"/>
           <a:lstStyle/>
           <a:p>
-            <a:pPr indent="0" marL="0">
-              <a:buNone/>
-            </a:pPr>
-            <a:r>
-              <a:rPr lang="en-US" sz="1300" b="1" dirty="0">
-                <a:solidFill>
-                  <a:srgbClr val="1D1D1F"/>
+            <a:pPr algn="ctr" indent="0" marL="0">
+              <a:buNone/>
+            </a:pPr>
+            <a:r>
+              <a:rPr lang="en-US" sz="900" b="1" dirty="0">
+                <a:solidFill>
+                  <a:srgbClr val="0B7A6F"/>
                 </a:solidFill>
                 <a:latin typeface="SF Pro Display" pitchFamily="34" charset="0"/>
                 <a:ea typeface="SF Pro Display" pitchFamily="34" charset="-122"/>
                 <a:cs typeface="SF Pro Display" pitchFamily="34" charset="-120"/>
               </a:rPr>
-              <a:t>Protects the customer's wallet</a:t>
-            </a:r>
-            <a:endParaRPr lang="en-US" sz="1300" dirty="0"/>
-          </a:p>
-        </p:txBody>
-      </p:sp>
-      <p:sp>
-        <p:nvSpPr>
-          <p:cNvPr id="10" name="Text 6"/>
+              <a:t>2</a:t>
+            </a:r>
+            <a:endParaRPr lang="en-US" sz="900" dirty="0"/>
+          </a:p>
+        </p:txBody>
+      </p:sp>
+      <p:sp>
+        <p:nvSpPr>
+          <p:cNvPr id="16" name="Text 12"/>
           <p:cNvSpPr txBox="1"/>
           <p:nvPr/>
         </p:nvSpPr>
         <p:spPr>
           <a:xfrm>
-            <a:off x="594360" y="2084832"/>
-            <a:ext cx="3726180" cy="1188720"/>
+            <a:off x="3642360" y="1280160"/>
+            <a:ext cx="2270760" cy="457200"/>
           </a:xfrm>
           <a:prstGeom prst="rect">
             <a:avLst/>
@@ -41648,66 +41839,41 @@
           <a:ln/>
         </p:spPr>
         <p:txBody>
-          <a:bodyPr wrap="square" lIns="0" tIns="0" rIns="0" bIns="0" rtlCol="0" anchor="t"/>
-          <a:lstStyle/>
-          <a:p>
-            <a:pPr marL="127000" indent="-127000">
-              <a:spcAft>
-                <a:spcPts val="500"/>
-              </a:spcAft>
-              <a:buSzPct val="100000"/>
-              <a:buChar char="•"/>
-            </a:pPr>
-            <a:r>
-              <a:rPr lang="en-US" sz="1000" dirty="0">
+          <a:bodyPr wrap="square" lIns="0" tIns="0" rIns="0" bIns="0" rtlCol="0" anchor="ctr"/>
+          <a:lstStyle/>
+          <a:p>
+            <a:pPr indent="0" marL="0">
+              <a:buNone/>
+            </a:pPr>
+            <a:r>
+              <a:rPr lang="en-US" sz="1050" b="1" dirty="0">
                 <a:solidFill>
                   <a:srgbClr val="1D1D1F"/>
                 </a:solidFill>
-                <a:latin typeface="SF Pro Text" pitchFamily="34" charset="0"/>
-                <a:ea typeface="SF Pro Text" pitchFamily="34" charset="-122"/>
-                <a:cs typeface="SF Pro Text" pitchFamily="34" charset="-120"/>
-              </a:rPr>
-              <a:t>Cleaners above the cap can't claim</a:t>
-            </a:r>
-            <a:endParaRPr lang="en-US" sz="1000" dirty="0"/>
-          </a:p>
-          <a:p>
-            <a:pPr marL="127000" indent="-127000">
-              <a:spcAft>
-                <a:spcPts val="500"/>
-              </a:spcAft>
-              <a:buSzPct val="100000"/>
-              <a:buChar char="•"/>
-            </a:pPr>
-            <a:r>
-              <a:rPr lang="en-US" sz="1000" dirty="0">
-                <a:solidFill>
-                  <a:srgbClr val="1D1D1F"/>
-                </a:solidFill>
-                <a:latin typeface="SF Pro Text" pitchFamily="34" charset="0"/>
-                <a:ea typeface="SF Pro Text" pitchFamily="34" charset="-122"/>
-                <a:cs typeface="SF Pro Text" pitchFamily="34" charset="-120"/>
-              </a:rPr>
-              <a:t>New jobs price at or below the cap</a:t>
-            </a:r>
-            <a:endParaRPr lang="en-US" sz="1000" dirty="0"/>
-          </a:p>
-        </p:txBody>
-      </p:sp>
-      <p:sp>
-        <p:nvSpPr>
-          <p:cNvPr id="11" name="Shape 7"/>
+                <a:latin typeface="SF Pro Display" pitchFamily="34" charset="0"/>
+                <a:ea typeface="SF Pro Display" pitchFamily="34" charset="-122"/>
+                <a:cs typeface="SF Pro Display" pitchFamily="34" charset="-120"/>
+              </a:rPr>
+              <a:t>Find Max Rate and click Update Max Rate</a:t>
+            </a:r>
+            <a:endParaRPr lang="en-US" sz="1050" dirty="0"/>
+          </a:p>
+        </p:txBody>
+      </p:sp>
+      <p:sp>
+        <p:nvSpPr>
+          <p:cNvPr id="17" name="Shape 13"/>
           <p:cNvSpPr/>
           <p:nvPr/>
         </p:nvSpPr>
         <p:spPr>
           <a:xfrm>
-            <a:off x="4640580" y="1371600"/>
-            <a:ext cx="4091940" cy="2011680"/>
+            <a:off x="3230880" y="1810512"/>
+            <a:ext cx="2682240" cy="1600200"/>
           </a:xfrm>
           <a:prstGeom prst="roundRect">
             <a:avLst>
-              <a:gd name="adj" fmla="val 3636"/>
+              <a:gd name="adj" fmla="val 4571"/>
             </a:avLst>
           </a:prstGeom>
           <a:solidFill>
@@ -41721,16 +41887,128 @@
           </a:ln>
         </p:spPr>
       </p:sp>
-      <p:sp>
-        <p:nvSpPr>
-          <p:cNvPr id="12" name="Shape 8"/>
+      <p:pic>
+        <p:nvPicPr>
+          <p:cNvPr id="18" name="Image 1" descr="/tmp/claude-0/-workspace-training/3ce5cff6-cccf-5f33-b0ee-0b147a55120e/scratchpad/img3/maxrate_do_menu.png">    </p:cNvPr>
+          <p:cNvPicPr>
+            <a:picLocks noChangeAspect="1"/>
+          </p:cNvPicPr>
+          <p:nvPr/>
+        </p:nvPicPr>
+        <p:blipFill>
+          <a:blip r:embed="rId2"/>
+          <a:stretch>
+            <a:fillRect/>
+          </a:stretch>
+        </p:blipFill>
+        <p:spPr>
+          <a:xfrm>
+            <a:off x="3304032" y="2320442"/>
+            <a:ext cx="2535936" cy="580339"/>
+          </a:xfrm>
+          <a:prstGeom prst="rect">
+            <a:avLst/>
+          </a:prstGeom>
+        </p:spPr>
+      </p:pic>
+      <p:sp>
+        <p:nvSpPr>
+          <p:cNvPr id="19" name="Shape 14"/>
           <p:cNvSpPr/>
           <p:nvPr/>
         </p:nvSpPr>
         <p:spPr>
           <a:xfrm>
-            <a:off x="4823460" y="1554480"/>
-            <a:ext cx="384048" cy="384048"/>
+            <a:off x="3318662" y="2476500"/>
+            <a:ext cx="2482291" cy="141427"/>
+          </a:xfrm>
+          <a:prstGeom prst="roundRect">
+            <a:avLst>
+              <a:gd name="adj" fmla="val 19397"/>
+            </a:avLst>
+          </a:prstGeom>
+          <a:ln w="25400">
+            <a:solidFill>
+              <a:srgbClr val="0B7A6F"/>
+            </a:solidFill>
+            <a:prstDash val="solid"/>
+          </a:ln>
+        </p:spPr>
+      </p:sp>
+      <p:sp>
+        <p:nvSpPr>
+          <p:cNvPr id="20" name="Shape 15"/>
+          <p:cNvSpPr/>
+          <p:nvPr/>
+        </p:nvSpPr>
+        <p:spPr>
+          <a:xfrm>
+            <a:off x="3218078" y="2375916"/>
+            <a:ext cx="201168" cy="201168"/>
+          </a:xfrm>
+          <a:prstGeom prst="ellipse">
+            <a:avLst/>
+          </a:prstGeom>
+          <a:solidFill>
+            <a:srgbClr val="0B7A6F"/>
+          </a:solidFill>
+          <a:ln w="12700">
+            <a:solidFill>
+              <a:srgbClr val="FFFFFF"/>
+            </a:solidFill>
+            <a:prstDash val="solid"/>
+          </a:ln>
+        </p:spPr>
+      </p:sp>
+      <p:sp>
+        <p:nvSpPr>
+          <p:cNvPr id="21" name="Text 16"/>
+          <p:cNvSpPr txBox="1"/>
+          <p:nvPr/>
+        </p:nvSpPr>
+        <p:spPr>
+          <a:xfrm>
+            <a:off x="3218078" y="2375916"/>
+            <a:ext cx="201168" cy="201168"/>
+          </a:xfrm>
+          <a:prstGeom prst="rect">
+            <a:avLst/>
+          </a:prstGeom>
+          <a:noFill/>
+          <a:ln/>
+        </p:spPr>
+        <p:txBody>
+          <a:bodyPr wrap="square" lIns="0" tIns="0" rIns="0" bIns="0" rtlCol="0" anchor="ctr"/>
+          <a:lstStyle/>
+          <a:p>
+            <a:pPr algn="ctr" indent="0" marL="0">
+              <a:buNone/>
+            </a:pPr>
+            <a:r>
+              <a:rPr lang="en-US" sz="800" b="1" dirty="0">
+                <a:solidFill>
+                  <a:srgbClr val="FFFFFF"/>
+                </a:solidFill>
+                <a:latin typeface="SF Pro Display" pitchFamily="34" charset="0"/>
+                <a:ea typeface="SF Pro Display" pitchFamily="34" charset="-122"/>
+                <a:cs typeface="SF Pro Display" pitchFamily="34" charset="-120"/>
+              </a:rPr>
+              <a:t>2</a:t>
+            </a:r>
+            <a:endParaRPr lang="en-US" sz="800" dirty="0"/>
+          </a:p>
+        </p:txBody>
+      </p:sp>
+      <p:sp>
+        <p:nvSpPr>
+          <p:cNvPr id="22" name="Shape 17"/>
+          <p:cNvSpPr/>
+          <p:nvPr/>
+        </p:nvSpPr>
+        <p:spPr>
+          <a:xfrm>
+            <a:off x="6050280" y="1344168"/>
+            <a:ext cx="274320" cy="274320"/>
           </a:xfrm>
           <a:prstGeom prst="ellipse">
             <a:avLst/>
@@ -41746,40 +42024,16 @@
           </a:ln>
         </p:spPr>
       </p:sp>
-      <p:pic>
-        <p:nvPicPr>
-          <p:cNvPr id="13" name="Image 1" descr="preencoded.png">    </p:cNvPr>
-          <p:cNvPicPr>
-            <a:picLocks noChangeAspect="1"/>
-          </p:cNvPicPr>
-          <p:nvPr/>
-        </p:nvPicPr>
-        <p:blipFill>
-          <a:blip r:embed="rId2"/>
-          <a:stretch>
-            <a:fillRect/>
-          </a:stretch>
-        </p:blipFill>
-        <p:spPr>
-          <a:xfrm>
-            <a:off x="4915632" y="1646652"/>
-            <a:ext cx="199705" cy="199705"/>
-          </a:xfrm>
-          <a:prstGeom prst="rect">
-            <a:avLst/>
-          </a:prstGeom>
-        </p:spPr>
-      </p:pic>
-      <p:sp>
-        <p:nvSpPr>
-          <p:cNvPr id="14" name="Text 9"/>
+      <p:sp>
+        <p:nvSpPr>
+          <p:cNvPr id="23" name="Text 18"/>
           <p:cNvSpPr txBox="1"/>
           <p:nvPr/>
         </p:nvSpPr>
         <p:spPr>
           <a:xfrm>
-            <a:off x="5326380" y="1554480"/>
-            <a:ext cx="3223260" cy="384048"/>
+            <a:off x="6050280" y="1344168"/>
+            <a:ext cx="274320" cy="274320"/>
           </a:xfrm>
           <a:prstGeom prst="rect">
             <a:avLst/>
@@ -41791,34 +42045,34 @@
           <a:bodyPr wrap="square" lIns="0" tIns="0" rIns="0" bIns="0" rtlCol="0" anchor="ctr"/>
           <a:lstStyle/>
           <a:p>
-            <a:pPr indent="0" marL="0">
-              <a:buNone/>
-            </a:pPr>
-            <a:r>
-              <a:rPr lang="en-US" sz="1300" b="1" dirty="0">
-                <a:solidFill>
-                  <a:srgbClr val="1D1D1F"/>
+            <a:pPr algn="ctr" indent="0" marL="0">
+              <a:buNone/>
+            </a:pPr>
+            <a:r>
+              <a:rPr lang="en-US" sz="900" b="1" dirty="0">
+                <a:solidFill>
+                  <a:srgbClr val="0B7A6F"/>
                 </a:solidFill>
                 <a:latin typeface="SF Pro Display" pitchFamily="34" charset="0"/>
                 <a:ea typeface="SF Pro Display" pitchFamily="34" charset="-122"/>
                 <a:cs typeface="SF Pro Display" pitchFamily="34" charset="-120"/>
               </a:rPr>
-              <a:t>Shrinks the cleaner pool</a:t>
-            </a:r>
-            <a:endParaRPr lang="en-US" sz="1300" dirty="0"/>
-          </a:p>
-        </p:txBody>
-      </p:sp>
-      <p:sp>
-        <p:nvSpPr>
-          <p:cNvPr id="15" name="Text 10"/>
+              <a:t>3</a:t>
+            </a:r>
+            <a:endParaRPr lang="en-US" sz="900" dirty="0"/>
+          </a:p>
+        </p:txBody>
+      </p:sp>
+      <p:sp>
+        <p:nvSpPr>
+          <p:cNvPr id="24" name="Text 19"/>
           <p:cNvSpPr txBox="1"/>
           <p:nvPr/>
         </p:nvSpPr>
         <p:spPr>
           <a:xfrm>
-            <a:off x="4823460" y="2084832"/>
-            <a:ext cx="3726180" cy="1188720"/>
+            <a:off x="6461760" y="1280160"/>
+            <a:ext cx="2270760" cy="457200"/>
           </a:xfrm>
           <a:prstGeom prst="rect">
             <a:avLst/>
@@ -41827,74 +42081,49 @@
           <a:ln/>
         </p:spPr>
         <p:txBody>
-          <a:bodyPr wrap="square" lIns="0" tIns="0" rIns="0" bIns="0" rtlCol="0" anchor="t"/>
-          <a:lstStyle/>
-          <a:p>
-            <a:pPr marL="127000" indent="-127000">
-              <a:spcAft>
-                <a:spcPts val="500"/>
-              </a:spcAft>
-              <a:buSzPct val="100000"/>
-              <a:buChar char="•"/>
-            </a:pPr>
-            <a:r>
-              <a:rPr lang="en-US" sz="1000" dirty="0">
+          <a:bodyPr wrap="square" lIns="0" tIns="0" rIns="0" bIns="0" rtlCol="0" anchor="ctr"/>
+          <a:lstStyle/>
+          <a:p>
+            <a:pPr indent="0" marL="0">
+              <a:buNone/>
+            </a:pPr>
+            <a:r>
+              <a:rPr lang="en-US" sz="1050" b="1" dirty="0">
                 <a:solidFill>
                   <a:srgbClr val="1D1D1F"/>
                 </a:solidFill>
-                <a:latin typeface="SF Pro Text" pitchFamily="34" charset="0"/>
-                <a:ea typeface="SF Pro Text" pitchFamily="34" charset="-122"/>
-                <a:cs typeface="SF Pro Text" pitchFamily="34" charset="-120"/>
-              </a:rPr>
-              <a:t>Their current cleaner may be above it</a:t>
-            </a:r>
-            <a:endParaRPr lang="en-US" sz="1000" dirty="0"/>
-          </a:p>
-          <a:p>
-            <a:pPr marL="127000" indent="-127000">
-              <a:spcAft>
-                <a:spcPts val="500"/>
-              </a:spcAft>
-              <a:buSzPct val="100000"/>
-              <a:buChar char="•"/>
-            </a:pPr>
-            <a:r>
-              <a:rPr lang="en-US" sz="1000" dirty="0">
-                <a:solidFill>
-                  <a:srgbClr val="1D1D1F"/>
-                </a:solidFill>
-                <a:latin typeface="SF Pro Text" pitchFamily="34" charset="0"/>
-                <a:ea typeface="SF Pro Text" pitchFamily="34" charset="-122"/>
-                <a:cs typeface="SF Pro Text" pitchFamily="34" charset="-120"/>
-              </a:rPr>
-              <a:t>Too low, and jobs can go unclaimed</a:t>
-            </a:r>
-            <a:endParaRPr lang="en-US" sz="1000" dirty="0"/>
-          </a:p>
-        </p:txBody>
-      </p:sp>
-      <p:sp>
-        <p:nvSpPr>
-          <p:cNvPr id="16" name="Shape 11"/>
+                <a:latin typeface="SF Pro Display" pitchFamily="34" charset="0"/>
+                <a:ea typeface="SF Pro Display" pitchFamily="34" charset="-122"/>
+                <a:cs typeface="SF Pro Display" pitchFamily="34" charset="-120"/>
+              </a:rPr>
+              <a:t>Enter the hourly cap and click Update Max Rate</a:t>
+            </a:r>
+            <a:endParaRPr lang="en-US" sz="1050" dirty="0"/>
+          </a:p>
+        </p:txBody>
+      </p:sp>
+      <p:sp>
+        <p:nvSpPr>
+          <p:cNvPr id="25" name="Shape 20"/>
           <p:cNvSpPr/>
           <p:nvPr/>
         </p:nvSpPr>
         <p:spPr>
           <a:xfrm>
-            <a:off x="411480" y="3566160"/>
-            <a:ext cx="8321040" cy="384048"/>
+            <a:off x="6050280" y="1810512"/>
+            <a:ext cx="2682240" cy="1600200"/>
           </a:xfrm>
           <a:prstGeom prst="roundRect">
             <a:avLst>
-              <a:gd name="adj" fmla="val 19048"/>
+              <a:gd name="adj" fmla="val 4571"/>
             </a:avLst>
           </a:prstGeom>
           <a:solidFill>
-            <a:srgbClr val="FFF3D6"/>
+            <a:srgbClr val="FFFFFF"/>
           </a:solidFill>
           <a:ln w="9525">
             <a:solidFill>
-              <a:srgbClr val="FFF3D6"/>
+              <a:srgbClr val="DCE1E7"/>
             </a:solidFill>
             <a:prstDash val="solid"/>
           </a:ln>
@@ -41902,7 +42131,7 @@
       </p:sp>
       <p:pic>
         <p:nvPicPr>
-          <p:cNvPr id="17" name="Image 2" descr="preencoded.png">    </p:cNvPr>
+          <p:cNvPr id="26" name="Image 2" descr="/tmp/claude-0/-workspace-training/3ce5cff6-cccf-5f33-b0ee-0b147a55120e/scratchpad/img3/maxrate_form_crop.png">    </p:cNvPr>
           <p:cNvPicPr>
             <a:picLocks noChangeAspect="1"/>
           </p:cNvPicPr>
@@ -41916,8 +42145,8 @@
         </p:blipFill>
         <p:spPr>
           <a:xfrm>
-            <a:off x="566928" y="3675888"/>
-            <a:ext cx="164592" cy="164592"/>
+            <a:off x="6123432" y="2010591"/>
+            <a:ext cx="2535936" cy="1200041"/>
           </a:xfrm>
           <a:prstGeom prst="rect">
             <a:avLst/>
@@ -41926,14 +42155,90 @@
       </p:pic>
       <p:sp>
         <p:nvSpPr>
-          <p:cNvPr id="18" name="Text 12"/>
+          <p:cNvPr id="27" name="Shape 21"/>
+          <p:cNvSpPr/>
+          <p:nvPr/>
+        </p:nvSpPr>
+        <p:spPr>
+          <a:xfrm>
+            <a:off x="411480" y="3566160"/>
+            <a:ext cx="4091940" cy="777240"/>
+          </a:xfrm>
+          <a:prstGeom prst="roundRect">
+            <a:avLst>
+              <a:gd name="adj" fmla="val 9412"/>
+            </a:avLst>
+          </a:prstGeom>
+          <a:solidFill>
+            <a:srgbClr val="FFFFFF"/>
+          </a:solidFill>
+          <a:ln w="9525">
+            <a:solidFill>
+              <a:srgbClr val="DCE1E7"/>
+            </a:solidFill>
+            <a:prstDash val="solid"/>
+          </a:ln>
+        </p:spPr>
+      </p:sp>
+      <p:sp>
+        <p:nvSpPr>
+          <p:cNvPr id="28" name="Shape 22"/>
+          <p:cNvSpPr/>
+          <p:nvPr/>
+        </p:nvSpPr>
+        <p:spPr>
+          <a:xfrm>
+            <a:off x="576072" y="3758184"/>
+            <a:ext cx="384048" cy="384048"/>
+          </a:xfrm>
+          <a:prstGeom prst="ellipse">
+            <a:avLst/>
+          </a:prstGeom>
+          <a:solidFill>
+            <a:srgbClr val="E3F4F1"/>
+          </a:solidFill>
+          <a:ln w="12700">
+            <a:solidFill>
+              <a:srgbClr val="E3F4F1"/>
+            </a:solidFill>
+            <a:prstDash val="solid"/>
+          </a:ln>
+        </p:spPr>
+      </p:sp>
+      <p:pic>
+        <p:nvPicPr>
+          <p:cNvPr id="29" name="Image 3" descr="preencoded.png">    </p:cNvPr>
+          <p:cNvPicPr>
+            <a:picLocks noChangeAspect="1"/>
+          </p:cNvPicPr>
+          <p:nvPr/>
+        </p:nvPicPr>
+        <p:blipFill>
+          <a:blip r:embed="rId4"/>
+          <a:stretch>
+            <a:fillRect/>
+          </a:stretch>
+        </p:blipFill>
+        <p:spPr>
+          <a:xfrm>
+            <a:off x="668244" y="3850356"/>
+            <a:ext cx="199705" cy="199705"/>
+          </a:xfrm>
+          <a:prstGeom prst="rect">
+            <a:avLst/>
+          </a:prstGeom>
+        </p:spPr>
+      </p:pic>
+      <p:sp>
+        <p:nvSpPr>
+          <p:cNvPr id="30" name="Text 23"/>
           <p:cNvSpPr txBox="1"/>
           <p:nvPr/>
         </p:nvSpPr>
         <p:spPr>
           <a:xfrm>
-            <a:off x="822960" y="3666744"/>
-            <a:ext cx="7772400" cy="201168"/>
+            <a:off x="1097280" y="3611880"/>
+            <a:ext cx="3268980" cy="685800"/>
           </a:xfrm>
           <a:prstGeom prst="rect">
             <a:avLst/>
@@ -41942,38 +42247,173 @@
           <a:ln/>
         </p:spPr>
         <p:txBody>
-          <a:bodyPr wrap="square" lIns="0" tIns="0" rIns="0" bIns="0" rtlCol="0" anchor="t"/>
+          <a:bodyPr wrap="square" lIns="0" tIns="0" rIns="0" bIns="0" rtlCol="0" anchor="ctr"/>
           <a:lstStyle/>
           <a:p>
             <a:pPr indent="0" marL="0">
               <a:buNone/>
             </a:pPr>
             <a:r>
-              <a:rPr lang="en-US" sz="1000" b="1" dirty="0">
-                <a:solidFill>
-                  <a:srgbClr val="9A6410"/>
+              <a:rPr lang="en-US" sz="1150" b="1" dirty="0">
+                <a:solidFill>
+                  <a:srgbClr val="1D1D1F"/>
+                </a:solidFill>
+                <a:latin typeface="SF Pro Display" pitchFamily="34" charset="0"/>
+                <a:ea typeface="SF Pro Display" pitchFamily="34" charset="-122"/>
+                <a:cs typeface="SF Pro Display" pitchFamily="34" charset="-120"/>
+              </a:rPr>
+              <a:t>Protects the customer's wallet</a:t>
+            </a:r>
+            <a:endParaRPr lang="en-US" sz="1150" dirty="0"/>
+          </a:p>
+          <a:p>
+            <a:pPr indent="0" marL="0">
+              <a:buNone/>
+            </a:pPr>
+            <a:r>
+              <a:rPr lang="en-US" sz="950" dirty="0">
+                <a:solidFill>
+                  <a:srgbClr val="6E6E73"/>
                 </a:solidFill>
                 <a:latin typeface="SF Pro Text" pitchFamily="34" charset="0"/>
                 <a:ea typeface="SF Pro Text" pitchFamily="34" charset="-122"/>
                 <a:cs typeface="SF Pro Text" pitchFamily="34" charset="-120"/>
               </a:rPr>
-              <a:t>Not a pure win:  </a:t>
-            </a:r>
+              <a:t>Cleaners above the cap can't claim. New jobs price at or below it.</a:t>
+            </a:r>
+            <a:endParaRPr lang="en-US" sz="1150" dirty="0"/>
+          </a:p>
+        </p:txBody>
+      </p:sp>
+      <p:sp>
+        <p:nvSpPr>
+          <p:cNvPr id="31" name="Shape 24"/>
+          <p:cNvSpPr/>
+          <p:nvPr/>
+        </p:nvSpPr>
+        <p:spPr>
+          <a:xfrm>
+            <a:off x="4640580" y="3566160"/>
+            <a:ext cx="4091940" cy="777240"/>
+          </a:xfrm>
+          <a:prstGeom prst="roundRect">
+            <a:avLst>
+              <a:gd name="adj" fmla="val 9412"/>
+            </a:avLst>
+          </a:prstGeom>
+          <a:solidFill>
+            <a:srgbClr val="FFFFFF"/>
+          </a:solidFill>
+          <a:ln w="9525">
+            <a:solidFill>
+              <a:srgbClr val="DCE1E7"/>
+            </a:solidFill>
+            <a:prstDash val="solid"/>
+          </a:ln>
+        </p:spPr>
+      </p:sp>
+      <p:sp>
+        <p:nvSpPr>
+          <p:cNvPr id="32" name="Shape 25"/>
+          <p:cNvSpPr/>
+          <p:nvPr/>
+        </p:nvSpPr>
+        <p:spPr>
+          <a:xfrm>
+            <a:off x="4805172" y="3758184"/>
+            <a:ext cx="384048" cy="384048"/>
+          </a:xfrm>
+          <a:prstGeom prst="ellipse">
+            <a:avLst/>
+          </a:prstGeom>
+          <a:solidFill>
+            <a:srgbClr val="E3F4F1"/>
+          </a:solidFill>
+          <a:ln w="12700">
+            <a:solidFill>
+              <a:srgbClr val="E3F4F1"/>
+            </a:solidFill>
+            <a:prstDash val="solid"/>
+          </a:ln>
+        </p:spPr>
+      </p:sp>
+      <p:pic>
+        <p:nvPicPr>
+          <p:cNvPr id="33" name="Image 4" descr="preencoded.png">    </p:cNvPr>
+          <p:cNvPicPr>
+            <a:picLocks noChangeAspect="1"/>
+          </p:cNvPicPr>
+          <p:nvPr/>
+        </p:nvPicPr>
+        <p:blipFill>
+          <a:blip r:embed="rId5"/>
+          <a:stretch>
+            <a:fillRect/>
+          </a:stretch>
+        </p:blipFill>
+        <p:spPr>
+          <a:xfrm>
+            <a:off x="4897344" y="3850356"/>
+            <a:ext cx="199705" cy="199705"/>
+          </a:xfrm>
+          <a:prstGeom prst="rect">
+            <a:avLst/>
+          </a:prstGeom>
+        </p:spPr>
+      </p:pic>
+      <p:sp>
+        <p:nvSpPr>
+          <p:cNvPr id="34" name="Text 26"/>
+          <p:cNvSpPr txBox="1"/>
+          <p:nvPr/>
+        </p:nvSpPr>
+        <p:spPr>
+          <a:xfrm>
+            <a:off x="5326380" y="3611880"/>
+            <a:ext cx="3268980" cy="685800"/>
+          </a:xfrm>
+          <a:prstGeom prst="rect">
+            <a:avLst/>
+          </a:prstGeom>
+          <a:noFill/>
+          <a:ln/>
+        </p:spPr>
+        <p:txBody>
+          <a:bodyPr wrap="square" lIns="0" tIns="0" rIns="0" bIns="0" rtlCol="0" anchor="ctr"/>
+          <a:lstStyle/>
+          <a:p>
             <a:pPr indent="0" marL="0">
               <a:buNone/>
             </a:pPr>
             <a:r>
-              <a:rPr lang="en-US" sz="1000" dirty="0">
+              <a:rPr lang="en-US" sz="1150" b="1" dirty="0">
                 <a:solidFill>
                   <a:srgbClr val="1D1D1F"/>
+                </a:solidFill>
+                <a:latin typeface="SF Pro Display" pitchFamily="34" charset="0"/>
+                <a:ea typeface="SF Pro Display" pitchFamily="34" charset="-122"/>
+                <a:cs typeface="SF Pro Display" pitchFamily="34" charset="-120"/>
+              </a:rPr>
+              <a:t>Shrinks the cleaner pool</a:t>
+            </a:r>
+            <a:endParaRPr lang="en-US" sz="1150" dirty="0"/>
+          </a:p>
+          <a:p>
+            <a:pPr indent="0" marL="0">
+              <a:buNone/>
+            </a:pPr>
+            <a:r>
+              <a:rPr lang="en-US" sz="950" dirty="0">
+                <a:solidFill>
+                  <a:srgbClr val="6E6E73"/>
                 </a:solidFill>
                 <a:latin typeface="SF Pro Text" pitchFamily="34" charset="0"/>
                 <a:ea typeface="SF Pro Text" pitchFamily="34" charset="-122"/>
                 <a:cs typeface="SF Pro Text" pitchFamily="34" charset="-120"/>
               </a:rPr>
-              <a:t>set it carefully, or it becomes an unclaimed-job ticket a week later.</a:t>
-            </a:r>
-            <a:endParaRPr lang="en-US" sz="1000" dirty="0"/>
+              <a:t>Their current cleaner may be above it. Too low, and jobs go unclaimed.</a:t>
+            </a:r>
+            <a:endParaRPr lang="en-US" sz="1150" dirty="0"/>
           </a:p>
         </p:txBody>
       </p:sp>

</xml_diff>